<commit_message>
Presentation: restyle title slide to match reference template, redesign data slide
Slide 1 now uses the deep-navy/eyebrow/info-card template from the reference
image (author/mentor/topic/date cards, accent line, source citations).
Slide 4 drops the VIX/TNX cards, keeps only the S&P 500 target ticker, and
adds a context/horizon rolling-window diagram plus a real cropped chart
figure showing history -> forecast on actual data.

Co-Authored-By: Claude Sonnet 5 <noreply@anthropic.com>
</commit_message>
<xml_diff>
--- a/SP500_ZeroShot_Forecasting.pptx
+++ b/SP500_ZeroShot_Forecasting.pptx
@@ -146,7 +146,7 @@
           <p:cNvPr id="2" name="Title 1">
             <a:extLst>
               <a:ext uri="{FF2B5EF4-FFF2-40B4-BE49-F238E27FC236}">
-                <a16:creationId xmlns:a16="http://schemas.microsoft.com/office/drawing/2014/main" id="{B298EDEA-7B1D-D567-211D-848F231C8A68}"/>
+                <a16:creationId xmlns:a16="http://schemas.microsoft.com/office/drawing/2014/main" id="{31A0DCF9-0DF9-8091-6E57-758668482381}"/>
               </a:ext>
             </a:extLst>
           </p:cNvPr>
@@ -183,7 +183,7 @@
           <p:cNvPr id="3" name="Subtitle 2">
             <a:extLst>
               <a:ext uri="{FF2B5EF4-FFF2-40B4-BE49-F238E27FC236}">
-                <a16:creationId xmlns:a16="http://schemas.microsoft.com/office/drawing/2014/main" id="{001D0419-0B16-FEBC-9416-BAEC03B583F8}"/>
+                <a16:creationId xmlns:a16="http://schemas.microsoft.com/office/drawing/2014/main" id="{1E063C3D-C80D-41E5-613B-2DEAAD99C801}"/>
               </a:ext>
             </a:extLst>
           </p:cNvPr>
@@ -253,7 +253,7 @@
           <p:cNvPr id="4" name="Date Placeholder 3">
             <a:extLst>
               <a:ext uri="{FF2B5EF4-FFF2-40B4-BE49-F238E27FC236}">
-                <a16:creationId xmlns:a16="http://schemas.microsoft.com/office/drawing/2014/main" id="{D69B7FB4-30D6-AAC7-66BC-709485112F90}"/>
+                <a16:creationId xmlns:a16="http://schemas.microsoft.com/office/drawing/2014/main" id="{E4BBE6D9-D83E-CF02-E90C-B0173DF76C38}"/>
               </a:ext>
             </a:extLst>
           </p:cNvPr>
@@ -269,7 +269,7 @@
           <a:bodyPr/>
           <a:lstStyle/>
           <a:p>
-            <a:fld id="{2FADDDB3-BC58-4304-9EBF-FF12BD3CC5C5}" type="datetimeFigureOut">
+            <a:fld id="{D451E412-291F-4FB0-8C2B-B790577930C0}" type="datetimeFigureOut">
               <a:rPr lang="en-US" smtClean="0"/>
               <a:t>8/12/2026</a:t>
             </a:fld>
@@ -282,7 +282,7 @@
           <p:cNvPr id="5" name="Footer Placeholder 4">
             <a:extLst>
               <a:ext uri="{FF2B5EF4-FFF2-40B4-BE49-F238E27FC236}">
-                <a16:creationId xmlns:a16="http://schemas.microsoft.com/office/drawing/2014/main" id="{AF90D419-DFC6-A092-2BFA-1936D0A07BCD}"/>
+                <a16:creationId xmlns:a16="http://schemas.microsoft.com/office/drawing/2014/main" id="{F01B03B7-F1D2-B62D-8AE7-B41868905166}"/>
               </a:ext>
             </a:extLst>
           </p:cNvPr>
@@ -307,7 +307,7 @@
           <p:cNvPr id="6" name="Slide Number Placeholder 5">
             <a:extLst>
               <a:ext uri="{FF2B5EF4-FFF2-40B4-BE49-F238E27FC236}">
-                <a16:creationId xmlns:a16="http://schemas.microsoft.com/office/drawing/2014/main" id="{9D4D463B-EB0C-3F58-BA5A-0A059330B3C3}"/>
+                <a16:creationId xmlns:a16="http://schemas.microsoft.com/office/drawing/2014/main" id="{BBB968EE-3677-1058-817A-472B77F604BE}"/>
               </a:ext>
             </a:extLst>
           </p:cNvPr>
@@ -323,7 +323,7 @@
           <a:bodyPr/>
           <a:lstStyle/>
           <a:p>
-            <a:fld id="{3D30C0DE-0749-4A80-8A4F-60FDA69401DD}" type="slidenum">
+            <a:fld id="{7DA03027-0733-407A-926A-230F7BC0EE61}" type="slidenum">
               <a:rPr lang="en-US" smtClean="0"/>
               <a:t>‹#›</a:t>
             </a:fld>
@@ -334,7 +334,7 @@
     </p:spTree>
     <p:extLst>
       <p:ext uri="{BB962C8B-B14F-4D97-AF65-F5344CB8AC3E}">
-        <p14:creationId xmlns:p14="http://schemas.microsoft.com/office/powerpoint/2010/main" val="1085053722"/>
+        <p14:creationId xmlns:p14="http://schemas.microsoft.com/office/powerpoint/2010/main" val="275179646"/>
       </p:ext>
     </p:extLst>
   </p:cSld>
@@ -366,7 +366,7 @@
           <p:cNvPr id="2" name="Title 1">
             <a:extLst>
               <a:ext uri="{FF2B5EF4-FFF2-40B4-BE49-F238E27FC236}">
-                <a16:creationId xmlns:a16="http://schemas.microsoft.com/office/drawing/2014/main" id="{9C2545AF-1BED-4A62-6B3E-6B6E5B3C5063}"/>
+                <a16:creationId xmlns:a16="http://schemas.microsoft.com/office/drawing/2014/main" id="{5F6C94BE-95E7-671F-FC8E-672DB72B1611}"/>
               </a:ext>
             </a:extLst>
           </p:cNvPr>
@@ -394,7 +394,7 @@
           <p:cNvPr id="3" name="Vertical Text Placeholder 2">
             <a:extLst>
               <a:ext uri="{FF2B5EF4-FFF2-40B4-BE49-F238E27FC236}">
-                <a16:creationId xmlns:a16="http://schemas.microsoft.com/office/drawing/2014/main" id="{422A8586-38A5-2452-AE5D-DD123EDB783C}"/>
+                <a16:creationId xmlns:a16="http://schemas.microsoft.com/office/drawing/2014/main" id="{053B9884-7AB3-7E9B-54C9-8F0501DA5144}"/>
               </a:ext>
             </a:extLst>
           </p:cNvPr>
@@ -451,7 +451,7 @@
           <p:cNvPr id="4" name="Date Placeholder 3">
             <a:extLst>
               <a:ext uri="{FF2B5EF4-FFF2-40B4-BE49-F238E27FC236}">
-                <a16:creationId xmlns:a16="http://schemas.microsoft.com/office/drawing/2014/main" id="{C9FDB918-026C-D070-511B-EE743D92579C}"/>
+                <a16:creationId xmlns:a16="http://schemas.microsoft.com/office/drawing/2014/main" id="{DB444727-FFF2-9B45-8DA5-892DB9A99F8D}"/>
               </a:ext>
             </a:extLst>
           </p:cNvPr>
@@ -467,7 +467,7 @@
           <a:bodyPr/>
           <a:lstStyle/>
           <a:p>
-            <a:fld id="{2FADDDB3-BC58-4304-9EBF-FF12BD3CC5C5}" type="datetimeFigureOut">
+            <a:fld id="{D451E412-291F-4FB0-8C2B-B790577930C0}" type="datetimeFigureOut">
               <a:rPr lang="en-US" smtClean="0"/>
               <a:t>8/12/2026</a:t>
             </a:fld>
@@ -480,7 +480,7 @@
           <p:cNvPr id="5" name="Footer Placeholder 4">
             <a:extLst>
               <a:ext uri="{FF2B5EF4-FFF2-40B4-BE49-F238E27FC236}">
-                <a16:creationId xmlns:a16="http://schemas.microsoft.com/office/drawing/2014/main" id="{B2A3B1EC-FDB6-F649-9936-91305DF5EA5D}"/>
+                <a16:creationId xmlns:a16="http://schemas.microsoft.com/office/drawing/2014/main" id="{3E15F0DC-EF15-69C6-A007-A1FF4D4F509A}"/>
               </a:ext>
             </a:extLst>
           </p:cNvPr>
@@ -505,7 +505,7 @@
           <p:cNvPr id="6" name="Slide Number Placeholder 5">
             <a:extLst>
               <a:ext uri="{FF2B5EF4-FFF2-40B4-BE49-F238E27FC236}">
-                <a16:creationId xmlns:a16="http://schemas.microsoft.com/office/drawing/2014/main" id="{DE6FE30D-8C72-D0EF-E8F1-7C4667941F4A}"/>
+                <a16:creationId xmlns:a16="http://schemas.microsoft.com/office/drawing/2014/main" id="{7EAA96F3-16C3-C3E1-CF1A-840ABC898C3C}"/>
               </a:ext>
             </a:extLst>
           </p:cNvPr>
@@ -521,7 +521,7 @@
           <a:bodyPr/>
           <a:lstStyle/>
           <a:p>
-            <a:fld id="{3D30C0DE-0749-4A80-8A4F-60FDA69401DD}" type="slidenum">
+            <a:fld id="{7DA03027-0733-407A-926A-230F7BC0EE61}" type="slidenum">
               <a:rPr lang="en-US" smtClean="0"/>
               <a:t>‹#›</a:t>
             </a:fld>
@@ -532,7 +532,7 @@
     </p:spTree>
     <p:extLst>
       <p:ext uri="{BB962C8B-B14F-4D97-AF65-F5344CB8AC3E}">
-        <p14:creationId xmlns:p14="http://schemas.microsoft.com/office/powerpoint/2010/main" val="45478357"/>
+        <p14:creationId xmlns:p14="http://schemas.microsoft.com/office/powerpoint/2010/main" val="2192465677"/>
       </p:ext>
     </p:extLst>
   </p:cSld>
@@ -564,7 +564,7 @@
           <p:cNvPr id="2" name="Vertical Title 1">
             <a:extLst>
               <a:ext uri="{FF2B5EF4-FFF2-40B4-BE49-F238E27FC236}">
-                <a16:creationId xmlns:a16="http://schemas.microsoft.com/office/drawing/2014/main" id="{9380B1F7-4624-BFC5-0652-3AE7C7BF4855}"/>
+                <a16:creationId xmlns:a16="http://schemas.microsoft.com/office/drawing/2014/main" id="{DF4539C4-ACB4-0588-AE51-50F45A441A52}"/>
               </a:ext>
             </a:extLst>
           </p:cNvPr>
@@ -597,7 +597,7 @@
           <p:cNvPr id="3" name="Vertical Text Placeholder 2">
             <a:extLst>
               <a:ext uri="{FF2B5EF4-FFF2-40B4-BE49-F238E27FC236}">
-                <a16:creationId xmlns:a16="http://schemas.microsoft.com/office/drawing/2014/main" id="{8151FEE6-E712-7C06-55D3-BDD456D2D000}"/>
+                <a16:creationId xmlns:a16="http://schemas.microsoft.com/office/drawing/2014/main" id="{5D71FA87-E040-6EB9-2589-A609719CDE7A}"/>
               </a:ext>
             </a:extLst>
           </p:cNvPr>
@@ -659,7 +659,7 @@
           <p:cNvPr id="4" name="Date Placeholder 3">
             <a:extLst>
               <a:ext uri="{FF2B5EF4-FFF2-40B4-BE49-F238E27FC236}">
-                <a16:creationId xmlns:a16="http://schemas.microsoft.com/office/drawing/2014/main" id="{FF29BA41-EE79-8587-DA44-B3DED72B6E6D}"/>
+                <a16:creationId xmlns:a16="http://schemas.microsoft.com/office/drawing/2014/main" id="{470AEB19-7A30-1D62-9B0F-21B39C59D6CC}"/>
               </a:ext>
             </a:extLst>
           </p:cNvPr>
@@ -675,7 +675,7 @@
           <a:bodyPr/>
           <a:lstStyle/>
           <a:p>
-            <a:fld id="{2FADDDB3-BC58-4304-9EBF-FF12BD3CC5C5}" type="datetimeFigureOut">
+            <a:fld id="{D451E412-291F-4FB0-8C2B-B790577930C0}" type="datetimeFigureOut">
               <a:rPr lang="en-US" smtClean="0"/>
               <a:t>8/12/2026</a:t>
             </a:fld>
@@ -688,7 +688,7 @@
           <p:cNvPr id="5" name="Footer Placeholder 4">
             <a:extLst>
               <a:ext uri="{FF2B5EF4-FFF2-40B4-BE49-F238E27FC236}">
-                <a16:creationId xmlns:a16="http://schemas.microsoft.com/office/drawing/2014/main" id="{97F00D81-4DA6-A02E-09C0-D4A2B74FF2C8}"/>
+                <a16:creationId xmlns:a16="http://schemas.microsoft.com/office/drawing/2014/main" id="{032B415D-608D-5C5A-5DDD-63AE902A294D}"/>
               </a:ext>
             </a:extLst>
           </p:cNvPr>
@@ -713,7 +713,7 @@
           <p:cNvPr id="6" name="Slide Number Placeholder 5">
             <a:extLst>
               <a:ext uri="{FF2B5EF4-FFF2-40B4-BE49-F238E27FC236}">
-                <a16:creationId xmlns:a16="http://schemas.microsoft.com/office/drawing/2014/main" id="{DF084B2F-CA2E-F963-48F4-59A7C5E6646F}"/>
+                <a16:creationId xmlns:a16="http://schemas.microsoft.com/office/drawing/2014/main" id="{04D4BF0E-8A40-997C-8CD1-CF9968F20B39}"/>
               </a:ext>
             </a:extLst>
           </p:cNvPr>
@@ -729,7 +729,7 @@
           <a:bodyPr/>
           <a:lstStyle/>
           <a:p>
-            <a:fld id="{3D30C0DE-0749-4A80-8A4F-60FDA69401DD}" type="slidenum">
+            <a:fld id="{7DA03027-0733-407A-926A-230F7BC0EE61}" type="slidenum">
               <a:rPr lang="en-US" smtClean="0"/>
               <a:t>‹#›</a:t>
             </a:fld>
@@ -740,7 +740,7 @@
     </p:spTree>
     <p:extLst>
       <p:ext uri="{BB962C8B-B14F-4D97-AF65-F5344CB8AC3E}">
-        <p14:creationId xmlns:p14="http://schemas.microsoft.com/office/powerpoint/2010/main" val="2590686551"/>
+        <p14:creationId xmlns:p14="http://schemas.microsoft.com/office/powerpoint/2010/main" val="3975237757"/>
       </p:ext>
     </p:extLst>
   </p:cSld>
@@ -772,7 +772,7 @@
           <p:cNvPr id="2" name="Title 1">
             <a:extLst>
               <a:ext uri="{FF2B5EF4-FFF2-40B4-BE49-F238E27FC236}">
-                <a16:creationId xmlns:a16="http://schemas.microsoft.com/office/drawing/2014/main" id="{66DBCA56-E619-0754-4463-34E172874094}"/>
+                <a16:creationId xmlns:a16="http://schemas.microsoft.com/office/drawing/2014/main" id="{C40FA915-BF1E-6431-1E3C-8BF6DF2234E3}"/>
               </a:ext>
             </a:extLst>
           </p:cNvPr>
@@ -800,7 +800,7 @@
           <p:cNvPr id="3" name="Content Placeholder 2">
             <a:extLst>
               <a:ext uri="{FF2B5EF4-FFF2-40B4-BE49-F238E27FC236}">
-                <a16:creationId xmlns:a16="http://schemas.microsoft.com/office/drawing/2014/main" id="{1150F6F6-0ACB-E8D1-CD58-903705D401E5}"/>
+                <a16:creationId xmlns:a16="http://schemas.microsoft.com/office/drawing/2014/main" id="{80F733B2-C389-C10C-4D80-6EC1C7FD686B}"/>
               </a:ext>
             </a:extLst>
           </p:cNvPr>
@@ -857,7 +857,7 @@
           <p:cNvPr id="4" name="Date Placeholder 3">
             <a:extLst>
               <a:ext uri="{FF2B5EF4-FFF2-40B4-BE49-F238E27FC236}">
-                <a16:creationId xmlns:a16="http://schemas.microsoft.com/office/drawing/2014/main" id="{B25DB663-C1A0-18B6-7513-0C0B7F6BA0DF}"/>
+                <a16:creationId xmlns:a16="http://schemas.microsoft.com/office/drawing/2014/main" id="{4EB5520C-0CFA-988B-325A-DEAE9F740ABA}"/>
               </a:ext>
             </a:extLst>
           </p:cNvPr>
@@ -873,7 +873,7 @@
           <a:bodyPr/>
           <a:lstStyle/>
           <a:p>
-            <a:fld id="{2FADDDB3-BC58-4304-9EBF-FF12BD3CC5C5}" type="datetimeFigureOut">
+            <a:fld id="{D451E412-291F-4FB0-8C2B-B790577930C0}" type="datetimeFigureOut">
               <a:rPr lang="en-US" smtClean="0"/>
               <a:t>8/12/2026</a:t>
             </a:fld>
@@ -886,7 +886,7 @@
           <p:cNvPr id="5" name="Footer Placeholder 4">
             <a:extLst>
               <a:ext uri="{FF2B5EF4-FFF2-40B4-BE49-F238E27FC236}">
-                <a16:creationId xmlns:a16="http://schemas.microsoft.com/office/drawing/2014/main" id="{748D6135-1162-CB48-1832-EC2ECA5A2BE2}"/>
+                <a16:creationId xmlns:a16="http://schemas.microsoft.com/office/drawing/2014/main" id="{EFD254F3-DE37-577F-ACA5-A08CEEDFE211}"/>
               </a:ext>
             </a:extLst>
           </p:cNvPr>
@@ -911,7 +911,7 @@
           <p:cNvPr id="6" name="Slide Number Placeholder 5">
             <a:extLst>
               <a:ext uri="{FF2B5EF4-FFF2-40B4-BE49-F238E27FC236}">
-                <a16:creationId xmlns:a16="http://schemas.microsoft.com/office/drawing/2014/main" id="{EC486541-DA60-6F1D-432D-69E34AF2EA99}"/>
+                <a16:creationId xmlns:a16="http://schemas.microsoft.com/office/drawing/2014/main" id="{BBCD3661-5495-0559-F9CD-B69C6CC4CBF2}"/>
               </a:ext>
             </a:extLst>
           </p:cNvPr>
@@ -927,7 +927,7 @@
           <a:bodyPr/>
           <a:lstStyle/>
           <a:p>
-            <a:fld id="{3D30C0DE-0749-4A80-8A4F-60FDA69401DD}" type="slidenum">
+            <a:fld id="{7DA03027-0733-407A-926A-230F7BC0EE61}" type="slidenum">
               <a:rPr lang="en-US" smtClean="0"/>
               <a:t>‹#›</a:t>
             </a:fld>
@@ -938,7 +938,7 @@
     </p:spTree>
     <p:extLst>
       <p:ext uri="{BB962C8B-B14F-4D97-AF65-F5344CB8AC3E}">
-        <p14:creationId xmlns:p14="http://schemas.microsoft.com/office/powerpoint/2010/main" val="1777031418"/>
+        <p14:creationId xmlns:p14="http://schemas.microsoft.com/office/powerpoint/2010/main" val="2330601629"/>
       </p:ext>
     </p:extLst>
   </p:cSld>
@@ -970,7 +970,7 @@
           <p:cNvPr id="2" name="Title 1">
             <a:extLst>
               <a:ext uri="{FF2B5EF4-FFF2-40B4-BE49-F238E27FC236}">
-                <a16:creationId xmlns:a16="http://schemas.microsoft.com/office/drawing/2014/main" id="{2340AA7A-50DA-1036-B4BF-3159CAC65ABF}"/>
+                <a16:creationId xmlns:a16="http://schemas.microsoft.com/office/drawing/2014/main" id="{6F07CA00-9B0D-0223-DB77-C705AF2BF894}"/>
               </a:ext>
             </a:extLst>
           </p:cNvPr>
@@ -1007,7 +1007,7 @@
           <p:cNvPr id="3" name="Text Placeholder 2">
             <a:extLst>
               <a:ext uri="{FF2B5EF4-FFF2-40B4-BE49-F238E27FC236}">
-                <a16:creationId xmlns:a16="http://schemas.microsoft.com/office/drawing/2014/main" id="{F05FF4C9-13E2-8668-D827-6DC699372AB0}"/>
+                <a16:creationId xmlns:a16="http://schemas.microsoft.com/office/drawing/2014/main" id="{0DEB5620-AB61-93DC-4701-875311FB5E7C}"/>
               </a:ext>
             </a:extLst>
           </p:cNvPr>
@@ -1132,7 +1132,7 @@
           <p:cNvPr id="4" name="Date Placeholder 3">
             <a:extLst>
               <a:ext uri="{FF2B5EF4-FFF2-40B4-BE49-F238E27FC236}">
-                <a16:creationId xmlns:a16="http://schemas.microsoft.com/office/drawing/2014/main" id="{2442BD88-F030-43AE-A379-441D2BE17403}"/>
+                <a16:creationId xmlns:a16="http://schemas.microsoft.com/office/drawing/2014/main" id="{9DCF33AC-8F7B-FEFF-568E-1572E170A265}"/>
               </a:ext>
             </a:extLst>
           </p:cNvPr>
@@ -1148,7 +1148,7 @@
           <a:bodyPr/>
           <a:lstStyle/>
           <a:p>
-            <a:fld id="{2FADDDB3-BC58-4304-9EBF-FF12BD3CC5C5}" type="datetimeFigureOut">
+            <a:fld id="{D451E412-291F-4FB0-8C2B-B790577930C0}" type="datetimeFigureOut">
               <a:rPr lang="en-US" smtClean="0"/>
               <a:t>8/12/2026</a:t>
             </a:fld>
@@ -1161,7 +1161,7 @@
           <p:cNvPr id="5" name="Footer Placeholder 4">
             <a:extLst>
               <a:ext uri="{FF2B5EF4-FFF2-40B4-BE49-F238E27FC236}">
-                <a16:creationId xmlns:a16="http://schemas.microsoft.com/office/drawing/2014/main" id="{E04BF239-4594-B133-7021-E07579AD5995}"/>
+                <a16:creationId xmlns:a16="http://schemas.microsoft.com/office/drawing/2014/main" id="{6CD52E0A-22CA-0574-07EC-4E6E0D05BE3A}"/>
               </a:ext>
             </a:extLst>
           </p:cNvPr>
@@ -1186,7 +1186,7 @@
           <p:cNvPr id="6" name="Slide Number Placeholder 5">
             <a:extLst>
               <a:ext uri="{FF2B5EF4-FFF2-40B4-BE49-F238E27FC236}">
-                <a16:creationId xmlns:a16="http://schemas.microsoft.com/office/drawing/2014/main" id="{A72567B7-57D4-39A2-56E2-06B8E8028676}"/>
+                <a16:creationId xmlns:a16="http://schemas.microsoft.com/office/drawing/2014/main" id="{C1AF9534-7562-1A19-BCF9-9060CD3F32F8}"/>
               </a:ext>
             </a:extLst>
           </p:cNvPr>
@@ -1202,7 +1202,7 @@
           <a:bodyPr/>
           <a:lstStyle/>
           <a:p>
-            <a:fld id="{3D30C0DE-0749-4A80-8A4F-60FDA69401DD}" type="slidenum">
+            <a:fld id="{7DA03027-0733-407A-926A-230F7BC0EE61}" type="slidenum">
               <a:rPr lang="en-US" smtClean="0"/>
               <a:t>‹#›</a:t>
             </a:fld>
@@ -1213,7 +1213,7 @@
     </p:spTree>
     <p:extLst>
       <p:ext uri="{BB962C8B-B14F-4D97-AF65-F5344CB8AC3E}">
-        <p14:creationId xmlns:p14="http://schemas.microsoft.com/office/powerpoint/2010/main" val="3189537094"/>
+        <p14:creationId xmlns:p14="http://schemas.microsoft.com/office/powerpoint/2010/main" val="2385956968"/>
       </p:ext>
     </p:extLst>
   </p:cSld>
@@ -1245,7 +1245,7 @@
           <p:cNvPr id="2" name="Title 1">
             <a:extLst>
               <a:ext uri="{FF2B5EF4-FFF2-40B4-BE49-F238E27FC236}">
-                <a16:creationId xmlns:a16="http://schemas.microsoft.com/office/drawing/2014/main" id="{A38A1A10-260A-DA2D-2EC5-0B18CEAB77C5}"/>
+                <a16:creationId xmlns:a16="http://schemas.microsoft.com/office/drawing/2014/main" id="{FB090E41-7478-2EF8-CB8D-63B452FFADF4}"/>
               </a:ext>
             </a:extLst>
           </p:cNvPr>
@@ -1273,7 +1273,7 @@
           <p:cNvPr id="3" name="Content Placeholder 2">
             <a:extLst>
               <a:ext uri="{FF2B5EF4-FFF2-40B4-BE49-F238E27FC236}">
-                <a16:creationId xmlns:a16="http://schemas.microsoft.com/office/drawing/2014/main" id="{5B1FE8E6-A56A-29BC-843F-EB13F6D8ADCA}"/>
+                <a16:creationId xmlns:a16="http://schemas.microsoft.com/office/drawing/2014/main" id="{5528A77A-0A3B-3C07-349C-A2BEF1D221A5}"/>
               </a:ext>
             </a:extLst>
           </p:cNvPr>
@@ -1335,7 +1335,7 @@
           <p:cNvPr id="4" name="Content Placeholder 3">
             <a:extLst>
               <a:ext uri="{FF2B5EF4-FFF2-40B4-BE49-F238E27FC236}">
-                <a16:creationId xmlns:a16="http://schemas.microsoft.com/office/drawing/2014/main" id="{E6E30243-DC00-9615-9912-BC8D2FBB3A3C}"/>
+                <a16:creationId xmlns:a16="http://schemas.microsoft.com/office/drawing/2014/main" id="{7D7406E1-B166-CE45-52F7-B2B511774F02}"/>
               </a:ext>
             </a:extLst>
           </p:cNvPr>
@@ -1397,7 +1397,7 @@
           <p:cNvPr id="5" name="Date Placeholder 4">
             <a:extLst>
               <a:ext uri="{FF2B5EF4-FFF2-40B4-BE49-F238E27FC236}">
-                <a16:creationId xmlns:a16="http://schemas.microsoft.com/office/drawing/2014/main" id="{5E01D9CE-7407-7C16-9407-8B8CB22B27F5}"/>
+                <a16:creationId xmlns:a16="http://schemas.microsoft.com/office/drawing/2014/main" id="{9499F8A2-631C-EABD-F343-87B268181C7C}"/>
               </a:ext>
             </a:extLst>
           </p:cNvPr>
@@ -1413,7 +1413,7 @@
           <a:bodyPr/>
           <a:lstStyle/>
           <a:p>
-            <a:fld id="{2FADDDB3-BC58-4304-9EBF-FF12BD3CC5C5}" type="datetimeFigureOut">
+            <a:fld id="{D451E412-291F-4FB0-8C2B-B790577930C0}" type="datetimeFigureOut">
               <a:rPr lang="en-US" smtClean="0"/>
               <a:t>8/12/2026</a:t>
             </a:fld>
@@ -1426,7 +1426,7 @@
           <p:cNvPr id="6" name="Footer Placeholder 5">
             <a:extLst>
               <a:ext uri="{FF2B5EF4-FFF2-40B4-BE49-F238E27FC236}">
-                <a16:creationId xmlns:a16="http://schemas.microsoft.com/office/drawing/2014/main" id="{5F72E9CF-600A-C2EC-0E93-934DA1D603DB}"/>
+                <a16:creationId xmlns:a16="http://schemas.microsoft.com/office/drawing/2014/main" id="{C056A312-49A7-804B-9CE1-974B575E9D88}"/>
               </a:ext>
             </a:extLst>
           </p:cNvPr>
@@ -1451,7 +1451,7 @@
           <p:cNvPr id="7" name="Slide Number Placeholder 6">
             <a:extLst>
               <a:ext uri="{FF2B5EF4-FFF2-40B4-BE49-F238E27FC236}">
-                <a16:creationId xmlns:a16="http://schemas.microsoft.com/office/drawing/2014/main" id="{F79DAE58-4C6A-B2B9-FC11-42FCF0E26340}"/>
+                <a16:creationId xmlns:a16="http://schemas.microsoft.com/office/drawing/2014/main" id="{784801BD-06D1-A67E-832B-B0D19FCAF744}"/>
               </a:ext>
             </a:extLst>
           </p:cNvPr>
@@ -1467,7 +1467,7 @@
           <a:bodyPr/>
           <a:lstStyle/>
           <a:p>
-            <a:fld id="{3D30C0DE-0749-4A80-8A4F-60FDA69401DD}" type="slidenum">
+            <a:fld id="{7DA03027-0733-407A-926A-230F7BC0EE61}" type="slidenum">
               <a:rPr lang="en-US" smtClean="0"/>
               <a:t>‹#›</a:t>
             </a:fld>
@@ -1478,7 +1478,7 @@
     </p:spTree>
     <p:extLst>
       <p:ext uri="{BB962C8B-B14F-4D97-AF65-F5344CB8AC3E}">
-        <p14:creationId xmlns:p14="http://schemas.microsoft.com/office/powerpoint/2010/main" val="2564322203"/>
+        <p14:creationId xmlns:p14="http://schemas.microsoft.com/office/powerpoint/2010/main" val="151716257"/>
       </p:ext>
     </p:extLst>
   </p:cSld>
@@ -1510,7 +1510,7 @@
           <p:cNvPr id="2" name="Title 1">
             <a:extLst>
               <a:ext uri="{FF2B5EF4-FFF2-40B4-BE49-F238E27FC236}">
-                <a16:creationId xmlns:a16="http://schemas.microsoft.com/office/drawing/2014/main" id="{1511F42E-1543-79BC-9334-B579FA589AA7}"/>
+                <a16:creationId xmlns:a16="http://schemas.microsoft.com/office/drawing/2014/main" id="{977865A2-7C70-0C7F-9F23-645FD87EED76}"/>
               </a:ext>
             </a:extLst>
           </p:cNvPr>
@@ -1543,7 +1543,7 @@
           <p:cNvPr id="3" name="Text Placeholder 2">
             <a:extLst>
               <a:ext uri="{FF2B5EF4-FFF2-40B4-BE49-F238E27FC236}">
-                <a16:creationId xmlns:a16="http://schemas.microsoft.com/office/drawing/2014/main" id="{BF73FAA2-1AA9-5023-366E-6DBCEF9A04D4}"/>
+                <a16:creationId xmlns:a16="http://schemas.microsoft.com/office/drawing/2014/main" id="{406562EA-CAEF-69C1-99B1-1E70BB4D8ACF}"/>
               </a:ext>
             </a:extLst>
           </p:cNvPr>
@@ -1614,7 +1614,7 @@
           <p:cNvPr id="4" name="Content Placeholder 3">
             <a:extLst>
               <a:ext uri="{FF2B5EF4-FFF2-40B4-BE49-F238E27FC236}">
-                <a16:creationId xmlns:a16="http://schemas.microsoft.com/office/drawing/2014/main" id="{2DEC1CD8-ABAC-153F-E0A7-A2AFD5132477}"/>
+                <a16:creationId xmlns:a16="http://schemas.microsoft.com/office/drawing/2014/main" id="{8903723D-0B6C-51DC-CEDD-30E21093E9A2}"/>
               </a:ext>
             </a:extLst>
           </p:cNvPr>
@@ -1676,7 +1676,7 @@
           <p:cNvPr id="5" name="Text Placeholder 4">
             <a:extLst>
               <a:ext uri="{FF2B5EF4-FFF2-40B4-BE49-F238E27FC236}">
-                <a16:creationId xmlns:a16="http://schemas.microsoft.com/office/drawing/2014/main" id="{6C3A3F36-0F5A-57D2-CDF1-6A40783DF760}"/>
+                <a16:creationId xmlns:a16="http://schemas.microsoft.com/office/drawing/2014/main" id="{B82EBC15-CBF7-F64E-05F7-2E63F0579C7E}"/>
               </a:ext>
             </a:extLst>
           </p:cNvPr>
@@ -1747,7 +1747,7 @@
           <p:cNvPr id="6" name="Content Placeholder 5">
             <a:extLst>
               <a:ext uri="{FF2B5EF4-FFF2-40B4-BE49-F238E27FC236}">
-                <a16:creationId xmlns:a16="http://schemas.microsoft.com/office/drawing/2014/main" id="{2FF15100-E45D-3724-423D-F00F184B1F54}"/>
+                <a16:creationId xmlns:a16="http://schemas.microsoft.com/office/drawing/2014/main" id="{5472129F-D67A-0CF0-A018-60056F03991C}"/>
               </a:ext>
             </a:extLst>
           </p:cNvPr>
@@ -1809,7 +1809,7 @@
           <p:cNvPr id="7" name="Date Placeholder 6">
             <a:extLst>
               <a:ext uri="{FF2B5EF4-FFF2-40B4-BE49-F238E27FC236}">
-                <a16:creationId xmlns:a16="http://schemas.microsoft.com/office/drawing/2014/main" id="{8104BD18-E76C-49DC-F8E7-10EC48ADD6D4}"/>
+                <a16:creationId xmlns:a16="http://schemas.microsoft.com/office/drawing/2014/main" id="{15925762-10BC-44B8-766D-FEAD477A4DB7}"/>
               </a:ext>
             </a:extLst>
           </p:cNvPr>
@@ -1825,7 +1825,7 @@
           <a:bodyPr/>
           <a:lstStyle/>
           <a:p>
-            <a:fld id="{2FADDDB3-BC58-4304-9EBF-FF12BD3CC5C5}" type="datetimeFigureOut">
+            <a:fld id="{D451E412-291F-4FB0-8C2B-B790577930C0}" type="datetimeFigureOut">
               <a:rPr lang="en-US" smtClean="0"/>
               <a:t>8/12/2026</a:t>
             </a:fld>
@@ -1838,7 +1838,7 @@
           <p:cNvPr id="8" name="Footer Placeholder 7">
             <a:extLst>
               <a:ext uri="{FF2B5EF4-FFF2-40B4-BE49-F238E27FC236}">
-                <a16:creationId xmlns:a16="http://schemas.microsoft.com/office/drawing/2014/main" id="{583989DD-F805-2084-1B97-A12469350D42}"/>
+                <a16:creationId xmlns:a16="http://schemas.microsoft.com/office/drawing/2014/main" id="{6D9CA218-DB17-AB37-91C2-F10CA3C828F0}"/>
               </a:ext>
             </a:extLst>
           </p:cNvPr>
@@ -1863,7 +1863,7 @@
           <p:cNvPr id="9" name="Slide Number Placeholder 8">
             <a:extLst>
               <a:ext uri="{FF2B5EF4-FFF2-40B4-BE49-F238E27FC236}">
-                <a16:creationId xmlns:a16="http://schemas.microsoft.com/office/drawing/2014/main" id="{60118CB7-5FB0-96E4-1F16-2E7DD3758931}"/>
+                <a16:creationId xmlns:a16="http://schemas.microsoft.com/office/drawing/2014/main" id="{4A46CFB2-566C-C908-7E23-D80D9124AEE8}"/>
               </a:ext>
             </a:extLst>
           </p:cNvPr>
@@ -1879,7 +1879,7 @@
           <a:bodyPr/>
           <a:lstStyle/>
           <a:p>
-            <a:fld id="{3D30C0DE-0749-4A80-8A4F-60FDA69401DD}" type="slidenum">
+            <a:fld id="{7DA03027-0733-407A-926A-230F7BC0EE61}" type="slidenum">
               <a:rPr lang="en-US" smtClean="0"/>
               <a:t>‹#›</a:t>
             </a:fld>
@@ -1890,7 +1890,7 @@
     </p:spTree>
     <p:extLst>
       <p:ext uri="{BB962C8B-B14F-4D97-AF65-F5344CB8AC3E}">
-        <p14:creationId xmlns:p14="http://schemas.microsoft.com/office/powerpoint/2010/main" val="3406919257"/>
+        <p14:creationId xmlns:p14="http://schemas.microsoft.com/office/powerpoint/2010/main" val="1474801906"/>
       </p:ext>
     </p:extLst>
   </p:cSld>
@@ -1922,7 +1922,7 @@
           <p:cNvPr id="2" name="Title 1">
             <a:extLst>
               <a:ext uri="{FF2B5EF4-FFF2-40B4-BE49-F238E27FC236}">
-                <a16:creationId xmlns:a16="http://schemas.microsoft.com/office/drawing/2014/main" id="{875DDEEF-2AD0-3BE0-0BFF-25F4D6AA2896}"/>
+                <a16:creationId xmlns:a16="http://schemas.microsoft.com/office/drawing/2014/main" id="{B4B07C72-9E9A-6603-9953-D23699968810}"/>
               </a:ext>
             </a:extLst>
           </p:cNvPr>
@@ -1950,7 +1950,7 @@
           <p:cNvPr id="3" name="Date Placeholder 2">
             <a:extLst>
               <a:ext uri="{FF2B5EF4-FFF2-40B4-BE49-F238E27FC236}">
-                <a16:creationId xmlns:a16="http://schemas.microsoft.com/office/drawing/2014/main" id="{C4BC358E-9B34-DEBC-56CD-CDFB32D3456A}"/>
+                <a16:creationId xmlns:a16="http://schemas.microsoft.com/office/drawing/2014/main" id="{0BBBF163-DD79-F51A-CCF1-AF00D3E0F804}"/>
               </a:ext>
             </a:extLst>
           </p:cNvPr>
@@ -1966,7 +1966,7 @@
           <a:bodyPr/>
           <a:lstStyle/>
           <a:p>
-            <a:fld id="{2FADDDB3-BC58-4304-9EBF-FF12BD3CC5C5}" type="datetimeFigureOut">
+            <a:fld id="{D451E412-291F-4FB0-8C2B-B790577930C0}" type="datetimeFigureOut">
               <a:rPr lang="en-US" smtClean="0"/>
               <a:t>8/12/2026</a:t>
             </a:fld>
@@ -1979,7 +1979,7 @@
           <p:cNvPr id="4" name="Footer Placeholder 3">
             <a:extLst>
               <a:ext uri="{FF2B5EF4-FFF2-40B4-BE49-F238E27FC236}">
-                <a16:creationId xmlns:a16="http://schemas.microsoft.com/office/drawing/2014/main" id="{3D2583AA-7933-CB68-8273-3D80BFE10777}"/>
+                <a16:creationId xmlns:a16="http://schemas.microsoft.com/office/drawing/2014/main" id="{E4A2521F-C40E-6CAA-49A4-8680AA36B5BC}"/>
               </a:ext>
             </a:extLst>
           </p:cNvPr>
@@ -2004,7 +2004,7 @@
           <p:cNvPr id="5" name="Slide Number Placeholder 4">
             <a:extLst>
               <a:ext uri="{FF2B5EF4-FFF2-40B4-BE49-F238E27FC236}">
-                <a16:creationId xmlns:a16="http://schemas.microsoft.com/office/drawing/2014/main" id="{89B45944-A1C7-A4E9-CD58-1D17A3F7A0F9}"/>
+                <a16:creationId xmlns:a16="http://schemas.microsoft.com/office/drawing/2014/main" id="{93E6A74C-916A-1F7A-7934-2672B8D4D618}"/>
               </a:ext>
             </a:extLst>
           </p:cNvPr>
@@ -2020,7 +2020,7 @@
           <a:bodyPr/>
           <a:lstStyle/>
           <a:p>
-            <a:fld id="{3D30C0DE-0749-4A80-8A4F-60FDA69401DD}" type="slidenum">
+            <a:fld id="{7DA03027-0733-407A-926A-230F7BC0EE61}" type="slidenum">
               <a:rPr lang="en-US" smtClean="0"/>
               <a:t>‹#›</a:t>
             </a:fld>
@@ -2031,7 +2031,7 @@
     </p:spTree>
     <p:extLst>
       <p:ext uri="{BB962C8B-B14F-4D97-AF65-F5344CB8AC3E}">
-        <p14:creationId xmlns:p14="http://schemas.microsoft.com/office/powerpoint/2010/main" val="2721423096"/>
+        <p14:creationId xmlns:p14="http://schemas.microsoft.com/office/powerpoint/2010/main" val="91680104"/>
       </p:ext>
     </p:extLst>
   </p:cSld>
@@ -2063,7 +2063,7 @@
           <p:cNvPr id="2" name="Date Placeholder 1">
             <a:extLst>
               <a:ext uri="{FF2B5EF4-FFF2-40B4-BE49-F238E27FC236}">
-                <a16:creationId xmlns:a16="http://schemas.microsoft.com/office/drawing/2014/main" id="{B29568EC-3907-D94C-DFFD-373D61E4E4F0}"/>
+                <a16:creationId xmlns:a16="http://schemas.microsoft.com/office/drawing/2014/main" id="{EF1D80C8-6376-4B34-68EF-165CF047E520}"/>
               </a:ext>
             </a:extLst>
           </p:cNvPr>
@@ -2079,7 +2079,7 @@
           <a:bodyPr/>
           <a:lstStyle/>
           <a:p>
-            <a:fld id="{2FADDDB3-BC58-4304-9EBF-FF12BD3CC5C5}" type="datetimeFigureOut">
+            <a:fld id="{D451E412-291F-4FB0-8C2B-B790577930C0}" type="datetimeFigureOut">
               <a:rPr lang="en-US" smtClean="0"/>
               <a:t>8/12/2026</a:t>
             </a:fld>
@@ -2092,7 +2092,7 @@
           <p:cNvPr id="3" name="Footer Placeholder 2">
             <a:extLst>
               <a:ext uri="{FF2B5EF4-FFF2-40B4-BE49-F238E27FC236}">
-                <a16:creationId xmlns:a16="http://schemas.microsoft.com/office/drawing/2014/main" id="{EF700604-5BFE-A740-855F-DEFA4EECC495}"/>
+                <a16:creationId xmlns:a16="http://schemas.microsoft.com/office/drawing/2014/main" id="{E78C6E1A-0492-B57B-DA11-1A4096794434}"/>
               </a:ext>
             </a:extLst>
           </p:cNvPr>
@@ -2117,7 +2117,7 @@
           <p:cNvPr id="4" name="Slide Number Placeholder 3">
             <a:extLst>
               <a:ext uri="{FF2B5EF4-FFF2-40B4-BE49-F238E27FC236}">
-                <a16:creationId xmlns:a16="http://schemas.microsoft.com/office/drawing/2014/main" id="{1855CF23-D891-CF7E-A097-823032D8FB38}"/>
+                <a16:creationId xmlns:a16="http://schemas.microsoft.com/office/drawing/2014/main" id="{1FAB6DFD-C270-2DE8-25DB-649E3E3B4B6B}"/>
               </a:ext>
             </a:extLst>
           </p:cNvPr>
@@ -2133,7 +2133,7 @@
           <a:bodyPr/>
           <a:lstStyle/>
           <a:p>
-            <a:fld id="{3D30C0DE-0749-4A80-8A4F-60FDA69401DD}" type="slidenum">
+            <a:fld id="{7DA03027-0733-407A-926A-230F7BC0EE61}" type="slidenum">
               <a:rPr lang="en-US" smtClean="0"/>
               <a:t>‹#›</a:t>
             </a:fld>
@@ -2144,7 +2144,7 @@
     </p:spTree>
     <p:extLst>
       <p:ext uri="{BB962C8B-B14F-4D97-AF65-F5344CB8AC3E}">
-        <p14:creationId xmlns:p14="http://schemas.microsoft.com/office/powerpoint/2010/main" val="715560688"/>
+        <p14:creationId xmlns:p14="http://schemas.microsoft.com/office/powerpoint/2010/main" val="148413258"/>
       </p:ext>
     </p:extLst>
   </p:cSld>
@@ -2176,7 +2176,7 @@
           <p:cNvPr id="2" name="Title 1">
             <a:extLst>
               <a:ext uri="{FF2B5EF4-FFF2-40B4-BE49-F238E27FC236}">
-                <a16:creationId xmlns:a16="http://schemas.microsoft.com/office/drawing/2014/main" id="{258B0821-84A4-7193-A87A-1C5691983B88}"/>
+                <a16:creationId xmlns:a16="http://schemas.microsoft.com/office/drawing/2014/main" id="{1E3A9465-1B02-8652-A690-0CF041243B7C}"/>
               </a:ext>
             </a:extLst>
           </p:cNvPr>
@@ -2213,7 +2213,7 @@
           <p:cNvPr id="3" name="Content Placeholder 2">
             <a:extLst>
               <a:ext uri="{FF2B5EF4-FFF2-40B4-BE49-F238E27FC236}">
-                <a16:creationId xmlns:a16="http://schemas.microsoft.com/office/drawing/2014/main" id="{B45758A9-58DB-A332-1FF5-56169CE8F351}"/>
+                <a16:creationId xmlns:a16="http://schemas.microsoft.com/office/drawing/2014/main" id="{13E6B291-B42F-5E57-B9FC-07C91D52FC89}"/>
               </a:ext>
             </a:extLst>
           </p:cNvPr>
@@ -2303,7 +2303,7 @@
           <p:cNvPr id="4" name="Text Placeholder 3">
             <a:extLst>
               <a:ext uri="{FF2B5EF4-FFF2-40B4-BE49-F238E27FC236}">
-                <a16:creationId xmlns:a16="http://schemas.microsoft.com/office/drawing/2014/main" id="{0FAE993B-7849-6668-8DD9-9F93F1E9D9E1}"/>
+                <a16:creationId xmlns:a16="http://schemas.microsoft.com/office/drawing/2014/main" id="{A014EB8F-76F0-DFEB-14F8-B247A64389FF}"/>
               </a:ext>
             </a:extLst>
           </p:cNvPr>
@@ -2374,7 +2374,7 @@
           <p:cNvPr id="5" name="Date Placeholder 4">
             <a:extLst>
               <a:ext uri="{FF2B5EF4-FFF2-40B4-BE49-F238E27FC236}">
-                <a16:creationId xmlns:a16="http://schemas.microsoft.com/office/drawing/2014/main" id="{43296E9A-4007-AFDF-4BF4-0668551CFCB5}"/>
+                <a16:creationId xmlns:a16="http://schemas.microsoft.com/office/drawing/2014/main" id="{285FE1A9-B7EF-B4B4-D556-B7F3C8568A05}"/>
               </a:ext>
             </a:extLst>
           </p:cNvPr>
@@ -2390,7 +2390,7 @@
           <a:bodyPr/>
           <a:lstStyle/>
           <a:p>
-            <a:fld id="{2FADDDB3-BC58-4304-9EBF-FF12BD3CC5C5}" type="datetimeFigureOut">
+            <a:fld id="{D451E412-291F-4FB0-8C2B-B790577930C0}" type="datetimeFigureOut">
               <a:rPr lang="en-US" smtClean="0"/>
               <a:t>8/12/2026</a:t>
             </a:fld>
@@ -2403,7 +2403,7 @@
           <p:cNvPr id="6" name="Footer Placeholder 5">
             <a:extLst>
               <a:ext uri="{FF2B5EF4-FFF2-40B4-BE49-F238E27FC236}">
-                <a16:creationId xmlns:a16="http://schemas.microsoft.com/office/drawing/2014/main" id="{A5CB1108-C4A5-272A-5167-4B1B06990254}"/>
+                <a16:creationId xmlns:a16="http://schemas.microsoft.com/office/drawing/2014/main" id="{9439C80E-7664-5D11-29D4-0124E6079EE4}"/>
               </a:ext>
             </a:extLst>
           </p:cNvPr>
@@ -2428,7 +2428,7 @@
           <p:cNvPr id="7" name="Slide Number Placeholder 6">
             <a:extLst>
               <a:ext uri="{FF2B5EF4-FFF2-40B4-BE49-F238E27FC236}">
-                <a16:creationId xmlns:a16="http://schemas.microsoft.com/office/drawing/2014/main" id="{914924F2-58C1-4EDB-99C5-7C9A300C10CA}"/>
+                <a16:creationId xmlns:a16="http://schemas.microsoft.com/office/drawing/2014/main" id="{31D78A3D-8F94-34B5-988A-8BE9EC9DE31F}"/>
               </a:ext>
             </a:extLst>
           </p:cNvPr>
@@ -2444,7 +2444,7 @@
           <a:bodyPr/>
           <a:lstStyle/>
           <a:p>
-            <a:fld id="{3D30C0DE-0749-4A80-8A4F-60FDA69401DD}" type="slidenum">
+            <a:fld id="{7DA03027-0733-407A-926A-230F7BC0EE61}" type="slidenum">
               <a:rPr lang="en-US" smtClean="0"/>
               <a:t>‹#›</a:t>
             </a:fld>
@@ -2455,7 +2455,7 @@
     </p:spTree>
     <p:extLst>
       <p:ext uri="{BB962C8B-B14F-4D97-AF65-F5344CB8AC3E}">
-        <p14:creationId xmlns:p14="http://schemas.microsoft.com/office/powerpoint/2010/main" val="2797560640"/>
+        <p14:creationId xmlns:p14="http://schemas.microsoft.com/office/powerpoint/2010/main" val="751589214"/>
       </p:ext>
     </p:extLst>
   </p:cSld>
@@ -2487,7 +2487,7 @@
           <p:cNvPr id="2" name="Title 1">
             <a:extLst>
               <a:ext uri="{FF2B5EF4-FFF2-40B4-BE49-F238E27FC236}">
-                <a16:creationId xmlns:a16="http://schemas.microsoft.com/office/drawing/2014/main" id="{8D923E89-6953-9077-BD4D-C368FAB96614}"/>
+                <a16:creationId xmlns:a16="http://schemas.microsoft.com/office/drawing/2014/main" id="{99E05C09-559C-C49F-A7F8-B37246C7A2A5}"/>
               </a:ext>
             </a:extLst>
           </p:cNvPr>
@@ -2524,7 +2524,7 @@
           <p:cNvPr id="3" name="Picture Placeholder 2">
             <a:extLst>
               <a:ext uri="{FF2B5EF4-FFF2-40B4-BE49-F238E27FC236}">
-                <a16:creationId xmlns:a16="http://schemas.microsoft.com/office/drawing/2014/main" id="{A4FD567C-DA55-B1EC-DE78-70BEDD435919}"/>
+                <a16:creationId xmlns:a16="http://schemas.microsoft.com/office/drawing/2014/main" id="{36275859-B82E-856C-19A2-4DDD1F9A5749}"/>
               </a:ext>
             </a:extLst>
           </p:cNvPr>
@@ -2591,7 +2591,7 @@
           <p:cNvPr id="4" name="Text Placeholder 3">
             <a:extLst>
               <a:ext uri="{FF2B5EF4-FFF2-40B4-BE49-F238E27FC236}">
-                <a16:creationId xmlns:a16="http://schemas.microsoft.com/office/drawing/2014/main" id="{2791EF85-8BD7-8148-01AA-34BEAF67AE51}"/>
+                <a16:creationId xmlns:a16="http://schemas.microsoft.com/office/drawing/2014/main" id="{D5CC0CFC-08CE-12A5-3DE6-5E8AED0A4246}"/>
               </a:ext>
             </a:extLst>
           </p:cNvPr>
@@ -2662,7 +2662,7 @@
           <p:cNvPr id="5" name="Date Placeholder 4">
             <a:extLst>
               <a:ext uri="{FF2B5EF4-FFF2-40B4-BE49-F238E27FC236}">
-                <a16:creationId xmlns:a16="http://schemas.microsoft.com/office/drawing/2014/main" id="{F3676133-A8F6-5570-ED96-1D8772E2022C}"/>
+                <a16:creationId xmlns:a16="http://schemas.microsoft.com/office/drawing/2014/main" id="{D1B7A1D9-3CEA-B55C-2A97-1B92B51D4A6B}"/>
               </a:ext>
             </a:extLst>
           </p:cNvPr>
@@ -2678,7 +2678,7 @@
           <a:bodyPr/>
           <a:lstStyle/>
           <a:p>
-            <a:fld id="{2FADDDB3-BC58-4304-9EBF-FF12BD3CC5C5}" type="datetimeFigureOut">
+            <a:fld id="{D451E412-291F-4FB0-8C2B-B790577930C0}" type="datetimeFigureOut">
               <a:rPr lang="en-US" smtClean="0"/>
               <a:t>8/12/2026</a:t>
             </a:fld>
@@ -2691,7 +2691,7 @@
           <p:cNvPr id="6" name="Footer Placeholder 5">
             <a:extLst>
               <a:ext uri="{FF2B5EF4-FFF2-40B4-BE49-F238E27FC236}">
-                <a16:creationId xmlns:a16="http://schemas.microsoft.com/office/drawing/2014/main" id="{4909F4CE-8BB3-0D44-4B87-EFF8336FC59E}"/>
+                <a16:creationId xmlns:a16="http://schemas.microsoft.com/office/drawing/2014/main" id="{59A08B95-2512-9D5A-7B11-B100C7DCC63D}"/>
               </a:ext>
             </a:extLst>
           </p:cNvPr>
@@ -2716,7 +2716,7 @@
           <p:cNvPr id="7" name="Slide Number Placeholder 6">
             <a:extLst>
               <a:ext uri="{FF2B5EF4-FFF2-40B4-BE49-F238E27FC236}">
-                <a16:creationId xmlns:a16="http://schemas.microsoft.com/office/drawing/2014/main" id="{F5802CD1-5368-5E7E-62E1-671E71BEBC04}"/>
+                <a16:creationId xmlns:a16="http://schemas.microsoft.com/office/drawing/2014/main" id="{AC0F5A71-1F91-3EF8-7BF4-D3F2F97A849D}"/>
               </a:ext>
             </a:extLst>
           </p:cNvPr>
@@ -2732,7 +2732,7 @@
           <a:bodyPr/>
           <a:lstStyle/>
           <a:p>
-            <a:fld id="{3D30C0DE-0749-4A80-8A4F-60FDA69401DD}" type="slidenum">
+            <a:fld id="{7DA03027-0733-407A-926A-230F7BC0EE61}" type="slidenum">
               <a:rPr lang="en-US" smtClean="0"/>
               <a:t>‹#›</a:t>
             </a:fld>
@@ -2743,7 +2743,7 @@
     </p:spTree>
     <p:extLst>
       <p:ext uri="{BB962C8B-B14F-4D97-AF65-F5344CB8AC3E}">
-        <p14:creationId xmlns:p14="http://schemas.microsoft.com/office/powerpoint/2010/main" val="3881438527"/>
+        <p14:creationId xmlns:p14="http://schemas.microsoft.com/office/powerpoint/2010/main" val="1956411945"/>
       </p:ext>
     </p:extLst>
   </p:cSld>
@@ -2780,7 +2780,7 @@
           <p:cNvPr id="2" name="Title Placeholder 1">
             <a:extLst>
               <a:ext uri="{FF2B5EF4-FFF2-40B4-BE49-F238E27FC236}">
-                <a16:creationId xmlns:a16="http://schemas.microsoft.com/office/drawing/2014/main" id="{D7F805DD-7C64-9F43-BF5E-4F7A3AA239B4}"/>
+                <a16:creationId xmlns:a16="http://schemas.microsoft.com/office/drawing/2014/main" id="{E9D33C1C-1E35-A8F7-EBA9-370A69D247B2}"/>
               </a:ext>
             </a:extLst>
           </p:cNvPr>
@@ -2818,7 +2818,7 @@
           <p:cNvPr id="3" name="Text Placeholder 2">
             <a:extLst>
               <a:ext uri="{FF2B5EF4-FFF2-40B4-BE49-F238E27FC236}">
-                <a16:creationId xmlns:a16="http://schemas.microsoft.com/office/drawing/2014/main" id="{95F8A4FB-B3E7-C046-0E35-35B702D7DBBD}"/>
+                <a16:creationId xmlns:a16="http://schemas.microsoft.com/office/drawing/2014/main" id="{9300FF06-599B-D4CB-488A-C8DE38545B62}"/>
               </a:ext>
             </a:extLst>
           </p:cNvPr>
@@ -2885,7 +2885,7 @@
           <p:cNvPr id="4" name="Date Placeholder 3">
             <a:extLst>
               <a:ext uri="{FF2B5EF4-FFF2-40B4-BE49-F238E27FC236}">
-                <a16:creationId xmlns:a16="http://schemas.microsoft.com/office/drawing/2014/main" id="{E2D3AD36-579F-83DE-7C60-0C3FE41B6885}"/>
+                <a16:creationId xmlns:a16="http://schemas.microsoft.com/office/drawing/2014/main" id="{1DD1BBC8-E767-9B48-1369-975DF3383E23}"/>
               </a:ext>
             </a:extLst>
           </p:cNvPr>
@@ -2919,7 +2919,7 @@
             </a:lvl1pPr>
           </a:lstStyle>
           <a:p>
-            <a:fld id="{2FADDDB3-BC58-4304-9EBF-FF12BD3CC5C5}" type="datetimeFigureOut">
+            <a:fld id="{D451E412-291F-4FB0-8C2B-B790577930C0}" type="datetimeFigureOut">
               <a:rPr lang="en-US" smtClean="0"/>
               <a:t>8/12/2026</a:t>
             </a:fld>
@@ -2932,7 +2932,7 @@
           <p:cNvPr id="5" name="Footer Placeholder 4">
             <a:extLst>
               <a:ext uri="{FF2B5EF4-FFF2-40B4-BE49-F238E27FC236}">
-                <a16:creationId xmlns:a16="http://schemas.microsoft.com/office/drawing/2014/main" id="{34EC55AA-6BA7-ED71-9489-76DF3E7FEE6E}"/>
+                <a16:creationId xmlns:a16="http://schemas.microsoft.com/office/drawing/2014/main" id="{FFDB11CD-13B5-6268-EC52-8DA3F32F209D}"/>
               </a:ext>
             </a:extLst>
           </p:cNvPr>
@@ -2975,7 +2975,7 @@
           <p:cNvPr id="6" name="Slide Number Placeholder 5">
             <a:extLst>
               <a:ext uri="{FF2B5EF4-FFF2-40B4-BE49-F238E27FC236}">
-                <a16:creationId xmlns:a16="http://schemas.microsoft.com/office/drawing/2014/main" id="{FCC35E95-E97A-BA0B-2955-4D25F62E2C59}"/>
+                <a16:creationId xmlns:a16="http://schemas.microsoft.com/office/drawing/2014/main" id="{429E4B02-3AC7-1293-D202-41226D797982}"/>
               </a:ext>
             </a:extLst>
           </p:cNvPr>
@@ -3009,7 +3009,7 @@
             </a:lvl1pPr>
           </a:lstStyle>
           <a:p>
-            <a:fld id="{3D30C0DE-0749-4A80-8A4F-60FDA69401DD}" type="slidenum">
+            <a:fld id="{7DA03027-0733-407A-926A-230F7BC0EE61}" type="slidenum">
               <a:rPr lang="en-US" smtClean="0"/>
               <a:t>‹#›</a:t>
             </a:fld>
@@ -3020,7 +3020,7 @@
     </p:spTree>
     <p:extLst>
       <p:ext uri="{BB962C8B-B14F-4D97-AF65-F5344CB8AC3E}">
-        <p14:creationId xmlns:p14="http://schemas.microsoft.com/office/powerpoint/2010/main" val="1752275648"/>
+        <p14:creationId xmlns:p14="http://schemas.microsoft.com/office/powerpoint/2010/main" val="3466633296"/>
       </p:ext>
     </p:extLst>
   </p:cSld>
@@ -3327,7 +3327,7 @@
     <p:bg>
       <p:bgPr>
         <a:solidFill>
-          <a:srgbClr val="1E2761"/>
+          <a:srgbClr val="12293F"/>
         </a:solidFill>
         <a:effectLst/>
       </p:bgPr>
@@ -3348,90 +3348,10 @@
       </p:grpSpPr>
       <p:sp>
         <p:nvSpPr>
-          <p:cNvPr id="2" name="TextBox 1">
-            <a:extLst>
-              <a:ext uri="{FF2B5EF4-FFF2-40B4-BE49-F238E27FC236}">
-                <a16:creationId xmlns:a16="http://schemas.microsoft.com/office/drawing/2014/main" id="{86899329-DD3F-77E5-0730-43616F8A8BEB}"/>
-              </a:ext>
-            </a:extLst>
-          </p:cNvPr>
-          <p:cNvSpPr txBox="1"/>
-          <p:nvPr/>
-        </p:nvSpPr>
-        <p:spPr>
-          <a:xfrm>
-            <a:off x="762000" y="2540000"/>
-            <a:ext cx="10668000" cy="615553"/>
-          </a:xfrm>
-          <a:prstGeom prst="rect">
-            <a:avLst/>
-          </a:prstGeom>
-          <a:noFill/>
-        </p:spPr>
-        <p:txBody>
-          <a:bodyPr vert="horz" wrap="square" lIns="0" tIns="0" rIns="0" bIns="0" rtlCol="0">
-            <a:spAutoFit/>
-          </a:bodyPr>
-          <a:lstStyle/>
-          <a:p>
-            <a:r>
-              <a:rPr lang="en-US" sz="4000" b="1">
-                <a:solidFill>
-                  <a:srgbClr val="FFFFFF"/>
-                </a:solidFill>
-                <a:latin typeface="Cambria" panose="02040503050406030204" pitchFamily="18" charset="0"/>
-              </a:rPr>
-              <a:t>S&amp;P 500 Zero-Shot Forecasting</a:t>
-            </a:r>
-          </a:p>
-        </p:txBody>
-      </p:sp>
-      <p:sp>
-        <p:nvSpPr>
-          <p:cNvPr id="3" name="TextBox 2">
-            <a:extLst>
-              <a:ext uri="{FF2B5EF4-FFF2-40B4-BE49-F238E27FC236}">
-                <a16:creationId xmlns:a16="http://schemas.microsoft.com/office/drawing/2014/main" id="{03E038A7-CA0D-212D-1AE8-66DFF7FCB8D6}"/>
-              </a:ext>
-            </a:extLst>
-          </p:cNvPr>
-          <p:cNvSpPr txBox="1"/>
-          <p:nvPr/>
-        </p:nvSpPr>
-        <p:spPr>
-          <a:xfrm>
-            <a:off x="762000" y="3403600"/>
-            <a:ext cx="10668000" cy="276999"/>
-          </a:xfrm>
-          <a:prstGeom prst="rect">
-            <a:avLst/>
-          </a:prstGeom>
-          <a:noFill/>
-        </p:spPr>
-        <p:txBody>
-          <a:bodyPr vert="horz" wrap="square" lIns="0" tIns="0" rIns="0" bIns="0" rtlCol="0">
-            <a:spAutoFit/>
-          </a:bodyPr>
-          <a:lstStyle/>
-          <a:p>
-            <a:r>
-              <a:rPr lang="en-US">
-                <a:solidFill>
-                  <a:srgbClr val="CADCFC"/>
-                </a:solidFill>
-                <a:latin typeface="Calibri" panose="020F0502020204030204" pitchFamily="34" charset="0"/>
-              </a:rPr>
-              <a:t>Moirai  .  Chronos  .  TimesFM  --  9 Checkpoints, Zero Fine-Tuning</a:t>
-            </a:r>
-          </a:p>
-        </p:txBody>
-      </p:sp>
-      <p:sp>
-        <p:nvSpPr>
-          <p:cNvPr id="4" name="Oval 3">
-            <a:extLst>
-              <a:ext uri="{FF2B5EF4-FFF2-40B4-BE49-F238E27FC236}">
-                <a16:creationId xmlns:a16="http://schemas.microsoft.com/office/drawing/2014/main" id="{FBB61501-C23B-3239-ABE1-4AA8E9B5860B}"/>
+          <p:cNvPr id="2" name="Rectangle 1">
+            <a:extLst>
+              <a:ext uri="{FF2B5EF4-FFF2-40B4-BE49-F238E27FC236}">
+                <a16:creationId xmlns:a16="http://schemas.microsoft.com/office/drawing/2014/main" id="{8E2636C4-E870-A75D-7EEC-CC72785D9138}"/>
               </a:ext>
             </a:extLst>
           </p:cNvPr>
@@ -3440,14 +3360,14 @@
         </p:nvSpPr>
         <p:spPr>
           <a:xfrm>
-            <a:off x="762000" y="4191000"/>
-            <a:ext cx="152400" cy="152400"/>
-          </a:xfrm>
-          <a:prstGeom prst="ellipse">
+            <a:off x="914400" y="1117600"/>
+            <a:ext cx="762000" cy="50800"/>
+          </a:xfrm>
+          <a:prstGeom prst="rect">
             <a:avLst/>
           </a:prstGeom>
           <a:solidFill>
-            <a:srgbClr val="2A78D6"/>
+            <a:srgbClr val="3AAED8"/>
           </a:solidFill>
           <a:ln w="19050" cap="flat" cmpd="sng" algn="ctr">
             <a:noFill/>
@@ -3496,10 +3416,176 @@
       </p:sp>
       <p:sp>
         <p:nvSpPr>
-          <p:cNvPr id="5" name="Oval 4">
-            <a:extLst>
-              <a:ext uri="{FF2B5EF4-FFF2-40B4-BE49-F238E27FC236}">
-                <a16:creationId xmlns:a16="http://schemas.microsoft.com/office/drawing/2014/main" id="{9D40C7C1-1322-07B2-FE4F-99E86CBB402B}"/>
+          <p:cNvPr id="3" name="TextBox 2">
+            <a:extLst>
+              <a:ext uri="{FF2B5EF4-FFF2-40B4-BE49-F238E27FC236}">
+                <a16:creationId xmlns:a16="http://schemas.microsoft.com/office/drawing/2014/main" id="{F80B1018-C69D-23EB-4C69-D773E4CD6F15}"/>
+              </a:ext>
+            </a:extLst>
+          </p:cNvPr>
+          <p:cNvSpPr txBox="1"/>
+          <p:nvPr/>
+        </p:nvSpPr>
+        <p:spPr>
+          <a:xfrm>
+            <a:off x="914400" y="1371600"/>
+            <a:ext cx="10160000" cy="184666"/>
+          </a:xfrm>
+          <a:prstGeom prst="rect">
+            <a:avLst/>
+          </a:prstGeom>
+          <a:noFill/>
+        </p:spPr>
+        <p:txBody>
+          <a:bodyPr vert="horz" wrap="square" lIns="0" tIns="0" rIns="0" bIns="0" rtlCol="0">
+            <a:spAutoFit/>
+          </a:bodyPr>
+          <a:lstStyle/>
+          <a:p>
+            <a:r>
+              <a:rPr lang="en-US" sz="1200" b="1">
+                <a:solidFill>
+                  <a:srgbClr val="7FA0B8"/>
+                </a:solidFill>
+                <a:latin typeface="Calibri" panose="020F0502020204030204" pitchFamily="34" charset="0"/>
+              </a:rPr>
+              <a:t>NUWARE AI   .   INTERNSHIP PROGRAM</a:t>
+            </a:r>
+          </a:p>
+        </p:txBody>
+      </p:sp>
+      <p:sp>
+        <p:nvSpPr>
+          <p:cNvPr id="4" name="TextBox 3">
+            <a:extLst>
+              <a:ext uri="{FF2B5EF4-FFF2-40B4-BE49-F238E27FC236}">
+                <a16:creationId xmlns:a16="http://schemas.microsoft.com/office/drawing/2014/main" id="{D71E2CA3-7884-9A49-6685-82F7CA1CEECC}"/>
+              </a:ext>
+            </a:extLst>
+          </p:cNvPr>
+          <p:cNvSpPr txBox="1"/>
+          <p:nvPr/>
+        </p:nvSpPr>
+        <p:spPr>
+          <a:xfrm>
+            <a:off x="914400" y="1828800"/>
+            <a:ext cx="13335000" cy="553998"/>
+          </a:xfrm>
+          <a:prstGeom prst="rect">
+            <a:avLst/>
+          </a:prstGeom>
+          <a:noFill/>
+        </p:spPr>
+        <p:txBody>
+          <a:bodyPr vert="horz" wrap="square" lIns="0" tIns="0" rIns="0" bIns="0" rtlCol="0">
+            <a:spAutoFit/>
+          </a:bodyPr>
+          <a:lstStyle/>
+          <a:p>
+            <a:r>
+              <a:rPr lang="en-US" sz="3600" b="1">
+                <a:solidFill>
+                  <a:srgbClr val="FFFFFF"/>
+                </a:solidFill>
+                <a:latin typeface="Cambria" panose="02040503050406030204" pitchFamily="18" charset="0"/>
+              </a:rPr>
+              <a:t>S&amp;P 500 Zero-Shot Forecasting</a:t>
+            </a:r>
+          </a:p>
+        </p:txBody>
+      </p:sp>
+      <p:sp>
+        <p:nvSpPr>
+          <p:cNvPr id="5" name="TextBox 4">
+            <a:extLst>
+              <a:ext uri="{FF2B5EF4-FFF2-40B4-BE49-F238E27FC236}">
+                <a16:creationId xmlns:a16="http://schemas.microsoft.com/office/drawing/2014/main" id="{53043193-D6BC-9A1D-4C35-50621147BE87}"/>
+              </a:ext>
+            </a:extLst>
+          </p:cNvPr>
+          <p:cNvSpPr txBox="1"/>
+          <p:nvPr/>
+        </p:nvSpPr>
+        <p:spPr>
+          <a:xfrm>
+            <a:off x="914400" y="2463800"/>
+            <a:ext cx="13335000" cy="553998"/>
+          </a:xfrm>
+          <a:prstGeom prst="rect">
+            <a:avLst/>
+          </a:prstGeom>
+          <a:noFill/>
+        </p:spPr>
+        <p:txBody>
+          <a:bodyPr vert="horz" wrap="square" lIns="0" tIns="0" rIns="0" bIns="0" rtlCol="0">
+            <a:spAutoFit/>
+          </a:bodyPr>
+          <a:lstStyle/>
+          <a:p>
+            <a:r>
+              <a:rPr lang="fr-FR" sz="3600" b="1">
+                <a:solidFill>
+                  <a:srgbClr val="FFFFFF"/>
+                </a:solidFill>
+                <a:latin typeface="Cambria" panose="02040503050406030204" pitchFamily="18" charset="0"/>
+              </a:rPr>
+              <a:t>Moirai vs. Chronos vs. TimesFM</a:t>
+            </a:r>
+            <a:endParaRPr lang="en-US" sz="3600" b="1">
+              <a:solidFill>
+                <a:srgbClr val="FFFFFF"/>
+              </a:solidFill>
+              <a:latin typeface="Cambria" panose="02040503050406030204" pitchFamily="18" charset="0"/>
+            </a:endParaRPr>
+          </a:p>
+        </p:txBody>
+      </p:sp>
+      <p:sp>
+        <p:nvSpPr>
+          <p:cNvPr id="6" name="TextBox 5">
+            <a:extLst>
+              <a:ext uri="{FF2B5EF4-FFF2-40B4-BE49-F238E27FC236}">
+                <a16:creationId xmlns:a16="http://schemas.microsoft.com/office/drawing/2014/main" id="{9B0F3A9C-ADC5-EE1F-8D5E-BD7A11DA53B0}"/>
+              </a:ext>
+            </a:extLst>
+          </p:cNvPr>
+          <p:cNvSpPr txBox="1"/>
+          <p:nvPr/>
+        </p:nvSpPr>
+        <p:spPr>
+          <a:xfrm>
+            <a:off x="914400" y="3225800"/>
+            <a:ext cx="13335000" cy="246221"/>
+          </a:xfrm>
+          <a:prstGeom prst="rect">
+            <a:avLst/>
+          </a:prstGeom>
+          <a:noFill/>
+        </p:spPr>
+        <p:txBody>
+          <a:bodyPr vert="horz" wrap="square" lIns="0" tIns="0" rIns="0" bIns="0" rtlCol="0">
+            <a:spAutoFit/>
+          </a:bodyPr>
+          <a:lstStyle/>
+          <a:p>
+            <a:r>
+              <a:rPr lang="en-US" sz="1600">
+                <a:solidFill>
+                  <a:srgbClr val="7FA0B8"/>
+                </a:solidFill>
+                <a:latin typeface="Calibri" panose="020F0502020204030204" pitchFamily="34" charset="0"/>
+              </a:rPr>
+              <a:t>Nine checkpoints, zero fine-tuning -- a rolling backtest comparison</a:t>
+            </a:r>
+          </a:p>
+        </p:txBody>
+      </p:sp>
+      <p:sp>
+        <p:nvSpPr>
+          <p:cNvPr id="7" name="Rectangle 6">
+            <a:extLst>
+              <a:ext uri="{FF2B5EF4-FFF2-40B4-BE49-F238E27FC236}">
+                <a16:creationId xmlns:a16="http://schemas.microsoft.com/office/drawing/2014/main" id="{1B260C14-F6EF-DEC2-E2DF-28595BB7E283}"/>
               </a:ext>
             </a:extLst>
           </p:cNvPr>
@@ -3508,14 +3594,14 @@
         </p:nvSpPr>
         <p:spPr>
           <a:xfrm>
-            <a:off x="1041400" y="4191000"/>
-            <a:ext cx="152400" cy="152400"/>
-          </a:xfrm>
-          <a:prstGeom prst="ellipse">
+            <a:off x="914400" y="4064000"/>
+            <a:ext cx="2400300" cy="1270000"/>
+          </a:xfrm>
+          <a:prstGeom prst="rect">
             <a:avLst/>
           </a:prstGeom>
           <a:solidFill>
-            <a:srgbClr val="EB6834"/>
+            <a:srgbClr val="1D3E56"/>
           </a:solidFill>
           <a:ln w="19050" cap="flat" cmpd="sng" algn="ctr">
             <a:noFill/>
@@ -3564,10 +3650,90 @@
       </p:sp>
       <p:sp>
         <p:nvSpPr>
-          <p:cNvPr id="6" name="Oval 5">
-            <a:extLst>
-              <a:ext uri="{FF2B5EF4-FFF2-40B4-BE49-F238E27FC236}">
-                <a16:creationId xmlns:a16="http://schemas.microsoft.com/office/drawing/2014/main" id="{D536A835-CF3B-6A00-E62E-5B6CF718D2CF}"/>
+          <p:cNvPr id="8" name="TextBox 7">
+            <a:extLst>
+              <a:ext uri="{FF2B5EF4-FFF2-40B4-BE49-F238E27FC236}">
+                <a16:creationId xmlns:a16="http://schemas.microsoft.com/office/drawing/2014/main" id="{3AFA427B-2991-FD62-C42D-10C4D06E9A85}"/>
+              </a:ext>
+            </a:extLst>
+          </p:cNvPr>
+          <p:cNvSpPr txBox="1"/>
+          <p:nvPr/>
+        </p:nvSpPr>
+        <p:spPr>
+          <a:xfrm>
+            <a:off x="1143000" y="4241800"/>
+            <a:ext cx="1943100" cy="153888"/>
+          </a:xfrm>
+          <a:prstGeom prst="rect">
+            <a:avLst/>
+          </a:prstGeom>
+          <a:noFill/>
+        </p:spPr>
+        <p:txBody>
+          <a:bodyPr vert="horz" wrap="square" lIns="0" tIns="0" rIns="0" bIns="0" rtlCol="0">
+            <a:spAutoFit/>
+          </a:bodyPr>
+          <a:lstStyle/>
+          <a:p>
+            <a:r>
+              <a:rPr lang="en-US" sz="1000" b="1">
+                <a:solidFill>
+                  <a:srgbClr val="5B7D91"/>
+                </a:solidFill>
+                <a:latin typeface="Calibri" panose="020F0502020204030204" pitchFamily="34" charset="0"/>
+              </a:rPr>
+              <a:t>AUTHOR</a:t>
+            </a:r>
+          </a:p>
+        </p:txBody>
+      </p:sp>
+      <p:sp>
+        <p:nvSpPr>
+          <p:cNvPr id="9" name="TextBox 8">
+            <a:extLst>
+              <a:ext uri="{FF2B5EF4-FFF2-40B4-BE49-F238E27FC236}">
+                <a16:creationId xmlns:a16="http://schemas.microsoft.com/office/drawing/2014/main" id="{93630745-E081-24D0-A631-0B159B046CF1}"/>
+              </a:ext>
+            </a:extLst>
+          </p:cNvPr>
+          <p:cNvSpPr txBox="1"/>
+          <p:nvPr/>
+        </p:nvSpPr>
+        <p:spPr>
+          <a:xfrm>
+            <a:off x="1143000" y="4521200"/>
+            <a:ext cx="1943100" cy="200055"/>
+          </a:xfrm>
+          <a:prstGeom prst="rect">
+            <a:avLst/>
+          </a:prstGeom>
+          <a:noFill/>
+        </p:spPr>
+        <p:txBody>
+          <a:bodyPr vert="horz" wrap="square" lIns="0" tIns="0" rIns="0" bIns="0" rtlCol="0">
+            <a:spAutoFit/>
+          </a:bodyPr>
+          <a:lstStyle/>
+          <a:p>
+            <a:r>
+              <a:rPr lang="en-US" sz="1300" b="1">
+                <a:solidFill>
+                  <a:srgbClr val="FFFFFF"/>
+                </a:solidFill>
+                <a:latin typeface="Calibri" panose="020F0502020204030204" pitchFamily="34" charset="0"/>
+              </a:rPr>
+              <a:t>Agrim Gupta</a:t>
+            </a:r>
+          </a:p>
+        </p:txBody>
+      </p:sp>
+      <p:sp>
+        <p:nvSpPr>
+          <p:cNvPr id="10" name="Rectangle 9">
+            <a:extLst>
+              <a:ext uri="{FF2B5EF4-FFF2-40B4-BE49-F238E27FC236}">
+                <a16:creationId xmlns:a16="http://schemas.microsoft.com/office/drawing/2014/main" id="{1908AFF9-F360-53D6-BA13-31C291266F5D}"/>
               </a:ext>
             </a:extLst>
           </p:cNvPr>
@@ -3576,14 +3742,14 @@
         </p:nvSpPr>
         <p:spPr>
           <a:xfrm>
-            <a:off x="1320800" y="4191000"/>
-            <a:ext cx="152400" cy="152400"/>
-          </a:xfrm>
-          <a:prstGeom prst="ellipse">
+            <a:off x="3568700" y="4064000"/>
+            <a:ext cx="2400300" cy="1270000"/>
+          </a:xfrm>
+          <a:prstGeom prst="rect">
             <a:avLst/>
           </a:prstGeom>
           <a:solidFill>
-            <a:srgbClr val="1BAF7A"/>
+            <a:srgbClr val="1D3E56"/>
           </a:solidFill>
           <a:ln w="19050" cap="flat" cmpd="sng" algn="ctr">
             <a:noFill/>
@@ -3632,10 +3798,10 @@
       </p:sp>
       <p:sp>
         <p:nvSpPr>
-          <p:cNvPr id="7" name="TextBox 6">
-            <a:extLst>
-              <a:ext uri="{FF2B5EF4-FFF2-40B4-BE49-F238E27FC236}">
-                <a16:creationId xmlns:a16="http://schemas.microsoft.com/office/drawing/2014/main" id="{F52BA7FE-839C-0C4D-4D51-33C8AD71B5FC}"/>
+          <p:cNvPr id="11" name="TextBox 10">
+            <a:extLst>
+              <a:ext uri="{FF2B5EF4-FFF2-40B4-BE49-F238E27FC236}">
+                <a16:creationId xmlns:a16="http://schemas.microsoft.com/office/drawing/2014/main" id="{FDA19E4A-6432-66A2-9A17-00ED6C346614}"/>
               </a:ext>
             </a:extLst>
           </p:cNvPr>
@@ -3644,8 +3810,8 @@
         </p:nvSpPr>
         <p:spPr>
           <a:xfrm>
-            <a:off x="762000" y="5080000"/>
-            <a:ext cx="10668000" cy="200055"/>
+            <a:off x="3797300" y="4241800"/>
+            <a:ext cx="1943100" cy="153888"/>
           </a:xfrm>
           <a:prstGeom prst="rect">
             <a:avLst/>
@@ -3659,13 +3825,390 @@
           <a:lstStyle/>
           <a:p>
             <a:r>
-              <a:rPr lang="en-US" sz="1300" i="1">
-                <a:solidFill>
-                  <a:srgbClr val="CADCFC"/>
+              <a:rPr lang="en-US" sz="1000" b="1">
+                <a:solidFill>
+                  <a:srgbClr val="5B7D91"/>
                 </a:solidFill>
                 <a:latin typeface="Calibri" panose="020F0502020204030204" pitchFamily="34" charset="0"/>
               </a:rPr>
-              <a:t>Rolling backtest, 2005 to present   |   MASE . sMAPE . WQL</a:t>
+              <a:t>MENTOR</a:t>
+            </a:r>
+          </a:p>
+        </p:txBody>
+      </p:sp>
+      <p:sp>
+        <p:nvSpPr>
+          <p:cNvPr id="12" name="TextBox 11">
+            <a:extLst>
+              <a:ext uri="{FF2B5EF4-FFF2-40B4-BE49-F238E27FC236}">
+                <a16:creationId xmlns:a16="http://schemas.microsoft.com/office/drawing/2014/main" id="{6118F75D-C124-D4D6-4EC0-A12B3E5A93DC}"/>
+              </a:ext>
+            </a:extLst>
+          </p:cNvPr>
+          <p:cNvSpPr txBox="1"/>
+          <p:nvPr/>
+        </p:nvSpPr>
+        <p:spPr>
+          <a:xfrm>
+            <a:off x="3797300" y="4521200"/>
+            <a:ext cx="1943100" cy="400110"/>
+          </a:xfrm>
+          <a:prstGeom prst="rect">
+            <a:avLst/>
+          </a:prstGeom>
+          <a:noFill/>
+        </p:spPr>
+        <p:txBody>
+          <a:bodyPr vert="horz" wrap="square" lIns="0" tIns="0" rIns="0" bIns="0" rtlCol="0">
+            <a:spAutoFit/>
+          </a:bodyPr>
+          <a:lstStyle/>
+          <a:p>
+            <a:r>
+              <a:rPr lang="en-US" sz="1300" b="1">
+                <a:solidFill>
+                  <a:srgbClr val="FFFFFF"/>
+                </a:solidFill>
+                <a:latin typeface="Calibri" panose="020F0502020204030204" pitchFamily="34" charset="0"/>
+              </a:rPr>
+              <a:t>Sushant Khuntegave
+Shivanshu Garg</a:t>
+            </a:r>
+          </a:p>
+        </p:txBody>
+      </p:sp>
+      <p:sp>
+        <p:nvSpPr>
+          <p:cNvPr id="13" name="Rectangle 12">
+            <a:extLst>
+              <a:ext uri="{FF2B5EF4-FFF2-40B4-BE49-F238E27FC236}">
+                <a16:creationId xmlns:a16="http://schemas.microsoft.com/office/drawing/2014/main" id="{4BDB4E57-FF75-79F9-8EE2-49E7A0C0C6E7}"/>
+              </a:ext>
+            </a:extLst>
+          </p:cNvPr>
+          <p:cNvSpPr/>
+          <p:nvPr/>
+        </p:nvSpPr>
+        <p:spPr>
+          <a:xfrm>
+            <a:off x="6223000" y="4064000"/>
+            <a:ext cx="2400300" cy="1270000"/>
+          </a:xfrm>
+          <a:prstGeom prst="rect">
+            <a:avLst/>
+          </a:prstGeom>
+          <a:solidFill>
+            <a:srgbClr val="1D3E56"/>
+          </a:solidFill>
+          <a:ln w="19050" cap="flat" cmpd="sng" algn="ctr">
+            <a:noFill/>
+            <a:prstDash val="solid"/>
+            <a:miter lim="800000"/>
+          </a:ln>
+          <a:effectLst/>
+          <a:extLst>
+            <a:ext uri="{91240B29-F687-4F45-9708-019B960494DF}">
+              <a14:hiddenLine xmlns:a14="http://schemas.microsoft.com/office/drawing/2010/main" w="19050" cap="flat" cmpd="sng" algn="ctr">
+                <a:solidFill>
+                  <a:schemeClr val="accent1">
+                    <a:shade val="15000"/>
+                  </a:schemeClr>
+                </a:solidFill>
+                <a:prstDash val="solid"/>
+                <a:miter lim="800000"/>
+              </a14:hiddenLine>
+            </a:ext>
+          </a:extLst>
+        </p:spPr>
+        <p:style>
+          <a:lnRef idx="2">
+            <a:schemeClr val="accent1">
+              <a:shade val="15000"/>
+            </a:schemeClr>
+          </a:lnRef>
+          <a:fillRef idx="1">
+            <a:schemeClr val="accent1"/>
+          </a:fillRef>
+          <a:effectRef idx="0">
+            <a:schemeClr val="accent1"/>
+          </a:effectRef>
+          <a:fontRef idx="minor">
+            <a:schemeClr val="lt1"/>
+          </a:fontRef>
+        </p:style>
+        <p:txBody>
+          <a:bodyPr rtlCol="0" anchor="ctr"/>
+          <a:lstStyle/>
+          <a:p>
+            <a:pPr algn="ctr"/>
+            <a:endParaRPr lang="en-US"/>
+          </a:p>
+        </p:txBody>
+      </p:sp>
+      <p:sp>
+        <p:nvSpPr>
+          <p:cNvPr id="14" name="TextBox 13">
+            <a:extLst>
+              <a:ext uri="{FF2B5EF4-FFF2-40B4-BE49-F238E27FC236}">
+                <a16:creationId xmlns:a16="http://schemas.microsoft.com/office/drawing/2014/main" id="{CEEA0D23-FF8E-F1AA-0F6E-040069579A2E}"/>
+              </a:ext>
+            </a:extLst>
+          </p:cNvPr>
+          <p:cNvSpPr txBox="1"/>
+          <p:nvPr/>
+        </p:nvSpPr>
+        <p:spPr>
+          <a:xfrm>
+            <a:off x="6451600" y="4241800"/>
+            <a:ext cx="1943100" cy="153888"/>
+          </a:xfrm>
+          <a:prstGeom prst="rect">
+            <a:avLst/>
+          </a:prstGeom>
+          <a:noFill/>
+        </p:spPr>
+        <p:txBody>
+          <a:bodyPr vert="horz" wrap="square" lIns="0" tIns="0" rIns="0" bIns="0" rtlCol="0">
+            <a:spAutoFit/>
+          </a:bodyPr>
+          <a:lstStyle/>
+          <a:p>
+            <a:r>
+              <a:rPr lang="en-US" sz="1000" b="1">
+                <a:solidFill>
+                  <a:srgbClr val="5B7D91"/>
+                </a:solidFill>
+                <a:latin typeface="Calibri" panose="020F0502020204030204" pitchFamily="34" charset="0"/>
+              </a:rPr>
+              <a:t>TOPIC</a:t>
+            </a:r>
+          </a:p>
+        </p:txBody>
+      </p:sp>
+      <p:sp>
+        <p:nvSpPr>
+          <p:cNvPr id="15" name="TextBox 14">
+            <a:extLst>
+              <a:ext uri="{FF2B5EF4-FFF2-40B4-BE49-F238E27FC236}">
+                <a16:creationId xmlns:a16="http://schemas.microsoft.com/office/drawing/2014/main" id="{93F8E7B4-1913-A559-538B-F0107A483B43}"/>
+              </a:ext>
+            </a:extLst>
+          </p:cNvPr>
+          <p:cNvSpPr txBox="1"/>
+          <p:nvPr/>
+        </p:nvSpPr>
+        <p:spPr>
+          <a:xfrm>
+            <a:off x="6451600" y="4521200"/>
+            <a:ext cx="1943100" cy="200055"/>
+          </a:xfrm>
+          <a:prstGeom prst="rect">
+            <a:avLst/>
+          </a:prstGeom>
+          <a:noFill/>
+        </p:spPr>
+        <p:txBody>
+          <a:bodyPr vert="horz" wrap="square" lIns="0" tIns="0" rIns="0" bIns="0" rtlCol="0">
+            <a:spAutoFit/>
+          </a:bodyPr>
+          <a:lstStyle/>
+          <a:p>
+            <a:r>
+              <a:rPr lang="en-US" sz="1300" b="1">
+                <a:solidFill>
+                  <a:srgbClr val="FFFFFF"/>
+                </a:solidFill>
+                <a:latin typeface="Calibri" panose="020F0502020204030204" pitchFamily="34" charset="0"/>
+              </a:rPr>
+              <a:t>Moirai . Chronos . TimesFM</a:t>
+            </a:r>
+          </a:p>
+        </p:txBody>
+      </p:sp>
+      <p:sp>
+        <p:nvSpPr>
+          <p:cNvPr id="16" name="Rectangle 15">
+            <a:extLst>
+              <a:ext uri="{FF2B5EF4-FFF2-40B4-BE49-F238E27FC236}">
+                <a16:creationId xmlns:a16="http://schemas.microsoft.com/office/drawing/2014/main" id="{FA9631F1-8D8D-6218-F817-90A6A249714D}"/>
+              </a:ext>
+            </a:extLst>
+          </p:cNvPr>
+          <p:cNvSpPr/>
+          <p:nvPr/>
+        </p:nvSpPr>
+        <p:spPr>
+          <a:xfrm>
+            <a:off x="8877300" y="4064000"/>
+            <a:ext cx="2400300" cy="1270000"/>
+          </a:xfrm>
+          <a:prstGeom prst="rect">
+            <a:avLst/>
+          </a:prstGeom>
+          <a:solidFill>
+            <a:srgbClr val="1D3E56"/>
+          </a:solidFill>
+          <a:ln w="19050" cap="flat" cmpd="sng" algn="ctr">
+            <a:noFill/>
+            <a:prstDash val="solid"/>
+            <a:miter lim="800000"/>
+          </a:ln>
+          <a:effectLst/>
+          <a:extLst>
+            <a:ext uri="{91240B29-F687-4F45-9708-019B960494DF}">
+              <a14:hiddenLine xmlns:a14="http://schemas.microsoft.com/office/drawing/2010/main" w="19050" cap="flat" cmpd="sng" algn="ctr">
+                <a:solidFill>
+                  <a:schemeClr val="accent1">
+                    <a:shade val="15000"/>
+                  </a:schemeClr>
+                </a:solidFill>
+                <a:prstDash val="solid"/>
+                <a:miter lim="800000"/>
+              </a14:hiddenLine>
+            </a:ext>
+          </a:extLst>
+        </p:spPr>
+        <p:style>
+          <a:lnRef idx="2">
+            <a:schemeClr val="accent1">
+              <a:shade val="15000"/>
+            </a:schemeClr>
+          </a:lnRef>
+          <a:fillRef idx="1">
+            <a:schemeClr val="accent1"/>
+          </a:fillRef>
+          <a:effectRef idx="0">
+            <a:schemeClr val="accent1"/>
+          </a:effectRef>
+          <a:fontRef idx="minor">
+            <a:schemeClr val="lt1"/>
+          </a:fontRef>
+        </p:style>
+        <p:txBody>
+          <a:bodyPr rtlCol="0" anchor="ctr"/>
+          <a:lstStyle/>
+          <a:p>
+            <a:pPr algn="ctr"/>
+            <a:endParaRPr lang="en-US"/>
+          </a:p>
+        </p:txBody>
+      </p:sp>
+      <p:sp>
+        <p:nvSpPr>
+          <p:cNvPr id="17" name="TextBox 16">
+            <a:extLst>
+              <a:ext uri="{FF2B5EF4-FFF2-40B4-BE49-F238E27FC236}">
+                <a16:creationId xmlns:a16="http://schemas.microsoft.com/office/drawing/2014/main" id="{8F0759EB-E081-371D-8AC8-5D9912D5ED20}"/>
+              </a:ext>
+            </a:extLst>
+          </p:cNvPr>
+          <p:cNvSpPr txBox="1"/>
+          <p:nvPr/>
+        </p:nvSpPr>
+        <p:spPr>
+          <a:xfrm>
+            <a:off x="9105900" y="4241800"/>
+            <a:ext cx="1943100" cy="153888"/>
+          </a:xfrm>
+          <a:prstGeom prst="rect">
+            <a:avLst/>
+          </a:prstGeom>
+          <a:noFill/>
+        </p:spPr>
+        <p:txBody>
+          <a:bodyPr vert="horz" wrap="square" lIns="0" tIns="0" rIns="0" bIns="0" rtlCol="0">
+            <a:spAutoFit/>
+          </a:bodyPr>
+          <a:lstStyle/>
+          <a:p>
+            <a:r>
+              <a:rPr lang="en-US" sz="1000" b="1">
+                <a:solidFill>
+                  <a:srgbClr val="5B7D91"/>
+                </a:solidFill>
+                <a:latin typeface="Calibri" panose="020F0502020204030204" pitchFamily="34" charset="0"/>
+              </a:rPr>
+              <a:t>DATE</a:t>
+            </a:r>
+          </a:p>
+        </p:txBody>
+      </p:sp>
+      <p:sp>
+        <p:nvSpPr>
+          <p:cNvPr id="18" name="TextBox 17">
+            <a:extLst>
+              <a:ext uri="{FF2B5EF4-FFF2-40B4-BE49-F238E27FC236}">
+                <a16:creationId xmlns:a16="http://schemas.microsoft.com/office/drawing/2014/main" id="{AA37012A-702A-08D3-CCB8-FE4E39B3B730}"/>
+              </a:ext>
+            </a:extLst>
+          </p:cNvPr>
+          <p:cNvSpPr txBox="1"/>
+          <p:nvPr/>
+        </p:nvSpPr>
+        <p:spPr>
+          <a:xfrm>
+            <a:off x="9105900" y="4521200"/>
+            <a:ext cx="1943100" cy="200055"/>
+          </a:xfrm>
+          <a:prstGeom prst="rect">
+            <a:avLst/>
+          </a:prstGeom>
+          <a:noFill/>
+        </p:spPr>
+        <p:txBody>
+          <a:bodyPr vert="horz" wrap="square" lIns="0" tIns="0" rIns="0" bIns="0" rtlCol="0">
+            <a:spAutoFit/>
+          </a:bodyPr>
+          <a:lstStyle/>
+          <a:p>
+            <a:r>
+              <a:rPr lang="en-US" sz="1300" b="1">
+                <a:solidFill>
+                  <a:srgbClr val="FFFFFF"/>
+                </a:solidFill>
+                <a:latin typeface="Calibri" panose="020F0502020204030204" pitchFamily="34" charset="0"/>
+              </a:rPr>
+              <a:t>12th August 2026</a:t>
+            </a:r>
+          </a:p>
+        </p:txBody>
+      </p:sp>
+      <p:sp>
+        <p:nvSpPr>
+          <p:cNvPr id="19" name="TextBox 18">
+            <a:extLst>
+              <a:ext uri="{FF2B5EF4-FFF2-40B4-BE49-F238E27FC236}">
+                <a16:creationId xmlns:a16="http://schemas.microsoft.com/office/drawing/2014/main" id="{BD92BBE2-3C91-9A5C-D638-E60EA7EC84CF}"/>
+              </a:ext>
+            </a:extLst>
+          </p:cNvPr>
+          <p:cNvSpPr txBox="1"/>
+          <p:nvPr/>
+        </p:nvSpPr>
+        <p:spPr>
+          <a:xfrm>
+            <a:off x="914400" y="5511800"/>
+            <a:ext cx="13335000" cy="169277"/>
+          </a:xfrm>
+          <a:prstGeom prst="rect">
+            <a:avLst/>
+          </a:prstGeom>
+          <a:noFill/>
+        </p:spPr>
+        <p:txBody>
+          <a:bodyPr vert="horz" wrap="square" lIns="0" tIns="0" rIns="0" bIns="0" rtlCol="0">
+            <a:spAutoFit/>
+          </a:bodyPr>
+          <a:lstStyle/>
+          <a:p>
+            <a:r>
+              <a:rPr lang="en-US" sz="1100" i="1">
+                <a:solidFill>
+                  <a:srgbClr val="5B7D91"/>
+                </a:solidFill>
+                <a:latin typeface="Calibri" panose="020F0502020204030204" pitchFamily="34" charset="0"/>
+              </a:rPr>
+              <a:t>yfinance   .   Salesforce/uni2ts   .   amazon-science/chronos-forecasting   .   google-research/timesfm</a:t>
             </a:r>
           </a:p>
         </p:txBody>
@@ -3673,7 +4216,7 @@
     </p:spTree>
     <p:extLst>
       <p:ext uri="{BB962C8B-B14F-4D97-AF65-F5344CB8AC3E}">
-        <p14:creationId xmlns:p14="http://schemas.microsoft.com/office/powerpoint/2010/main" val="3403295478"/>
+        <p14:creationId xmlns:p14="http://schemas.microsoft.com/office/powerpoint/2010/main" val="3936920908"/>
       </p:ext>
     </p:extLst>
   </p:cSld>
@@ -3713,7 +4256,7 @@
           <p:cNvPr id="2" name="Oval 1">
             <a:extLst>
               <a:ext uri="{FF2B5EF4-FFF2-40B4-BE49-F238E27FC236}">
-                <a16:creationId xmlns:a16="http://schemas.microsoft.com/office/drawing/2014/main" id="{C3B8F80E-8921-F440-CA9F-972307193D14}"/>
+                <a16:creationId xmlns:a16="http://schemas.microsoft.com/office/drawing/2014/main" id="{A144F4BD-7519-3132-B4FA-5350A60B7243}"/>
               </a:ext>
             </a:extLst>
           </p:cNvPr>
@@ -3781,7 +4324,7 @@
           <p:cNvPr id="3" name="TextBox 2">
             <a:extLst>
               <a:ext uri="{FF2B5EF4-FFF2-40B4-BE49-F238E27FC236}">
-                <a16:creationId xmlns:a16="http://schemas.microsoft.com/office/drawing/2014/main" id="{014D0316-CAD8-C01B-3D30-15EDFD0AEFD3}"/>
+                <a16:creationId xmlns:a16="http://schemas.microsoft.com/office/drawing/2014/main" id="{85736F30-C5A5-789A-E6CC-D67875DBBB13}"/>
               </a:ext>
             </a:extLst>
           </p:cNvPr>
@@ -3821,7 +4364,7 @@
           <p:cNvPr id="5" name="Picture 4">
             <a:extLst>
               <a:ext uri="{FF2B5EF4-FFF2-40B4-BE49-F238E27FC236}">
-                <a16:creationId xmlns:a16="http://schemas.microsoft.com/office/drawing/2014/main" id="{190D3AB7-4163-0AE6-BAF0-1D41D6398A5F}"/>
+                <a16:creationId xmlns:a16="http://schemas.microsoft.com/office/drawing/2014/main" id="{69897B0D-11A4-B82D-FC27-485B0B5572B1}"/>
               </a:ext>
             </a:extLst>
           </p:cNvPr>
@@ -3857,7 +4400,7 @@
           <p:cNvPr id="6" name="TextBox 5">
             <a:extLst>
               <a:ext uri="{FF2B5EF4-FFF2-40B4-BE49-F238E27FC236}">
-                <a16:creationId xmlns:a16="http://schemas.microsoft.com/office/drawing/2014/main" id="{3BEE08E5-0C50-604C-0644-88D538072E94}"/>
+                <a16:creationId xmlns:a16="http://schemas.microsoft.com/office/drawing/2014/main" id="{5363CCD1-2681-9A9C-B04B-B6614363D839}"/>
               </a:ext>
             </a:extLst>
           </p:cNvPr>
@@ -3896,7 +4439,7 @@
     </p:spTree>
     <p:extLst>
       <p:ext uri="{BB962C8B-B14F-4D97-AF65-F5344CB8AC3E}">
-        <p14:creationId xmlns:p14="http://schemas.microsoft.com/office/powerpoint/2010/main" val="2364321975"/>
+        <p14:creationId xmlns:p14="http://schemas.microsoft.com/office/powerpoint/2010/main" val="1058182210"/>
       </p:ext>
     </p:extLst>
   </p:cSld>
@@ -3936,7 +4479,7 @@
           <p:cNvPr id="2" name="Oval 1">
             <a:extLst>
               <a:ext uri="{FF2B5EF4-FFF2-40B4-BE49-F238E27FC236}">
-                <a16:creationId xmlns:a16="http://schemas.microsoft.com/office/drawing/2014/main" id="{F5BEAB52-17A9-524F-3065-4CC7D633A94E}"/>
+                <a16:creationId xmlns:a16="http://schemas.microsoft.com/office/drawing/2014/main" id="{BBDF4AAF-C99F-A8F9-1C6F-91810F4760B9}"/>
               </a:ext>
             </a:extLst>
           </p:cNvPr>
@@ -4004,7 +4547,7 @@
           <p:cNvPr id="3" name="TextBox 2">
             <a:extLst>
               <a:ext uri="{FF2B5EF4-FFF2-40B4-BE49-F238E27FC236}">
-                <a16:creationId xmlns:a16="http://schemas.microsoft.com/office/drawing/2014/main" id="{4FCD1F26-7D3E-0432-5992-CD6D515F3E39}"/>
+                <a16:creationId xmlns:a16="http://schemas.microsoft.com/office/drawing/2014/main" id="{5AFE0C96-996C-396E-8C48-35BBFA155AE2}"/>
               </a:ext>
             </a:extLst>
           </p:cNvPr>
@@ -4044,7 +4587,7 @@
           <p:cNvPr id="5" name="Picture 4">
             <a:extLst>
               <a:ext uri="{FF2B5EF4-FFF2-40B4-BE49-F238E27FC236}">
-                <a16:creationId xmlns:a16="http://schemas.microsoft.com/office/drawing/2014/main" id="{61F3CB12-772D-F662-0EC0-CD7F399E461B}"/>
+                <a16:creationId xmlns:a16="http://schemas.microsoft.com/office/drawing/2014/main" id="{550A7CB7-03BF-9827-5C94-2DBC9CB4A9DB}"/>
               </a:ext>
             </a:extLst>
           </p:cNvPr>
@@ -4080,7 +4623,7 @@
           <p:cNvPr id="6" name="TextBox 5">
             <a:extLst>
               <a:ext uri="{FF2B5EF4-FFF2-40B4-BE49-F238E27FC236}">
-                <a16:creationId xmlns:a16="http://schemas.microsoft.com/office/drawing/2014/main" id="{E57F6935-4010-F214-47E0-62A3FEE43375}"/>
+                <a16:creationId xmlns:a16="http://schemas.microsoft.com/office/drawing/2014/main" id="{3666D0C2-76C4-0A5F-FDBF-40697365898B}"/>
               </a:ext>
             </a:extLst>
           </p:cNvPr>
@@ -4119,7 +4662,7 @@
     </p:spTree>
     <p:extLst>
       <p:ext uri="{BB962C8B-B14F-4D97-AF65-F5344CB8AC3E}">
-        <p14:creationId xmlns:p14="http://schemas.microsoft.com/office/powerpoint/2010/main" val="266876575"/>
+        <p14:creationId xmlns:p14="http://schemas.microsoft.com/office/powerpoint/2010/main" val="4167108953"/>
       </p:ext>
     </p:extLst>
   </p:cSld>
@@ -4159,7 +4702,7 @@
           <p:cNvPr id="2" name="Oval 1">
             <a:extLst>
               <a:ext uri="{FF2B5EF4-FFF2-40B4-BE49-F238E27FC236}">
-                <a16:creationId xmlns:a16="http://schemas.microsoft.com/office/drawing/2014/main" id="{DE83A506-94D6-BDB7-D08E-122603C51430}"/>
+                <a16:creationId xmlns:a16="http://schemas.microsoft.com/office/drawing/2014/main" id="{24D05124-3CDD-40FC-5854-39CDD629605D}"/>
               </a:ext>
             </a:extLst>
           </p:cNvPr>
@@ -4227,7 +4770,7 @@
           <p:cNvPr id="3" name="TextBox 2">
             <a:extLst>
               <a:ext uri="{FF2B5EF4-FFF2-40B4-BE49-F238E27FC236}">
-                <a16:creationId xmlns:a16="http://schemas.microsoft.com/office/drawing/2014/main" id="{F427F20A-F2B6-D5A6-4F39-DD3CD6CB420E}"/>
+                <a16:creationId xmlns:a16="http://schemas.microsoft.com/office/drawing/2014/main" id="{66A0257B-B674-51A7-CB17-173CB6B7806E}"/>
               </a:ext>
             </a:extLst>
           </p:cNvPr>
@@ -4267,7 +4810,7 @@
           <p:cNvPr id="5" name="Picture 4">
             <a:extLst>
               <a:ext uri="{FF2B5EF4-FFF2-40B4-BE49-F238E27FC236}">
-                <a16:creationId xmlns:a16="http://schemas.microsoft.com/office/drawing/2014/main" id="{94EF9B30-20FC-0F0E-C5CA-5BAFF4AA8583}"/>
+                <a16:creationId xmlns:a16="http://schemas.microsoft.com/office/drawing/2014/main" id="{E2B2720D-4BA1-8896-1461-BA2831B3B9A7}"/>
               </a:ext>
             </a:extLst>
           </p:cNvPr>
@@ -4303,7 +4846,7 @@
           <p:cNvPr id="6" name="TextBox 5">
             <a:extLst>
               <a:ext uri="{FF2B5EF4-FFF2-40B4-BE49-F238E27FC236}">
-                <a16:creationId xmlns:a16="http://schemas.microsoft.com/office/drawing/2014/main" id="{74BC5091-C004-6E0B-82DF-E89E650C36F3}"/>
+                <a16:creationId xmlns:a16="http://schemas.microsoft.com/office/drawing/2014/main" id="{D43F0880-564F-5FAB-7A2C-9C26654276F9}"/>
               </a:ext>
             </a:extLst>
           </p:cNvPr>
@@ -4342,7 +4885,7 @@
     </p:spTree>
     <p:extLst>
       <p:ext uri="{BB962C8B-B14F-4D97-AF65-F5344CB8AC3E}">
-        <p14:creationId xmlns:p14="http://schemas.microsoft.com/office/powerpoint/2010/main" val="2480056757"/>
+        <p14:creationId xmlns:p14="http://schemas.microsoft.com/office/powerpoint/2010/main" val="4253319724"/>
       </p:ext>
     </p:extLst>
   </p:cSld>
@@ -4382,7 +4925,7 @@
           <p:cNvPr id="2" name="Oval 1">
             <a:extLst>
               <a:ext uri="{FF2B5EF4-FFF2-40B4-BE49-F238E27FC236}">
-                <a16:creationId xmlns:a16="http://schemas.microsoft.com/office/drawing/2014/main" id="{21A46EC0-BB0B-7466-F898-F183C636AC29}"/>
+                <a16:creationId xmlns:a16="http://schemas.microsoft.com/office/drawing/2014/main" id="{AE67AE81-44A2-52D6-F65C-13EEC395311A}"/>
               </a:ext>
             </a:extLst>
           </p:cNvPr>
@@ -4450,7 +4993,7 @@
           <p:cNvPr id="3" name="TextBox 2">
             <a:extLst>
               <a:ext uri="{FF2B5EF4-FFF2-40B4-BE49-F238E27FC236}">
-                <a16:creationId xmlns:a16="http://schemas.microsoft.com/office/drawing/2014/main" id="{5185CD5B-504E-D956-E4E6-8C419245013C}"/>
+                <a16:creationId xmlns:a16="http://schemas.microsoft.com/office/drawing/2014/main" id="{64B54FEB-943A-B4FE-79FF-D2409138DF03}"/>
               </a:ext>
             </a:extLst>
           </p:cNvPr>
@@ -4490,7 +5033,7 @@
           <p:cNvPr id="5" name="Picture 4">
             <a:extLst>
               <a:ext uri="{FF2B5EF4-FFF2-40B4-BE49-F238E27FC236}">
-                <a16:creationId xmlns:a16="http://schemas.microsoft.com/office/drawing/2014/main" id="{279C7D14-BBAE-E45B-E9DD-95CEEC7B0B8C}"/>
+                <a16:creationId xmlns:a16="http://schemas.microsoft.com/office/drawing/2014/main" id="{23DBE2E7-77A0-7BC3-9A33-D33CA8BB75C7}"/>
               </a:ext>
             </a:extLst>
           </p:cNvPr>
@@ -4526,7 +5069,7 @@
           <p:cNvPr id="6" name="TextBox 5">
             <a:extLst>
               <a:ext uri="{FF2B5EF4-FFF2-40B4-BE49-F238E27FC236}">
-                <a16:creationId xmlns:a16="http://schemas.microsoft.com/office/drawing/2014/main" id="{1013A97C-625D-8B83-3FE9-952C4C9BD916}"/>
+                <a16:creationId xmlns:a16="http://schemas.microsoft.com/office/drawing/2014/main" id="{AFF2E0D2-4158-73FD-0A97-F1C0A51B23C3}"/>
               </a:ext>
             </a:extLst>
           </p:cNvPr>
@@ -4565,7 +5108,7 @@
     </p:spTree>
     <p:extLst>
       <p:ext uri="{BB962C8B-B14F-4D97-AF65-F5344CB8AC3E}">
-        <p14:creationId xmlns:p14="http://schemas.microsoft.com/office/powerpoint/2010/main" val="4034592212"/>
+        <p14:creationId xmlns:p14="http://schemas.microsoft.com/office/powerpoint/2010/main" val="829572064"/>
       </p:ext>
     </p:extLst>
   </p:cSld>
@@ -4605,7 +5148,7 @@
           <p:cNvPr id="2" name="Oval 1">
             <a:extLst>
               <a:ext uri="{FF2B5EF4-FFF2-40B4-BE49-F238E27FC236}">
-                <a16:creationId xmlns:a16="http://schemas.microsoft.com/office/drawing/2014/main" id="{57CD7A2F-6DD9-8207-6C4F-A8A1B8B83AAD}"/>
+                <a16:creationId xmlns:a16="http://schemas.microsoft.com/office/drawing/2014/main" id="{085E98CB-10FA-0922-D727-5469460589FF}"/>
               </a:ext>
             </a:extLst>
           </p:cNvPr>
@@ -4673,7 +5216,7 @@
           <p:cNvPr id="3" name="TextBox 2">
             <a:extLst>
               <a:ext uri="{FF2B5EF4-FFF2-40B4-BE49-F238E27FC236}">
-                <a16:creationId xmlns:a16="http://schemas.microsoft.com/office/drawing/2014/main" id="{AC05896E-D151-1664-E4C6-59ABC554B567}"/>
+                <a16:creationId xmlns:a16="http://schemas.microsoft.com/office/drawing/2014/main" id="{444C5E8D-8A48-B9AE-A5A8-F7283D698751}"/>
               </a:ext>
             </a:extLst>
           </p:cNvPr>
@@ -4713,7 +5256,7 @@
           <p:cNvPr id="5" name="Picture 4">
             <a:extLst>
               <a:ext uri="{FF2B5EF4-FFF2-40B4-BE49-F238E27FC236}">
-                <a16:creationId xmlns:a16="http://schemas.microsoft.com/office/drawing/2014/main" id="{93D20390-B523-FA40-65BC-9C122B50E8FE}"/>
+                <a16:creationId xmlns:a16="http://schemas.microsoft.com/office/drawing/2014/main" id="{6B0E8761-151F-B4E2-1124-0693604FE9A8}"/>
               </a:ext>
             </a:extLst>
           </p:cNvPr>
@@ -4749,7 +5292,7 @@
           <p:cNvPr id="6" name="TextBox 5">
             <a:extLst>
               <a:ext uri="{FF2B5EF4-FFF2-40B4-BE49-F238E27FC236}">
-                <a16:creationId xmlns:a16="http://schemas.microsoft.com/office/drawing/2014/main" id="{F654A22E-8FE6-7211-5367-C307B0BFD32F}"/>
+                <a16:creationId xmlns:a16="http://schemas.microsoft.com/office/drawing/2014/main" id="{A17D0AD3-D86F-852F-5C49-7A973E57BC7E}"/>
               </a:ext>
             </a:extLst>
           </p:cNvPr>
@@ -4788,7 +5331,7 @@
     </p:spTree>
     <p:extLst>
       <p:ext uri="{BB962C8B-B14F-4D97-AF65-F5344CB8AC3E}">
-        <p14:creationId xmlns:p14="http://schemas.microsoft.com/office/powerpoint/2010/main" val="1819416951"/>
+        <p14:creationId xmlns:p14="http://schemas.microsoft.com/office/powerpoint/2010/main" val="817821568"/>
       </p:ext>
     </p:extLst>
   </p:cSld>
@@ -4828,7 +5371,7 @@
           <p:cNvPr id="2" name="TextBox 1">
             <a:extLst>
               <a:ext uri="{FF2B5EF4-FFF2-40B4-BE49-F238E27FC236}">
-                <a16:creationId xmlns:a16="http://schemas.microsoft.com/office/drawing/2014/main" id="{9682F5CB-0E0D-B746-9E36-3A2E528710E0}"/>
+                <a16:creationId xmlns:a16="http://schemas.microsoft.com/office/drawing/2014/main" id="{6683BCCE-2853-827E-93FA-08A7B3FFBA2F}"/>
               </a:ext>
             </a:extLst>
           </p:cNvPr>
@@ -4868,7 +5411,7 @@
           <p:cNvPr id="4" name="Picture 3">
             <a:extLst>
               <a:ext uri="{FF2B5EF4-FFF2-40B4-BE49-F238E27FC236}">
-                <a16:creationId xmlns:a16="http://schemas.microsoft.com/office/drawing/2014/main" id="{061B81E8-7448-2CFD-FE71-B7F296A2B7DA}"/>
+                <a16:creationId xmlns:a16="http://schemas.microsoft.com/office/drawing/2014/main" id="{DC0543BB-DE28-5C98-3865-B06783F9BDAD}"/>
               </a:ext>
             </a:extLst>
           </p:cNvPr>
@@ -4904,7 +5447,7 @@
           <p:cNvPr id="5" name="TextBox 4">
             <a:extLst>
               <a:ext uri="{FF2B5EF4-FFF2-40B4-BE49-F238E27FC236}">
-                <a16:creationId xmlns:a16="http://schemas.microsoft.com/office/drawing/2014/main" id="{7B3A7BC5-7D38-D16E-1E97-94877908BE83}"/>
+                <a16:creationId xmlns:a16="http://schemas.microsoft.com/office/drawing/2014/main" id="{56430264-98C4-67F3-D53F-E0966223C05C}"/>
               </a:ext>
             </a:extLst>
           </p:cNvPr>
@@ -4943,7 +5486,7 @@
     </p:spTree>
     <p:extLst>
       <p:ext uri="{BB962C8B-B14F-4D97-AF65-F5344CB8AC3E}">
-        <p14:creationId xmlns:p14="http://schemas.microsoft.com/office/powerpoint/2010/main" val="1668443655"/>
+        <p14:creationId xmlns:p14="http://schemas.microsoft.com/office/powerpoint/2010/main" val="1923938091"/>
       </p:ext>
     </p:extLst>
   </p:cSld>
@@ -4983,7 +5526,7 @@
           <p:cNvPr id="2" name="TextBox 1">
             <a:extLst>
               <a:ext uri="{FF2B5EF4-FFF2-40B4-BE49-F238E27FC236}">
-                <a16:creationId xmlns:a16="http://schemas.microsoft.com/office/drawing/2014/main" id="{699F7AC3-8F4C-643E-26A6-67D3000F5826}"/>
+                <a16:creationId xmlns:a16="http://schemas.microsoft.com/office/drawing/2014/main" id="{B8BF6C83-9395-BAF4-B876-F7E8FBDC0303}"/>
               </a:ext>
             </a:extLst>
           </p:cNvPr>
@@ -5023,7 +5566,7 @@
           <p:cNvPr id="4" name="Picture 3">
             <a:extLst>
               <a:ext uri="{FF2B5EF4-FFF2-40B4-BE49-F238E27FC236}">
-                <a16:creationId xmlns:a16="http://schemas.microsoft.com/office/drawing/2014/main" id="{22E12476-A477-2922-9920-CC954DC07603}"/>
+                <a16:creationId xmlns:a16="http://schemas.microsoft.com/office/drawing/2014/main" id="{F6A77204-E584-C9B1-0280-5CEF3BF64B0E}"/>
               </a:ext>
             </a:extLst>
           </p:cNvPr>
@@ -5059,7 +5602,7 @@
           <p:cNvPr id="5" name="TextBox 4">
             <a:extLst>
               <a:ext uri="{FF2B5EF4-FFF2-40B4-BE49-F238E27FC236}">
-                <a16:creationId xmlns:a16="http://schemas.microsoft.com/office/drawing/2014/main" id="{B77EF1DD-B68B-3023-6CE0-B76AF8CFD85D}"/>
+                <a16:creationId xmlns:a16="http://schemas.microsoft.com/office/drawing/2014/main" id="{6A03B463-5B5E-C9F5-B3E4-9F0A75AB97AD}"/>
               </a:ext>
             </a:extLst>
           </p:cNvPr>
@@ -5098,7 +5641,7 @@
     </p:spTree>
     <p:extLst>
       <p:ext uri="{BB962C8B-B14F-4D97-AF65-F5344CB8AC3E}">
-        <p14:creationId xmlns:p14="http://schemas.microsoft.com/office/powerpoint/2010/main" val="343942661"/>
+        <p14:creationId xmlns:p14="http://schemas.microsoft.com/office/powerpoint/2010/main" val="4268784095"/>
       </p:ext>
     </p:extLst>
   </p:cSld>
@@ -5138,7 +5681,7 @@
           <p:cNvPr id="2" name="TextBox 1">
             <a:extLst>
               <a:ext uri="{FF2B5EF4-FFF2-40B4-BE49-F238E27FC236}">
-                <a16:creationId xmlns:a16="http://schemas.microsoft.com/office/drawing/2014/main" id="{3A45F2A8-A06C-7D23-A264-451E93AD3983}"/>
+                <a16:creationId xmlns:a16="http://schemas.microsoft.com/office/drawing/2014/main" id="{12FCCDFD-A6C6-FC1B-83F5-9FAD359FE4E6}"/>
               </a:ext>
             </a:extLst>
           </p:cNvPr>
@@ -5178,7 +5721,7 @@
           <p:cNvPr id="4" name="Picture 3">
             <a:extLst>
               <a:ext uri="{FF2B5EF4-FFF2-40B4-BE49-F238E27FC236}">
-                <a16:creationId xmlns:a16="http://schemas.microsoft.com/office/drawing/2014/main" id="{527EA7B1-01D5-2C60-A62C-D2A5ACED15C6}"/>
+                <a16:creationId xmlns:a16="http://schemas.microsoft.com/office/drawing/2014/main" id="{80CAFDE5-B869-CEED-003F-F16C1E3620A7}"/>
               </a:ext>
             </a:extLst>
           </p:cNvPr>
@@ -5214,7 +5757,7 @@
           <p:cNvPr id="5" name="TextBox 4">
             <a:extLst>
               <a:ext uri="{FF2B5EF4-FFF2-40B4-BE49-F238E27FC236}">
-                <a16:creationId xmlns:a16="http://schemas.microsoft.com/office/drawing/2014/main" id="{AFADD551-CA5E-7F0D-E839-5E0D3D5C3515}"/>
+                <a16:creationId xmlns:a16="http://schemas.microsoft.com/office/drawing/2014/main" id="{14D57406-12F2-14D9-8822-E26999019D70}"/>
               </a:ext>
             </a:extLst>
           </p:cNvPr>
@@ -5253,7 +5796,7 @@
     </p:spTree>
     <p:extLst>
       <p:ext uri="{BB962C8B-B14F-4D97-AF65-F5344CB8AC3E}">
-        <p14:creationId xmlns:p14="http://schemas.microsoft.com/office/powerpoint/2010/main" val="3542949035"/>
+        <p14:creationId xmlns:p14="http://schemas.microsoft.com/office/powerpoint/2010/main" val="2616586641"/>
       </p:ext>
     </p:extLst>
   </p:cSld>
@@ -5293,7 +5836,7 @@
           <p:cNvPr id="2" name="TextBox 1">
             <a:extLst>
               <a:ext uri="{FF2B5EF4-FFF2-40B4-BE49-F238E27FC236}">
-                <a16:creationId xmlns:a16="http://schemas.microsoft.com/office/drawing/2014/main" id="{0F93F076-D851-7DB9-6C24-3F23BCC6DFFA}"/>
+                <a16:creationId xmlns:a16="http://schemas.microsoft.com/office/drawing/2014/main" id="{22E8566B-6DBE-8031-FE5B-E82F7BE50DA5}"/>
               </a:ext>
             </a:extLst>
           </p:cNvPr>
@@ -5333,7 +5876,7 @@
           <p:cNvPr id="4" name="Picture 3">
             <a:extLst>
               <a:ext uri="{FF2B5EF4-FFF2-40B4-BE49-F238E27FC236}">
-                <a16:creationId xmlns:a16="http://schemas.microsoft.com/office/drawing/2014/main" id="{965E025F-331C-28D5-D82F-3AD6CCF8FAC1}"/>
+                <a16:creationId xmlns:a16="http://schemas.microsoft.com/office/drawing/2014/main" id="{C5604015-CD28-26F8-4D35-7B213F57AEBF}"/>
               </a:ext>
             </a:extLst>
           </p:cNvPr>
@@ -5369,7 +5912,7 @@
           <p:cNvPr id="5" name="TextBox 4">
             <a:extLst>
               <a:ext uri="{FF2B5EF4-FFF2-40B4-BE49-F238E27FC236}">
-                <a16:creationId xmlns:a16="http://schemas.microsoft.com/office/drawing/2014/main" id="{2EDD4B86-C666-0C49-BA54-511787DB67AD}"/>
+                <a16:creationId xmlns:a16="http://schemas.microsoft.com/office/drawing/2014/main" id="{5FFE2D73-315C-07D1-268B-687556A3FEC2}"/>
               </a:ext>
             </a:extLst>
           </p:cNvPr>
@@ -5408,7 +5951,7 @@
     </p:spTree>
     <p:extLst>
       <p:ext uri="{BB962C8B-B14F-4D97-AF65-F5344CB8AC3E}">
-        <p14:creationId xmlns:p14="http://schemas.microsoft.com/office/powerpoint/2010/main" val="2416114712"/>
+        <p14:creationId xmlns:p14="http://schemas.microsoft.com/office/powerpoint/2010/main" val="126271272"/>
       </p:ext>
     </p:extLst>
   </p:cSld>
@@ -5448,7 +5991,7 @@
           <p:cNvPr id="2" name="TextBox 1">
             <a:extLst>
               <a:ext uri="{FF2B5EF4-FFF2-40B4-BE49-F238E27FC236}">
-                <a16:creationId xmlns:a16="http://schemas.microsoft.com/office/drawing/2014/main" id="{5667A47E-F159-8F10-A72F-15ADC7706DA4}"/>
+                <a16:creationId xmlns:a16="http://schemas.microsoft.com/office/drawing/2014/main" id="{CB8CE647-46DD-5E63-5C09-6272AFD06B20}"/>
               </a:ext>
             </a:extLst>
           </p:cNvPr>
@@ -5488,7 +6031,7 @@
           <p:cNvPr id="3" name="Rectangle: Rounded Corners 2">
             <a:extLst>
               <a:ext uri="{FF2B5EF4-FFF2-40B4-BE49-F238E27FC236}">
-                <a16:creationId xmlns:a16="http://schemas.microsoft.com/office/drawing/2014/main" id="{52825F1D-01C6-4FCB-386B-4182D9C4518E}"/>
+                <a16:creationId xmlns:a16="http://schemas.microsoft.com/office/drawing/2014/main" id="{D1D00CC1-7914-D8B8-3745-A406A8B91F09}"/>
               </a:ext>
             </a:extLst>
           </p:cNvPr>
@@ -5564,7 +6107,7 @@
           <p:cNvPr id="4" name="Oval 3">
             <a:extLst>
               <a:ext uri="{FF2B5EF4-FFF2-40B4-BE49-F238E27FC236}">
-                <a16:creationId xmlns:a16="http://schemas.microsoft.com/office/drawing/2014/main" id="{6F1ADFEA-219F-7882-4DC7-0345CF378176}"/>
+                <a16:creationId xmlns:a16="http://schemas.microsoft.com/office/drawing/2014/main" id="{0CB5D8B9-5660-2CC2-84EB-612FDC89E991}"/>
               </a:ext>
             </a:extLst>
           </p:cNvPr>
@@ -5632,7 +6175,7 @@
           <p:cNvPr id="5" name="TextBox 4">
             <a:extLst>
               <a:ext uri="{FF2B5EF4-FFF2-40B4-BE49-F238E27FC236}">
-                <a16:creationId xmlns:a16="http://schemas.microsoft.com/office/drawing/2014/main" id="{B2D60695-5294-FFAA-8D50-864818FAEA37}"/>
+                <a16:creationId xmlns:a16="http://schemas.microsoft.com/office/drawing/2014/main" id="{F3DBEBA1-8E3E-359F-7540-5323CA2920E5}"/>
               </a:ext>
             </a:extLst>
           </p:cNvPr>
@@ -5672,7 +6215,7 @@
           <p:cNvPr id="6" name="TextBox 5">
             <a:extLst>
               <a:ext uri="{FF2B5EF4-FFF2-40B4-BE49-F238E27FC236}">
-                <a16:creationId xmlns:a16="http://schemas.microsoft.com/office/drawing/2014/main" id="{58899039-4C84-3E9B-61EF-84C54E9DE391}"/>
+                <a16:creationId xmlns:a16="http://schemas.microsoft.com/office/drawing/2014/main" id="{76B7FDE8-748A-8839-A1F9-6ED64DF8D10B}"/>
               </a:ext>
             </a:extLst>
           </p:cNvPr>
@@ -5712,7 +6255,7 @@
           <p:cNvPr id="7" name="TextBox 6">
             <a:extLst>
               <a:ext uri="{FF2B5EF4-FFF2-40B4-BE49-F238E27FC236}">
-                <a16:creationId xmlns:a16="http://schemas.microsoft.com/office/drawing/2014/main" id="{C95FC1A1-31D4-BBF8-2E8B-E785F55F4792}"/>
+                <a16:creationId xmlns:a16="http://schemas.microsoft.com/office/drawing/2014/main" id="{20902993-DC6D-A193-F599-CFD3842370FF}"/>
               </a:ext>
             </a:extLst>
           </p:cNvPr>
@@ -5752,7 +6295,7 @@
           <p:cNvPr id="8" name="TextBox 7">
             <a:extLst>
               <a:ext uri="{FF2B5EF4-FFF2-40B4-BE49-F238E27FC236}">
-                <a16:creationId xmlns:a16="http://schemas.microsoft.com/office/drawing/2014/main" id="{F22F86C7-0F92-8F17-CC1D-AC0B31ADD59A}"/>
+                <a16:creationId xmlns:a16="http://schemas.microsoft.com/office/drawing/2014/main" id="{FD442B5B-98B3-3756-3DE0-DC731141B21F}"/>
               </a:ext>
             </a:extLst>
           </p:cNvPr>
@@ -5792,7 +6335,7 @@
           <p:cNvPr id="9" name="TextBox 8">
             <a:extLst>
               <a:ext uri="{FF2B5EF4-FFF2-40B4-BE49-F238E27FC236}">
-                <a16:creationId xmlns:a16="http://schemas.microsoft.com/office/drawing/2014/main" id="{0F8D560D-CB75-6DFF-B4D7-057A72C8B3AF}"/>
+                <a16:creationId xmlns:a16="http://schemas.microsoft.com/office/drawing/2014/main" id="{67CACBAA-5023-CF34-EDFE-09892DCC9E45}"/>
               </a:ext>
             </a:extLst>
           </p:cNvPr>
@@ -5832,7 +6375,7 @@
           <p:cNvPr id="10" name="TextBox 9">
             <a:extLst>
               <a:ext uri="{FF2B5EF4-FFF2-40B4-BE49-F238E27FC236}">
-                <a16:creationId xmlns:a16="http://schemas.microsoft.com/office/drawing/2014/main" id="{0762D5F9-B7D8-025F-7F8E-5622B36F48E9}"/>
+                <a16:creationId xmlns:a16="http://schemas.microsoft.com/office/drawing/2014/main" id="{CF1E6247-96D1-F49C-E909-4C051858EC2F}"/>
               </a:ext>
             </a:extLst>
           </p:cNvPr>
@@ -5872,7 +6415,7 @@
           <p:cNvPr id="11" name="TextBox 10">
             <a:extLst>
               <a:ext uri="{FF2B5EF4-FFF2-40B4-BE49-F238E27FC236}">
-                <a16:creationId xmlns:a16="http://schemas.microsoft.com/office/drawing/2014/main" id="{832C8123-6B7C-1D95-78AD-520D605FCDDE}"/>
+                <a16:creationId xmlns:a16="http://schemas.microsoft.com/office/drawing/2014/main" id="{26EF6039-80A6-AED2-E0D1-18A765FBF5DE}"/>
               </a:ext>
             </a:extLst>
           </p:cNvPr>
@@ -5912,7 +6455,7 @@
           <p:cNvPr id="12" name="Rectangle: Rounded Corners 11">
             <a:extLst>
               <a:ext uri="{FF2B5EF4-FFF2-40B4-BE49-F238E27FC236}">
-                <a16:creationId xmlns:a16="http://schemas.microsoft.com/office/drawing/2014/main" id="{89B871C3-9C20-1467-DEC1-4E395EB19655}"/>
+                <a16:creationId xmlns:a16="http://schemas.microsoft.com/office/drawing/2014/main" id="{5692F950-CEEE-11F6-5DB0-28BE2C2EBBBE}"/>
               </a:ext>
             </a:extLst>
           </p:cNvPr>
@@ -5988,7 +6531,7 @@
           <p:cNvPr id="13" name="Oval 12">
             <a:extLst>
               <a:ext uri="{FF2B5EF4-FFF2-40B4-BE49-F238E27FC236}">
-                <a16:creationId xmlns:a16="http://schemas.microsoft.com/office/drawing/2014/main" id="{D99E05C4-B523-9909-EB2A-DC16667ED5FB}"/>
+                <a16:creationId xmlns:a16="http://schemas.microsoft.com/office/drawing/2014/main" id="{B9E2C698-1754-8BB5-E4EC-932E14B0F9E0}"/>
               </a:ext>
             </a:extLst>
           </p:cNvPr>
@@ -6056,7 +6599,7 @@
           <p:cNvPr id="14" name="TextBox 13">
             <a:extLst>
               <a:ext uri="{FF2B5EF4-FFF2-40B4-BE49-F238E27FC236}">
-                <a16:creationId xmlns:a16="http://schemas.microsoft.com/office/drawing/2014/main" id="{ECFCEE9C-F114-B5CD-52B7-D316777BB4E9}"/>
+                <a16:creationId xmlns:a16="http://schemas.microsoft.com/office/drawing/2014/main" id="{39897D09-BD5B-F282-B1D5-A815E6C80455}"/>
               </a:ext>
             </a:extLst>
           </p:cNvPr>
@@ -6096,7 +6639,7 @@
           <p:cNvPr id="15" name="TextBox 14">
             <a:extLst>
               <a:ext uri="{FF2B5EF4-FFF2-40B4-BE49-F238E27FC236}">
-                <a16:creationId xmlns:a16="http://schemas.microsoft.com/office/drawing/2014/main" id="{1B5F7D52-B2BF-7AAB-EFF4-2F9695A09AD8}"/>
+                <a16:creationId xmlns:a16="http://schemas.microsoft.com/office/drawing/2014/main" id="{4CA1B7F9-3447-2570-2C57-544D02DD3641}"/>
               </a:ext>
             </a:extLst>
           </p:cNvPr>
@@ -6136,7 +6679,7 @@
           <p:cNvPr id="16" name="TextBox 15">
             <a:extLst>
               <a:ext uri="{FF2B5EF4-FFF2-40B4-BE49-F238E27FC236}">
-                <a16:creationId xmlns:a16="http://schemas.microsoft.com/office/drawing/2014/main" id="{F589E7B6-0E3A-2BD2-02B4-5164197098CF}"/>
+                <a16:creationId xmlns:a16="http://schemas.microsoft.com/office/drawing/2014/main" id="{E9DE1439-199F-7D90-C9BE-576EE9D69CE0}"/>
               </a:ext>
             </a:extLst>
           </p:cNvPr>
@@ -6176,7 +6719,7 @@
           <p:cNvPr id="17" name="TextBox 16">
             <a:extLst>
               <a:ext uri="{FF2B5EF4-FFF2-40B4-BE49-F238E27FC236}">
-                <a16:creationId xmlns:a16="http://schemas.microsoft.com/office/drawing/2014/main" id="{937384FE-BA33-01D2-33AB-FE6A75C276D5}"/>
+                <a16:creationId xmlns:a16="http://schemas.microsoft.com/office/drawing/2014/main" id="{21D99289-A3E8-BB13-2F1E-E80312B40156}"/>
               </a:ext>
             </a:extLst>
           </p:cNvPr>
@@ -6216,7 +6759,7 @@
           <p:cNvPr id="18" name="TextBox 17">
             <a:extLst>
               <a:ext uri="{FF2B5EF4-FFF2-40B4-BE49-F238E27FC236}">
-                <a16:creationId xmlns:a16="http://schemas.microsoft.com/office/drawing/2014/main" id="{07519B84-2D7B-EE00-747A-23D7123E97D6}"/>
+                <a16:creationId xmlns:a16="http://schemas.microsoft.com/office/drawing/2014/main" id="{4DF3FDE1-C29E-04FD-2007-66B5423125AC}"/>
               </a:ext>
             </a:extLst>
           </p:cNvPr>
@@ -6256,7 +6799,7 @@
           <p:cNvPr id="19" name="TextBox 18">
             <a:extLst>
               <a:ext uri="{FF2B5EF4-FFF2-40B4-BE49-F238E27FC236}">
-                <a16:creationId xmlns:a16="http://schemas.microsoft.com/office/drawing/2014/main" id="{05518DC6-0379-C4AF-B72A-E2A9FD75C35B}"/>
+                <a16:creationId xmlns:a16="http://schemas.microsoft.com/office/drawing/2014/main" id="{9352C29D-F9BF-BBC2-D8E3-3A2B94EE9659}"/>
               </a:ext>
             </a:extLst>
           </p:cNvPr>
@@ -6296,7 +6839,7 @@
           <p:cNvPr id="20" name="TextBox 19">
             <a:extLst>
               <a:ext uri="{FF2B5EF4-FFF2-40B4-BE49-F238E27FC236}">
-                <a16:creationId xmlns:a16="http://schemas.microsoft.com/office/drawing/2014/main" id="{A9A4F374-6740-7FAE-CF6D-06981424E1CA}"/>
+                <a16:creationId xmlns:a16="http://schemas.microsoft.com/office/drawing/2014/main" id="{39E05089-FD29-8D2E-4408-4E8682072A03}"/>
               </a:ext>
             </a:extLst>
           </p:cNvPr>
@@ -6336,7 +6879,7 @@
           <p:cNvPr id="21" name="Rectangle: Rounded Corners 20">
             <a:extLst>
               <a:ext uri="{FF2B5EF4-FFF2-40B4-BE49-F238E27FC236}">
-                <a16:creationId xmlns:a16="http://schemas.microsoft.com/office/drawing/2014/main" id="{3A726401-3638-4EC9-3DF3-B46DB09E0682}"/>
+                <a16:creationId xmlns:a16="http://schemas.microsoft.com/office/drawing/2014/main" id="{21E289A0-AC69-3E06-6A75-8CAB2A9D1A99}"/>
               </a:ext>
             </a:extLst>
           </p:cNvPr>
@@ -6412,7 +6955,7 @@
           <p:cNvPr id="22" name="Oval 21">
             <a:extLst>
               <a:ext uri="{FF2B5EF4-FFF2-40B4-BE49-F238E27FC236}">
-                <a16:creationId xmlns:a16="http://schemas.microsoft.com/office/drawing/2014/main" id="{E214D069-1050-326D-84A7-46F1B87F91AF}"/>
+                <a16:creationId xmlns:a16="http://schemas.microsoft.com/office/drawing/2014/main" id="{9159A4CF-A181-77B3-74E3-38DB4AC63876}"/>
               </a:ext>
             </a:extLst>
           </p:cNvPr>
@@ -6480,7 +7023,7 @@
           <p:cNvPr id="23" name="TextBox 22">
             <a:extLst>
               <a:ext uri="{FF2B5EF4-FFF2-40B4-BE49-F238E27FC236}">
-                <a16:creationId xmlns:a16="http://schemas.microsoft.com/office/drawing/2014/main" id="{DBF295E3-A173-99B1-F79F-90BA5930425E}"/>
+                <a16:creationId xmlns:a16="http://schemas.microsoft.com/office/drawing/2014/main" id="{B5B78855-BA2E-E39D-07B9-99F529FA203B}"/>
               </a:ext>
             </a:extLst>
           </p:cNvPr>
@@ -6520,7 +7063,7 @@
           <p:cNvPr id="24" name="TextBox 23">
             <a:extLst>
               <a:ext uri="{FF2B5EF4-FFF2-40B4-BE49-F238E27FC236}">
-                <a16:creationId xmlns:a16="http://schemas.microsoft.com/office/drawing/2014/main" id="{E8820FE3-F5DE-5763-85D2-BE52336BB676}"/>
+                <a16:creationId xmlns:a16="http://schemas.microsoft.com/office/drawing/2014/main" id="{6043472A-EB72-3142-F229-508654F0C1B3}"/>
               </a:ext>
             </a:extLst>
           </p:cNvPr>
@@ -6560,7 +7103,7 @@
           <p:cNvPr id="25" name="TextBox 24">
             <a:extLst>
               <a:ext uri="{FF2B5EF4-FFF2-40B4-BE49-F238E27FC236}">
-                <a16:creationId xmlns:a16="http://schemas.microsoft.com/office/drawing/2014/main" id="{19B7B59F-00A7-0F40-320C-9789E99C1CDF}"/>
+                <a16:creationId xmlns:a16="http://schemas.microsoft.com/office/drawing/2014/main" id="{5AE6CBB1-07CD-7025-A3FD-202EBE26AA4F}"/>
               </a:ext>
             </a:extLst>
           </p:cNvPr>
@@ -6600,7 +7143,7 @@
           <p:cNvPr id="26" name="TextBox 25">
             <a:extLst>
               <a:ext uri="{FF2B5EF4-FFF2-40B4-BE49-F238E27FC236}">
-                <a16:creationId xmlns:a16="http://schemas.microsoft.com/office/drawing/2014/main" id="{6D2087CE-CD44-0EFB-1E2E-6571EEB48851}"/>
+                <a16:creationId xmlns:a16="http://schemas.microsoft.com/office/drawing/2014/main" id="{DBEFBF89-9AA8-84AA-3A12-DAFEE739E9CC}"/>
               </a:ext>
             </a:extLst>
           </p:cNvPr>
@@ -6640,7 +7183,7 @@
           <p:cNvPr id="27" name="TextBox 26">
             <a:extLst>
               <a:ext uri="{FF2B5EF4-FFF2-40B4-BE49-F238E27FC236}">
-                <a16:creationId xmlns:a16="http://schemas.microsoft.com/office/drawing/2014/main" id="{AD27EC47-0044-BA19-6737-8C0632A54F9B}"/>
+                <a16:creationId xmlns:a16="http://schemas.microsoft.com/office/drawing/2014/main" id="{74D3F15A-A3B7-E76C-4C68-F644FD51A226}"/>
               </a:ext>
             </a:extLst>
           </p:cNvPr>
@@ -6680,7 +7223,7 @@
           <p:cNvPr id="28" name="TextBox 27">
             <a:extLst>
               <a:ext uri="{FF2B5EF4-FFF2-40B4-BE49-F238E27FC236}">
-                <a16:creationId xmlns:a16="http://schemas.microsoft.com/office/drawing/2014/main" id="{33111695-EF97-3CE3-7D92-8D59F5654958}"/>
+                <a16:creationId xmlns:a16="http://schemas.microsoft.com/office/drawing/2014/main" id="{F95CEDED-35D0-6FD3-ED1C-F3405C3AE661}"/>
               </a:ext>
             </a:extLst>
           </p:cNvPr>
@@ -6720,7 +7263,7 @@
           <p:cNvPr id="29" name="TextBox 28">
             <a:extLst>
               <a:ext uri="{FF2B5EF4-FFF2-40B4-BE49-F238E27FC236}">
-                <a16:creationId xmlns:a16="http://schemas.microsoft.com/office/drawing/2014/main" id="{B7256011-9F9E-A55C-EE8E-D45010877F3D}"/>
+                <a16:creationId xmlns:a16="http://schemas.microsoft.com/office/drawing/2014/main" id="{A6F3ECDF-DCC0-3906-F123-E6C11695125E}"/>
               </a:ext>
             </a:extLst>
           </p:cNvPr>
@@ -6760,7 +7303,7 @@
           <p:cNvPr id="30" name="TextBox 29">
             <a:extLst>
               <a:ext uri="{FF2B5EF4-FFF2-40B4-BE49-F238E27FC236}">
-                <a16:creationId xmlns:a16="http://schemas.microsoft.com/office/drawing/2014/main" id="{F282582A-FDB6-7178-081B-6D88C53E8BFE}"/>
+                <a16:creationId xmlns:a16="http://schemas.microsoft.com/office/drawing/2014/main" id="{ADDE36D6-54EA-E543-B201-4597AC9A1E86}"/>
               </a:ext>
             </a:extLst>
           </p:cNvPr>
@@ -6798,7 +7341,7 @@
     </p:spTree>
     <p:extLst>
       <p:ext uri="{BB962C8B-B14F-4D97-AF65-F5344CB8AC3E}">
-        <p14:creationId xmlns:p14="http://schemas.microsoft.com/office/powerpoint/2010/main" val="3097225027"/>
+        <p14:creationId xmlns:p14="http://schemas.microsoft.com/office/powerpoint/2010/main" val="3319840386"/>
       </p:ext>
     </p:extLst>
   </p:cSld>
@@ -6838,7 +7381,7 @@
           <p:cNvPr id="2" name="TextBox 1">
             <a:extLst>
               <a:ext uri="{FF2B5EF4-FFF2-40B4-BE49-F238E27FC236}">
-                <a16:creationId xmlns:a16="http://schemas.microsoft.com/office/drawing/2014/main" id="{B3B16660-E422-843B-5625-78C6354D49C6}"/>
+                <a16:creationId xmlns:a16="http://schemas.microsoft.com/office/drawing/2014/main" id="{4846EE46-CF25-6C64-AACC-80B8F9660700}"/>
               </a:ext>
             </a:extLst>
           </p:cNvPr>
@@ -6878,7 +7421,7 @@
           <p:cNvPr id="3" name="TextBox 2">
             <a:extLst>
               <a:ext uri="{FF2B5EF4-FFF2-40B4-BE49-F238E27FC236}">
-                <a16:creationId xmlns:a16="http://schemas.microsoft.com/office/drawing/2014/main" id="{5C75D81C-1409-8C28-2964-4B9EFE177DEB}"/>
+                <a16:creationId xmlns:a16="http://schemas.microsoft.com/office/drawing/2014/main" id="{33A194E3-A207-4741-92BD-BA0692097BA8}"/>
               </a:ext>
             </a:extLst>
           </p:cNvPr>
@@ -6918,7 +7461,7 @@
           <p:cNvPr id="4" name="Rectangle: Rounded Corners 3">
             <a:extLst>
               <a:ext uri="{FF2B5EF4-FFF2-40B4-BE49-F238E27FC236}">
-                <a16:creationId xmlns:a16="http://schemas.microsoft.com/office/drawing/2014/main" id="{CA5681CE-AA30-33AE-29BB-0446B6324D4A}"/>
+                <a16:creationId xmlns:a16="http://schemas.microsoft.com/office/drawing/2014/main" id="{E4A25922-DE37-620E-D5D2-C4BC66BF5F6C}"/>
               </a:ext>
             </a:extLst>
           </p:cNvPr>
@@ -6988,7 +7531,7 @@
           <p:cNvPr id="5" name="TextBox 4">
             <a:extLst>
               <a:ext uri="{FF2B5EF4-FFF2-40B4-BE49-F238E27FC236}">
-                <a16:creationId xmlns:a16="http://schemas.microsoft.com/office/drawing/2014/main" id="{20E441BA-9021-6D19-5A4B-89B20BA91F5E}"/>
+                <a16:creationId xmlns:a16="http://schemas.microsoft.com/office/drawing/2014/main" id="{D055CC57-28A1-F645-6851-FAF4285D9200}"/>
               </a:ext>
             </a:extLst>
           </p:cNvPr>
@@ -7029,7 +7572,7 @@
           <p:cNvPr id="6" name="TextBox 5">
             <a:extLst>
               <a:ext uri="{FF2B5EF4-FFF2-40B4-BE49-F238E27FC236}">
-                <a16:creationId xmlns:a16="http://schemas.microsoft.com/office/drawing/2014/main" id="{C95537C7-01E3-7FDD-8DB1-6D4D12A7BB81}"/>
+                <a16:creationId xmlns:a16="http://schemas.microsoft.com/office/drawing/2014/main" id="{314A93CD-5AF0-6A43-642E-0941659024AA}"/>
               </a:ext>
             </a:extLst>
           </p:cNvPr>
@@ -7070,7 +7613,7 @@
           <p:cNvPr id="7" name="Rectangle: Rounded Corners 6">
             <a:extLst>
               <a:ext uri="{FF2B5EF4-FFF2-40B4-BE49-F238E27FC236}">
-                <a16:creationId xmlns:a16="http://schemas.microsoft.com/office/drawing/2014/main" id="{299FA604-2A98-290B-26D0-8CE920D6C6F5}"/>
+                <a16:creationId xmlns:a16="http://schemas.microsoft.com/office/drawing/2014/main" id="{83E813B6-54F0-20F2-3968-6FC4CF0BDFB8}"/>
               </a:ext>
             </a:extLst>
           </p:cNvPr>
@@ -7140,7 +7683,7 @@
           <p:cNvPr id="8" name="TextBox 7">
             <a:extLst>
               <a:ext uri="{FF2B5EF4-FFF2-40B4-BE49-F238E27FC236}">
-                <a16:creationId xmlns:a16="http://schemas.microsoft.com/office/drawing/2014/main" id="{44093E91-DEFB-1A8D-E7C1-3AE3C7957B5E}"/>
+                <a16:creationId xmlns:a16="http://schemas.microsoft.com/office/drawing/2014/main" id="{BE981924-6777-D5A9-7009-C91A7BA68E23}"/>
               </a:ext>
             </a:extLst>
           </p:cNvPr>
@@ -7181,7 +7724,7 @@
           <p:cNvPr id="9" name="TextBox 8">
             <a:extLst>
               <a:ext uri="{FF2B5EF4-FFF2-40B4-BE49-F238E27FC236}">
-                <a16:creationId xmlns:a16="http://schemas.microsoft.com/office/drawing/2014/main" id="{FB000499-9541-52E1-BD05-722D758335E9}"/>
+                <a16:creationId xmlns:a16="http://schemas.microsoft.com/office/drawing/2014/main" id="{8CF2D287-2E27-7845-D3D4-E2B757BBBC86}"/>
               </a:ext>
             </a:extLst>
           </p:cNvPr>
@@ -7222,7 +7765,7 @@
           <p:cNvPr id="10" name="Rectangle: Rounded Corners 9">
             <a:extLst>
               <a:ext uri="{FF2B5EF4-FFF2-40B4-BE49-F238E27FC236}">
-                <a16:creationId xmlns:a16="http://schemas.microsoft.com/office/drawing/2014/main" id="{34C4450F-B7EE-4139-44F3-7CC84623AECB}"/>
+                <a16:creationId xmlns:a16="http://schemas.microsoft.com/office/drawing/2014/main" id="{6FD9C9EE-93C5-1C38-2E4D-31090DB701FD}"/>
               </a:ext>
             </a:extLst>
           </p:cNvPr>
@@ -7292,7 +7835,7 @@
           <p:cNvPr id="11" name="TextBox 10">
             <a:extLst>
               <a:ext uri="{FF2B5EF4-FFF2-40B4-BE49-F238E27FC236}">
-                <a16:creationId xmlns:a16="http://schemas.microsoft.com/office/drawing/2014/main" id="{BC83A892-DEA5-03E7-8233-725702A823C6}"/>
+                <a16:creationId xmlns:a16="http://schemas.microsoft.com/office/drawing/2014/main" id="{0E0D8F3A-2EC7-B74D-51DE-7F5275C37E4B}"/>
               </a:ext>
             </a:extLst>
           </p:cNvPr>
@@ -7333,7 +7876,7 @@
           <p:cNvPr id="12" name="TextBox 11">
             <a:extLst>
               <a:ext uri="{FF2B5EF4-FFF2-40B4-BE49-F238E27FC236}">
-                <a16:creationId xmlns:a16="http://schemas.microsoft.com/office/drawing/2014/main" id="{7F045CA7-0249-A73C-6B94-78EA6B3816A5}"/>
+                <a16:creationId xmlns:a16="http://schemas.microsoft.com/office/drawing/2014/main" id="{B6913AA3-97A9-C21B-6828-53925FBA472C}"/>
               </a:ext>
             </a:extLst>
           </p:cNvPr>
@@ -7374,7 +7917,7 @@
           <p:cNvPr id="13" name="Rectangle: Rounded Corners 12">
             <a:extLst>
               <a:ext uri="{FF2B5EF4-FFF2-40B4-BE49-F238E27FC236}">
-                <a16:creationId xmlns:a16="http://schemas.microsoft.com/office/drawing/2014/main" id="{678E268C-3C59-FA38-44C9-AC6E8F5E179E}"/>
+                <a16:creationId xmlns:a16="http://schemas.microsoft.com/office/drawing/2014/main" id="{17A66CB7-4AFB-249F-C56D-566DA0446A74}"/>
               </a:ext>
             </a:extLst>
           </p:cNvPr>
@@ -7444,7 +7987,7 @@
           <p:cNvPr id="14" name="TextBox 13">
             <a:extLst>
               <a:ext uri="{FF2B5EF4-FFF2-40B4-BE49-F238E27FC236}">
-                <a16:creationId xmlns:a16="http://schemas.microsoft.com/office/drawing/2014/main" id="{717597FA-F9B8-E702-8FAF-2923AE60F5A2}"/>
+                <a16:creationId xmlns:a16="http://schemas.microsoft.com/office/drawing/2014/main" id="{EB7BAB5C-57D4-5D8D-D90D-BFB44C7FEE4C}"/>
               </a:ext>
             </a:extLst>
           </p:cNvPr>
@@ -7485,7 +8028,7 @@
           <p:cNvPr id="15" name="TextBox 14">
             <a:extLst>
               <a:ext uri="{FF2B5EF4-FFF2-40B4-BE49-F238E27FC236}">
-                <a16:creationId xmlns:a16="http://schemas.microsoft.com/office/drawing/2014/main" id="{4794DC8F-330A-0131-AC52-A4B1B050EB69}"/>
+                <a16:creationId xmlns:a16="http://schemas.microsoft.com/office/drawing/2014/main" id="{43A2B07E-1E26-C8FC-71B1-073149E62801}"/>
               </a:ext>
             </a:extLst>
           </p:cNvPr>
@@ -7526,7 +8069,7 @@
           <p:cNvPr id="16" name="Rectangle: Rounded Corners 15">
             <a:extLst>
               <a:ext uri="{FF2B5EF4-FFF2-40B4-BE49-F238E27FC236}">
-                <a16:creationId xmlns:a16="http://schemas.microsoft.com/office/drawing/2014/main" id="{4AB8275C-68C0-F9F7-69DE-A8F5A9659920}"/>
+                <a16:creationId xmlns:a16="http://schemas.microsoft.com/office/drawing/2014/main" id="{21BA030D-A633-AA15-DE86-4FF91706C0E9}"/>
               </a:ext>
             </a:extLst>
           </p:cNvPr>
@@ -7596,7 +8139,7 @@
           <p:cNvPr id="17" name="TextBox 16">
             <a:extLst>
               <a:ext uri="{FF2B5EF4-FFF2-40B4-BE49-F238E27FC236}">
-                <a16:creationId xmlns:a16="http://schemas.microsoft.com/office/drawing/2014/main" id="{B9DBA511-4CAE-A200-5098-895DC93AAF71}"/>
+                <a16:creationId xmlns:a16="http://schemas.microsoft.com/office/drawing/2014/main" id="{937F758F-EADA-68A5-FB5D-A8305541795B}"/>
               </a:ext>
             </a:extLst>
           </p:cNvPr>
@@ -7637,7 +8180,7 @@
           <p:cNvPr id="18" name="TextBox 17">
             <a:extLst>
               <a:ext uri="{FF2B5EF4-FFF2-40B4-BE49-F238E27FC236}">
-                <a16:creationId xmlns:a16="http://schemas.microsoft.com/office/drawing/2014/main" id="{7857D170-3525-5B26-58CC-10D1E8BDAB60}"/>
+                <a16:creationId xmlns:a16="http://schemas.microsoft.com/office/drawing/2014/main" id="{09474B27-95B9-61C4-AABD-9EA3B78D1224}"/>
               </a:ext>
             </a:extLst>
           </p:cNvPr>
@@ -7678,7 +8221,7 @@
           <p:cNvPr id="19" name="TextBox 18">
             <a:extLst>
               <a:ext uri="{FF2B5EF4-FFF2-40B4-BE49-F238E27FC236}">
-                <a16:creationId xmlns:a16="http://schemas.microsoft.com/office/drawing/2014/main" id="{F988A591-6677-C782-84AC-BDD73435A0F3}"/>
+                <a16:creationId xmlns:a16="http://schemas.microsoft.com/office/drawing/2014/main" id="{FC4CECC2-9BFC-2A84-1536-FF43B583A5E4}"/>
               </a:ext>
             </a:extLst>
           </p:cNvPr>
@@ -7719,7 +8262,7 @@
           <p:cNvPr id="20" name="TextBox 19">
             <a:extLst>
               <a:ext uri="{FF2B5EF4-FFF2-40B4-BE49-F238E27FC236}">
-                <a16:creationId xmlns:a16="http://schemas.microsoft.com/office/drawing/2014/main" id="{26F53B1E-DD71-16BD-7BAD-B14F3AE342D9}"/>
+                <a16:creationId xmlns:a16="http://schemas.microsoft.com/office/drawing/2014/main" id="{D529C243-E1D2-9BE7-E2F0-7FD0C36E85CA}"/>
               </a:ext>
             </a:extLst>
           </p:cNvPr>
@@ -7759,7 +8302,7 @@
           <p:cNvPr id="21" name="TextBox 20">
             <a:extLst>
               <a:ext uri="{FF2B5EF4-FFF2-40B4-BE49-F238E27FC236}">
-                <a16:creationId xmlns:a16="http://schemas.microsoft.com/office/drawing/2014/main" id="{D1301A95-84C7-8E26-96F7-71543E92688F}"/>
+                <a16:creationId xmlns:a16="http://schemas.microsoft.com/office/drawing/2014/main" id="{45E60B66-5750-2AE0-4916-4A8F9B74315D}"/>
               </a:ext>
             </a:extLst>
           </p:cNvPr>
@@ -7797,7 +8340,7 @@
     </p:spTree>
     <p:extLst>
       <p:ext uri="{BB962C8B-B14F-4D97-AF65-F5344CB8AC3E}">
-        <p14:creationId xmlns:p14="http://schemas.microsoft.com/office/powerpoint/2010/main" val="2414089227"/>
+        <p14:creationId xmlns:p14="http://schemas.microsoft.com/office/powerpoint/2010/main" val="4185662440"/>
       </p:ext>
     </p:extLst>
   </p:cSld>
@@ -7837,7 +8380,7 @@
           <p:cNvPr id="2" name="TextBox 1">
             <a:extLst>
               <a:ext uri="{FF2B5EF4-FFF2-40B4-BE49-F238E27FC236}">
-                <a16:creationId xmlns:a16="http://schemas.microsoft.com/office/drawing/2014/main" id="{D09D817F-7CE8-39A0-62C5-F8B5A68B3172}"/>
+                <a16:creationId xmlns:a16="http://schemas.microsoft.com/office/drawing/2014/main" id="{F8850D55-0A36-2C34-2E66-132B868FAC36}"/>
               </a:ext>
             </a:extLst>
           </p:cNvPr>
@@ -7877,7 +8420,7 @@
           <p:cNvPr id="3" name="Rectangle: Rounded Corners 2">
             <a:extLst>
               <a:ext uri="{FF2B5EF4-FFF2-40B4-BE49-F238E27FC236}">
-                <a16:creationId xmlns:a16="http://schemas.microsoft.com/office/drawing/2014/main" id="{3B6E7F5C-C624-1C82-1794-A00952BA6BBA}"/>
+                <a16:creationId xmlns:a16="http://schemas.microsoft.com/office/drawing/2014/main" id="{397013F6-C212-C2AF-5DCF-5F2FEDF39AFC}"/>
               </a:ext>
             </a:extLst>
           </p:cNvPr>
@@ -7886,8 +8429,8 @@
         </p:nvSpPr>
         <p:spPr>
           <a:xfrm>
-            <a:off x="508000" y="1397000"/>
-            <a:ext cx="3517900" cy="2159000"/>
+            <a:off x="508000" y="1219200"/>
+            <a:ext cx="5842000" cy="1371600"/>
           </a:xfrm>
           <a:prstGeom prst="roundRect">
             <a:avLst>
@@ -7953,7 +8496,7 @@
           <p:cNvPr id="4" name="TextBox 3">
             <a:extLst>
               <a:ext uri="{FF2B5EF4-FFF2-40B4-BE49-F238E27FC236}">
-                <a16:creationId xmlns:a16="http://schemas.microsoft.com/office/drawing/2014/main" id="{8E97AFD2-B4A1-4B72-CBC4-E10C98EDFD26}"/>
+                <a16:creationId xmlns:a16="http://schemas.microsoft.com/office/drawing/2014/main" id="{ABD8724E-FF69-2452-AA0D-EC57600A2386}"/>
               </a:ext>
             </a:extLst>
           </p:cNvPr>
@@ -7962,8 +8505,8 @@
         </p:nvSpPr>
         <p:spPr>
           <a:xfrm>
-            <a:off x="762000" y="1676400"/>
-            <a:ext cx="3009900" cy="400110"/>
+            <a:off x="787400" y="1397000"/>
+            <a:ext cx="5283200" cy="430887"/>
           </a:xfrm>
           <a:prstGeom prst="rect">
             <a:avLst/>
@@ -7977,7 +8520,7 @@
           <a:lstStyle/>
           <a:p>
             <a:r>
-              <a:rPr lang="en-US" sz="2600" b="1">
+              <a:rPr lang="en-US" sz="2800" b="1">
                 <a:solidFill>
                   <a:srgbClr val="1E2761"/>
                 </a:solidFill>
@@ -7993,7 +8536,7 @@
           <p:cNvPr id="5" name="TextBox 4">
             <a:extLst>
               <a:ext uri="{FF2B5EF4-FFF2-40B4-BE49-F238E27FC236}">
-                <a16:creationId xmlns:a16="http://schemas.microsoft.com/office/drawing/2014/main" id="{C9DB63E0-604F-CD85-316C-D916055235FB}"/>
+                <a16:creationId xmlns:a16="http://schemas.microsoft.com/office/drawing/2014/main" id="{2E5B20CF-6358-CF5E-DA23-88A018F290FA}"/>
               </a:ext>
             </a:extLst>
           </p:cNvPr>
@@ -8002,8 +8545,8 @@
         </p:nvSpPr>
         <p:spPr>
           <a:xfrm>
-            <a:off x="762000" y="2311400"/>
-            <a:ext cx="3009900" cy="215444"/>
+            <a:off x="787400" y="1930400"/>
+            <a:ext cx="5283200" cy="200055"/>
           </a:xfrm>
           <a:prstGeom prst="rect">
             <a:avLst/>
@@ -8017,13 +8560,13 @@
           <a:lstStyle/>
           <a:p>
             <a:r>
-              <a:rPr lang="en-US" sz="1400" b="1">
+              <a:rPr lang="en-US" sz="1300" b="1">
                 <a:solidFill>
                   <a:srgbClr val="1A1A2E"/>
                 </a:solidFill>
                 <a:latin typeface="Calibri" panose="020F0502020204030204" pitchFamily="34" charset="0"/>
               </a:rPr>
-              <a:t>S&amp;P 500 Close</a:t>
+              <a:t>S&amp;P 500 Close -- the forecast target</a:t>
             </a:r>
           </a:p>
         </p:txBody>
@@ -8033,7 +8576,7 @@
           <p:cNvPr id="6" name="TextBox 5">
             <a:extLst>
               <a:ext uri="{FF2B5EF4-FFF2-40B4-BE49-F238E27FC236}">
-                <a16:creationId xmlns:a16="http://schemas.microsoft.com/office/drawing/2014/main" id="{D559D62E-75BE-CFBE-0B27-46F1B71A58B8}"/>
+                <a16:creationId xmlns:a16="http://schemas.microsoft.com/office/drawing/2014/main" id="{1DD0EAFE-A77B-3ABC-6AE4-847428CC98E3}"/>
               </a:ext>
             </a:extLst>
           </p:cNvPr>
@@ -8042,8 +8585,8 @@
         </p:nvSpPr>
         <p:spPr>
           <a:xfrm>
-            <a:off x="762000" y="2667000"/>
-            <a:ext cx="3009900" cy="184666"/>
+            <a:off x="787400" y="2209800"/>
+            <a:ext cx="5283200" cy="169277"/>
           </a:xfrm>
           <a:prstGeom prst="rect">
             <a:avLst/>
@@ -8057,23 +8600,103 @@
           <a:lstStyle/>
           <a:p>
             <a:r>
-              <a:rPr lang="en-US" sz="1200" i="1">
+              <a:rPr lang="en-US" sz="1100" i="1">
                 <a:solidFill>
                   <a:srgbClr val="6B7280"/>
                 </a:solidFill>
                 <a:latin typeface="Calibri" panose="020F0502020204030204" pitchFamily="34" charset="0"/>
               </a:rPr>
-              <a:t>Forecast target</a:t>
-            </a:r>
-          </a:p>
-        </p:txBody>
-      </p:sp>
-      <p:sp>
-        <p:nvSpPr>
-          <p:cNvPr id="7" name="Rectangle: Rounded Corners 6">
-            <a:extLst>
-              <a:ext uri="{FF2B5EF4-FFF2-40B4-BE49-F238E27FC236}">
-                <a16:creationId xmlns:a16="http://schemas.microsoft.com/office/drawing/2014/main" id="{45D31D99-1638-0F2A-EDEE-5ED78CD68832}"/>
+              <a:t>Yahoo Finance (yfinance)  .  2005-01-01 -&gt; present, refetched live</a:t>
+            </a:r>
+          </a:p>
+        </p:txBody>
+      </p:sp>
+      <p:sp>
+        <p:nvSpPr>
+          <p:cNvPr id="7" name="TextBox 6">
+            <a:extLst>
+              <a:ext uri="{FF2B5EF4-FFF2-40B4-BE49-F238E27FC236}">
+                <a16:creationId xmlns:a16="http://schemas.microsoft.com/office/drawing/2014/main" id="{E9662F5C-4F5D-32D2-4319-C6F9F64F9FD5}"/>
+              </a:ext>
+            </a:extLst>
+          </p:cNvPr>
+          <p:cNvSpPr txBox="1"/>
+          <p:nvPr/>
+        </p:nvSpPr>
+        <p:spPr>
+          <a:xfrm>
+            <a:off x="508000" y="2844800"/>
+            <a:ext cx="5842000" cy="200055"/>
+          </a:xfrm>
+          <a:prstGeom prst="rect">
+            <a:avLst/>
+          </a:prstGeom>
+          <a:noFill/>
+        </p:spPr>
+        <p:txBody>
+          <a:bodyPr vert="horz" wrap="square" lIns="0" tIns="0" rIns="0" bIns="0" rtlCol="0">
+            <a:spAutoFit/>
+          </a:bodyPr>
+          <a:lstStyle/>
+          <a:p>
+            <a:r>
+              <a:rPr lang="en-US" sz="1300" b="1">
+                <a:solidFill>
+                  <a:srgbClr val="1E2761"/>
+                </a:solidFill>
+                <a:latin typeface="Calibri" panose="020F0502020204030204" pitchFamily="34" charset="0"/>
+              </a:rPr>
+              <a:t>One rolling window, end to end</a:t>
+            </a:r>
+          </a:p>
+        </p:txBody>
+      </p:sp>
+      <p:sp>
+        <p:nvSpPr>
+          <p:cNvPr id="8" name="TextBox 7">
+            <a:extLst>
+              <a:ext uri="{FF2B5EF4-FFF2-40B4-BE49-F238E27FC236}">
+                <a16:creationId xmlns:a16="http://schemas.microsoft.com/office/drawing/2014/main" id="{635570C5-98AF-520F-5B3A-0DA9B33881AD}"/>
+              </a:ext>
+            </a:extLst>
+          </p:cNvPr>
+          <p:cNvSpPr txBox="1"/>
+          <p:nvPr/>
+        </p:nvSpPr>
+        <p:spPr>
+          <a:xfrm>
+            <a:off x="508000" y="3225800"/>
+            <a:ext cx="3810000" cy="169277"/>
+          </a:xfrm>
+          <a:prstGeom prst="rect">
+            <a:avLst/>
+          </a:prstGeom>
+          <a:noFill/>
+        </p:spPr>
+        <p:txBody>
+          <a:bodyPr vert="horz" wrap="square" lIns="0" tIns="0" rIns="0" bIns="0" rtlCol="0">
+            <a:spAutoFit/>
+          </a:bodyPr>
+          <a:lstStyle/>
+          <a:p>
+            <a:r>
+              <a:rPr lang="en-US" sz="1100" b="1">
+                <a:solidFill>
+                  <a:srgbClr val="6B7280"/>
+                </a:solidFill>
+                <a:latin typeface="Calibri" panose="020F0502020204030204" pitchFamily="34" charset="0"/>
+              </a:rPr>
+              <a:t>Context -- 512 trading days (~2 years)</a:t>
+            </a:r>
+          </a:p>
+        </p:txBody>
+      </p:sp>
+      <p:sp>
+        <p:nvSpPr>
+          <p:cNvPr id="9" name="Rectangle: Rounded Corners 8">
+            <a:extLst>
+              <a:ext uri="{FF2B5EF4-FFF2-40B4-BE49-F238E27FC236}">
+                <a16:creationId xmlns:a16="http://schemas.microsoft.com/office/drawing/2014/main" id="{515296FA-CCD0-5804-8395-005A44A08A2A}"/>
               </a:ext>
             </a:extLst>
           </p:cNvPr>
@@ -8082,12 +8705,380 @@
         </p:nvSpPr>
         <p:spPr>
           <a:xfrm>
-            <a:off x="4330700" y="1397000"/>
-            <a:ext cx="3517900" cy="2159000"/>
+            <a:off x="508000" y="3581400"/>
+            <a:ext cx="3810000" cy="381000"/>
           </a:xfrm>
           <a:prstGeom prst="roundRect">
             <a:avLst>
-              <a:gd name="adj" fmla="val 8000"/>
+              <a:gd name="adj" fmla="val 15000"/>
+            </a:avLst>
+          </a:prstGeom>
+          <a:solidFill>
+            <a:srgbClr val="CADCFC"/>
+          </a:solidFill>
+          <a:ln w="19050" cap="flat" cmpd="sng" algn="ctr">
+            <a:noFill/>
+            <a:prstDash val="solid"/>
+            <a:miter lim="800000"/>
+          </a:ln>
+          <a:effectLst/>
+          <a:extLst>
+            <a:ext uri="{91240B29-F687-4F45-9708-019B960494DF}">
+              <a14:hiddenLine xmlns:a14="http://schemas.microsoft.com/office/drawing/2010/main" w="19050" cap="flat" cmpd="sng" algn="ctr">
+                <a:solidFill>
+                  <a:schemeClr val="accent1">
+                    <a:shade val="15000"/>
+                  </a:schemeClr>
+                </a:solidFill>
+                <a:prstDash val="solid"/>
+                <a:miter lim="800000"/>
+              </a14:hiddenLine>
+            </a:ext>
+          </a:extLst>
+        </p:spPr>
+        <p:style>
+          <a:lnRef idx="2">
+            <a:schemeClr val="accent1">
+              <a:shade val="15000"/>
+            </a:schemeClr>
+          </a:lnRef>
+          <a:fillRef idx="1">
+            <a:schemeClr val="accent1"/>
+          </a:fillRef>
+          <a:effectRef idx="0">
+            <a:schemeClr val="accent1"/>
+          </a:effectRef>
+          <a:fontRef idx="minor">
+            <a:schemeClr val="lt1"/>
+          </a:fontRef>
+        </p:style>
+        <p:txBody>
+          <a:bodyPr rtlCol="0" anchor="ctr"/>
+          <a:lstStyle/>
+          <a:p>
+            <a:pPr algn="ctr"/>
+            <a:endParaRPr lang="en-US"/>
+          </a:p>
+        </p:txBody>
+      </p:sp>
+      <p:sp>
+        <p:nvSpPr>
+          <p:cNvPr id="10" name="TextBox 9">
+            <a:extLst>
+              <a:ext uri="{FF2B5EF4-FFF2-40B4-BE49-F238E27FC236}">
+                <a16:creationId xmlns:a16="http://schemas.microsoft.com/office/drawing/2014/main" id="{A42B7561-162E-F761-4F3E-F2DBFB20B8F6}"/>
+              </a:ext>
+            </a:extLst>
+          </p:cNvPr>
+          <p:cNvSpPr txBox="1"/>
+          <p:nvPr/>
+        </p:nvSpPr>
+        <p:spPr>
+          <a:xfrm>
+            <a:off x="4394200" y="3225800"/>
+            <a:ext cx="2794000" cy="169277"/>
+          </a:xfrm>
+          <a:prstGeom prst="rect">
+            <a:avLst/>
+          </a:prstGeom>
+          <a:noFill/>
+        </p:spPr>
+        <p:txBody>
+          <a:bodyPr vert="horz" wrap="square" lIns="0" tIns="0" rIns="0" bIns="0" rtlCol="0">
+            <a:spAutoFit/>
+          </a:bodyPr>
+          <a:lstStyle/>
+          <a:p>
+            <a:r>
+              <a:rPr lang="en-US" sz="1100" b="1">
+                <a:solidFill>
+                  <a:srgbClr val="EB6834"/>
+                </a:solidFill>
+                <a:latin typeface="Calibri" panose="020F0502020204030204" pitchFamily="34" charset="0"/>
+              </a:rPr>
+              <a:t>Forecast -- 5 or 21 days</a:t>
+            </a:r>
+          </a:p>
+        </p:txBody>
+      </p:sp>
+      <p:sp>
+        <p:nvSpPr>
+          <p:cNvPr id="11" name="Rectangle: Rounded Corners 10">
+            <a:extLst>
+              <a:ext uri="{FF2B5EF4-FFF2-40B4-BE49-F238E27FC236}">
+                <a16:creationId xmlns:a16="http://schemas.microsoft.com/office/drawing/2014/main" id="{BD67BF88-5236-C3A4-3A8C-16FB4AA1DAE5}"/>
+              </a:ext>
+            </a:extLst>
+          </p:cNvPr>
+          <p:cNvSpPr/>
+          <p:nvPr/>
+        </p:nvSpPr>
+        <p:spPr>
+          <a:xfrm>
+            <a:off x="4394200" y="3581400"/>
+            <a:ext cx="1397000" cy="381000"/>
+          </a:xfrm>
+          <a:prstGeom prst="roundRect">
+            <a:avLst>
+              <a:gd name="adj" fmla="val 15000"/>
+            </a:avLst>
+          </a:prstGeom>
+          <a:solidFill>
+            <a:srgbClr val="EB6834"/>
+          </a:solidFill>
+          <a:ln w="19050" cap="flat" cmpd="sng" algn="ctr">
+            <a:noFill/>
+            <a:prstDash val="solid"/>
+            <a:miter lim="800000"/>
+          </a:ln>
+          <a:effectLst/>
+          <a:extLst>
+            <a:ext uri="{91240B29-F687-4F45-9708-019B960494DF}">
+              <a14:hiddenLine xmlns:a14="http://schemas.microsoft.com/office/drawing/2010/main" w="19050" cap="flat" cmpd="sng" algn="ctr">
+                <a:solidFill>
+                  <a:schemeClr val="accent1">
+                    <a:shade val="15000"/>
+                  </a:schemeClr>
+                </a:solidFill>
+                <a:prstDash val="solid"/>
+                <a:miter lim="800000"/>
+              </a14:hiddenLine>
+            </a:ext>
+          </a:extLst>
+        </p:spPr>
+        <p:style>
+          <a:lnRef idx="2">
+            <a:schemeClr val="accent1">
+              <a:shade val="15000"/>
+            </a:schemeClr>
+          </a:lnRef>
+          <a:fillRef idx="1">
+            <a:schemeClr val="accent1"/>
+          </a:fillRef>
+          <a:effectRef idx="0">
+            <a:schemeClr val="accent1"/>
+          </a:effectRef>
+          <a:fontRef idx="minor">
+            <a:schemeClr val="lt1"/>
+          </a:fontRef>
+        </p:style>
+        <p:txBody>
+          <a:bodyPr rtlCol="0" anchor="ctr"/>
+          <a:lstStyle/>
+          <a:p>
+            <a:pPr algn="ctr"/>
+            <a:endParaRPr lang="en-US"/>
+          </a:p>
+        </p:txBody>
+      </p:sp>
+      <p:sp>
+        <p:nvSpPr>
+          <p:cNvPr id="12" name="Oval 11">
+            <a:extLst>
+              <a:ext uri="{FF2B5EF4-FFF2-40B4-BE49-F238E27FC236}">
+                <a16:creationId xmlns:a16="http://schemas.microsoft.com/office/drawing/2014/main" id="{6E1DE92F-CE60-3145-4336-3988AC4D7134}"/>
+              </a:ext>
+            </a:extLst>
+          </p:cNvPr>
+          <p:cNvSpPr/>
+          <p:nvPr/>
+        </p:nvSpPr>
+        <p:spPr>
+          <a:xfrm>
+            <a:off x="4241800" y="4064000"/>
+            <a:ext cx="152400" cy="152400"/>
+          </a:xfrm>
+          <a:prstGeom prst="ellipse">
+            <a:avLst/>
+          </a:prstGeom>
+          <a:solidFill>
+            <a:srgbClr val="1E2761"/>
+          </a:solidFill>
+          <a:ln w="19050" cap="flat" cmpd="sng" algn="ctr">
+            <a:noFill/>
+            <a:prstDash val="solid"/>
+            <a:miter lim="800000"/>
+          </a:ln>
+          <a:effectLst/>
+          <a:extLst>
+            <a:ext uri="{91240B29-F687-4F45-9708-019B960494DF}">
+              <a14:hiddenLine xmlns:a14="http://schemas.microsoft.com/office/drawing/2010/main" w="19050" cap="flat" cmpd="sng" algn="ctr">
+                <a:solidFill>
+                  <a:schemeClr val="accent1">
+                    <a:shade val="15000"/>
+                  </a:schemeClr>
+                </a:solidFill>
+                <a:prstDash val="solid"/>
+                <a:miter lim="800000"/>
+              </a14:hiddenLine>
+            </a:ext>
+          </a:extLst>
+        </p:spPr>
+        <p:style>
+          <a:lnRef idx="2">
+            <a:schemeClr val="accent1">
+              <a:shade val="15000"/>
+            </a:schemeClr>
+          </a:lnRef>
+          <a:fillRef idx="1">
+            <a:schemeClr val="accent1"/>
+          </a:fillRef>
+          <a:effectRef idx="0">
+            <a:schemeClr val="accent1"/>
+          </a:effectRef>
+          <a:fontRef idx="minor">
+            <a:schemeClr val="lt1"/>
+          </a:fontRef>
+        </p:style>
+        <p:txBody>
+          <a:bodyPr rtlCol="0" anchor="ctr"/>
+          <a:lstStyle/>
+          <a:p>
+            <a:pPr algn="ctr"/>
+            <a:endParaRPr lang="en-US"/>
+          </a:p>
+        </p:txBody>
+      </p:sp>
+      <p:sp>
+        <p:nvSpPr>
+          <p:cNvPr id="13" name="TextBox 12">
+            <a:extLst>
+              <a:ext uri="{FF2B5EF4-FFF2-40B4-BE49-F238E27FC236}">
+                <a16:creationId xmlns:a16="http://schemas.microsoft.com/office/drawing/2014/main" id="{BBB51540-F97F-B812-B3BC-9FB0E41959D8}"/>
+              </a:ext>
+            </a:extLst>
+          </p:cNvPr>
+          <p:cNvSpPr txBox="1"/>
+          <p:nvPr/>
+        </p:nvSpPr>
+        <p:spPr>
+          <a:xfrm>
+            <a:off x="3429000" y="4267200"/>
+            <a:ext cx="2540000" cy="153888"/>
+          </a:xfrm>
+          <a:prstGeom prst="rect">
+            <a:avLst/>
+          </a:prstGeom>
+          <a:noFill/>
+        </p:spPr>
+        <p:txBody>
+          <a:bodyPr vert="horz" wrap="square" lIns="0" tIns="0" rIns="0" bIns="0" rtlCol="0">
+            <a:spAutoFit/>
+          </a:bodyPr>
+          <a:lstStyle/>
+          <a:p>
+            <a:r>
+              <a:rPr lang="en-US" sz="1000" i="1">
+                <a:solidFill>
+                  <a:srgbClr val="6B7280"/>
+                </a:solidFill>
+                <a:latin typeface="Calibri" panose="020F0502020204030204" pitchFamily="34" charset="0"/>
+              </a:rPr>
+              <a:t>Forecast origin</a:t>
+            </a:r>
+          </a:p>
+        </p:txBody>
+      </p:sp>
+      <p:sp>
+        <p:nvSpPr>
+          <p:cNvPr id="14" name="TextBox 13">
+            <a:extLst>
+              <a:ext uri="{FF2B5EF4-FFF2-40B4-BE49-F238E27FC236}">
+                <a16:creationId xmlns:a16="http://schemas.microsoft.com/office/drawing/2014/main" id="{45DEF69F-84D8-EAC0-A8C5-C8F7E9B8A149}"/>
+              </a:ext>
+            </a:extLst>
+          </p:cNvPr>
+          <p:cNvSpPr txBox="1"/>
+          <p:nvPr/>
+        </p:nvSpPr>
+        <p:spPr>
+          <a:xfrm>
+            <a:off x="508000" y="4521200"/>
+            <a:ext cx="5842000" cy="184666"/>
+          </a:xfrm>
+          <a:prstGeom prst="rect">
+            <a:avLst/>
+          </a:prstGeom>
+          <a:noFill/>
+        </p:spPr>
+        <p:txBody>
+          <a:bodyPr vert="horz" wrap="square" lIns="0" tIns="0" rIns="0" bIns="0" rtlCol="0">
+            <a:spAutoFit/>
+          </a:bodyPr>
+          <a:lstStyle/>
+          <a:p>
+            <a:r>
+              <a:rPr lang="en-US" sz="1200" i="1">
+                <a:solidFill>
+                  <a:srgbClr val="6B7280"/>
+                </a:solidFill>
+                <a:latin typeface="Calibri" panose="020F0502020204030204" pitchFamily="34" charset="0"/>
+              </a:rPr>
+              <a:t>Repeated at 60 rolling origins spanning 2005 -&gt; present</a:t>
+            </a:r>
+          </a:p>
+        </p:txBody>
+      </p:sp>
+      <p:sp>
+        <p:nvSpPr>
+          <p:cNvPr id="15" name="TextBox 14">
+            <a:extLst>
+              <a:ext uri="{FF2B5EF4-FFF2-40B4-BE49-F238E27FC236}">
+                <a16:creationId xmlns:a16="http://schemas.microsoft.com/office/drawing/2014/main" id="{3B060100-7CA5-A337-3BDD-C1E2CCCB22F3}"/>
+              </a:ext>
+            </a:extLst>
+          </p:cNvPr>
+          <p:cNvSpPr txBox="1"/>
+          <p:nvPr/>
+        </p:nvSpPr>
+        <p:spPr>
+          <a:xfrm>
+            <a:off x="508000" y="5029200"/>
+            <a:ext cx="5842000" cy="200055"/>
+          </a:xfrm>
+          <a:prstGeom prst="rect">
+            <a:avLst/>
+          </a:prstGeom>
+          <a:noFill/>
+        </p:spPr>
+        <p:txBody>
+          <a:bodyPr vert="horz" wrap="square" lIns="0" tIns="0" rIns="0" bIns="0" rtlCol="0">
+            <a:spAutoFit/>
+          </a:bodyPr>
+          <a:lstStyle/>
+          <a:p>
+            <a:r>
+              <a:rPr lang="en-US" sz="1300" b="1">
+                <a:solidFill>
+                  <a:srgbClr val="1E2761"/>
+                </a:solidFill>
+                <a:latin typeface="Calibri" panose="020F0502020204030204" pitchFamily="34" charset="0"/>
+              </a:rPr>
+              <a:t>Predicted for every window</a:t>
+            </a:r>
+          </a:p>
+        </p:txBody>
+      </p:sp>
+      <p:sp>
+        <p:nvSpPr>
+          <p:cNvPr id="16" name="Rectangle: Rounded Corners 15">
+            <a:extLst>
+              <a:ext uri="{FF2B5EF4-FFF2-40B4-BE49-F238E27FC236}">
+                <a16:creationId xmlns:a16="http://schemas.microsoft.com/office/drawing/2014/main" id="{DDF6AE24-FE6E-D6A2-23A5-666F6157A0C5}"/>
+              </a:ext>
+            </a:extLst>
+          </p:cNvPr>
+          <p:cNvSpPr/>
+          <p:nvPr/>
+        </p:nvSpPr>
+        <p:spPr>
+          <a:xfrm>
+            <a:off x="508000" y="5384800"/>
+            <a:ext cx="1841500" cy="812800"/>
+          </a:xfrm>
+          <a:prstGeom prst="roundRect">
+            <a:avLst>
+              <a:gd name="adj" fmla="val 12000"/>
             </a:avLst>
           </a:prstGeom>
           <a:solidFill>
@@ -8146,10 +9137,78 @@
       </p:sp>
       <p:sp>
         <p:nvSpPr>
-          <p:cNvPr id="8" name="TextBox 7">
-            <a:extLst>
-              <a:ext uri="{FF2B5EF4-FFF2-40B4-BE49-F238E27FC236}">
-                <a16:creationId xmlns:a16="http://schemas.microsoft.com/office/drawing/2014/main" id="{23A68FA7-211A-371A-3F83-A79C93EC2C15}"/>
+          <p:cNvPr id="17" name="Oval 16">
+            <a:extLst>
+              <a:ext uri="{FF2B5EF4-FFF2-40B4-BE49-F238E27FC236}">
+                <a16:creationId xmlns:a16="http://schemas.microsoft.com/office/drawing/2014/main" id="{1D6220A8-103C-56D2-1A03-4D82230EBD9A}"/>
+              </a:ext>
+            </a:extLst>
+          </p:cNvPr>
+          <p:cNvSpPr/>
+          <p:nvPr/>
+        </p:nvSpPr>
+        <p:spPr>
+          <a:xfrm>
+            <a:off x="685800" y="5562600"/>
+            <a:ext cx="152400" cy="152400"/>
+          </a:xfrm>
+          <a:prstGeom prst="ellipse">
+            <a:avLst/>
+          </a:prstGeom>
+          <a:solidFill>
+            <a:srgbClr val="2A78D6"/>
+          </a:solidFill>
+          <a:ln w="19050" cap="flat" cmpd="sng" algn="ctr">
+            <a:noFill/>
+            <a:prstDash val="solid"/>
+            <a:miter lim="800000"/>
+          </a:ln>
+          <a:effectLst/>
+          <a:extLst>
+            <a:ext uri="{91240B29-F687-4F45-9708-019B960494DF}">
+              <a14:hiddenLine xmlns:a14="http://schemas.microsoft.com/office/drawing/2010/main" w="19050" cap="flat" cmpd="sng" algn="ctr">
+                <a:solidFill>
+                  <a:schemeClr val="accent1">
+                    <a:shade val="15000"/>
+                  </a:schemeClr>
+                </a:solidFill>
+                <a:prstDash val="solid"/>
+                <a:miter lim="800000"/>
+              </a14:hiddenLine>
+            </a:ext>
+          </a:extLst>
+        </p:spPr>
+        <p:style>
+          <a:lnRef idx="2">
+            <a:schemeClr val="accent1">
+              <a:shade val="15000"/>
+            </a:schemeClr>
+          </a:lnRef>
+          <a:fillRef idx="1">
+            <a:schemeClr val="accent1"/>
+          </a:fillRef>
+          <a:effectRef idx="0">
+            <a:schemeClr val="accent1"/>
+          </a:effectRef>
+          <a:fontRef idx="minor">
+            <a:schemeClr val="lt1"/>
+          </a:fontRef>
+        </p:style>
+        <p:txBody>
+          <a:bodyPr rtlCol="0" anchor="ctr"/>
+          <a:lstStyle/>
+          <a:p>
+            <a:pPr algn="ctr"/>
+            <a:endParaRPr lang="en-US"/>
+          </a:p>
+        </p:txBody>
+      </p:sp>
+      <p:sp>
+        <p:nvSpPr>
+          <p:cNvPr id="18" name="TextBox 17">
+            <a:extLst>
+              <a:ext uri="{FF2B5EF4-FFF2-40B4-BE49-F238E27FC236}">
+                <a16:creationId xmlns:a16="http://schemas.microsoft.com/office/drawing/2014/main" id="{02E640E6-A799-3641-A504-56E5B0A3B718}"/>
               </a:ext>
             </a:extLst>
           </p:cNvPr>
@@ -8158,8 +9217,8 @@
         </p:nvSpPr>
         <p:spPr>
           <a:xfrm>
-            <a:off x="4584700" y="1676400"/>
-            <a:ext cx="3009900" cy="400110"/>
+            <a:off x="685800" y="5816600"/>
+            <a:ext cx="1485900" cy="184666"/>
           </a:xfrm>
           <a:prstGeom prst="rect">
             <a:avLst/>
@@ -8173,103 +9232,23 @@
           <a:lstStyle/>
           <a:p>
             <a:r>
-              <a:rPr lang="en-US" sz="2600" b="1">
-                <a:solidFill>
-                  <a:srgbClr val="1E2761"/>
-                </a:solidFill>
-                <a:latin typeface="Cambria" panose="02040503050406030204" pitchFamily="18" charset="0"/>
-              </a:rPr>
-              <a:t>^VIX</a:t>
-            </a:r>
-          </a:p>
-        </p:txBody>
-      </p:sp>
-      <p:sp>
-        <p:nvSpPr>
-          <p:cNvPr id="9" name="TextBox 8">
-            <a:extLst>
-              <a:ext uri="{FF2B5EF4-FFF2-40B4-BE49-F238E27FC236}">
-                <a16:creationId xmlns:a16="http://schemas.microsoft.com/office/drawing/2014/main" id="{3247D1A1-7A33-082B-743D-DBEDA95CBB62}"/>
-              </a:ext>
-            </a:extLst>
-          </p:cNvPr>
-          <p:cNvSpPr txBox="1"/>
-          <p:nvPr/>
-        </p:nvSpPr>
-        <p:spPr>
-          <a:xfrm>
-            <a:off x="4584700" y="2311400"/>
-            <a:ext cx="3009900" cy="215444"/>
-          </a:xfrm>
-          <a:prstGeom prst="rect">
-            <a:avLst/>
-          </a:prstGeom>
-          <a:noFill/>
-        </p:spPr>
-        <p:txBody>
-          <a:bodyPr vert="horz" wrap="square" lIns="0" tIns="0" rIns="0" bIns="0" rtlCol="0">
-            <a:spAutoFit/>
-          </a:bodyPr>
-          <a:lstStyle/>
-          <a:p>
-            <a:r>
-              <a:rPr lang="en-US" sz="1400" b="1">
+              <a:rPr lang="en-US" sz="1200" b="1">
                 <a:solidFill>
                   <a:srgbClr val="1A1A2E"/>
                 </a:solidFill>
                 <a:latin typeface="Calibri" panose="020F0502020204030204" pitchFamily="34" charset="0"/>
               </a:rPr>
-              <a:t>CBOE Volatility Index</a:t>
-            </a:r>
-          </a:p>
-        </p:txBody>
-      </p:sp>
-      <p:sp>
-        <p:nvSpPr>
-          <p:cNvPr id="10" name="TextBox 9">
-            <a:extLst>
-              <a:ext uri="{FF2B5EF4-FFF2-40B4-BE49-F238E27FC236}">
-                <a16:creationId xmlns:a16="http://schemas.microsoft.com/office/drawing/2014/main" id="{EA285624-5A9A-DA35-FC33-6CABB0810927}"/>
-              </a:ext>
-            </a:extLst>
-          </p:cNvPr>
-          <p:cNvSpPr txBox="1"/>
-          <p:nvPr/>
-        </p:nvSpPr>
-        <p:spPr>
-          <a:xfrm>
-            <a:off x="4584700" y="2667000"/>
-            <a:ext cx="3009900" cy="184666"/>
-          </a:xfrm>
-          <a:prstGeom prst="rect">
-            <a:avLst/>
-          </a:prstGeom>
-          <a:noFill/>
-        </p:spPr>
-        <p:txBody>
-          <a:bodyPr vert="horz" wrap="square" lIns="0" tIns="0" rIns="0" bIns="0" rtlCol="0">
-            <a:spAutoFit/>
-          </a:bodyPr>
-          <a:lstStyle/>
-          <a:p>
-            <a:r>
-              <a:rPr lang="en-US" sz="1200" i="1">
-                <a:solidFill>
-                  <a:srgbClr val="6B7280"/>
-                </a:solidFill>
-                <a:latin typeface="Calibri" panose="020F0502020204030204" pitchFamily="34" charset="0"/>
-              </a:rPr>
-              <a:t>Covariate (past-only)</a:t>
-            </a:r>
-          </a:p>
-        </p:txBody>
-      </p:sp>
-      <p:sp>
-        <p:nvSpPr>
-          <p:cNvPr id="11" name="Rectangle: Rounded Corners 10">
-            <a:extLst>
-              <a:ext uri="{FF2B5EF4-FFF2-40B4-BE49-F238E27FC236}">
-                <a16:creationId xmlns:a16="http://schemas.microsoft.com/office/drawing/2014/main" id="{F31FE4AD-8CD4-34F6-FE2E-87CB8BC68557}"/>
+              <a:t>Close price</a:t>
+            </a:r>
+          </a:p>
+        </p:txBody>
+      </p:sp>
+      <p:sp>
+        <p:nvSpPr>
+          <p:cNvPr id="19" name="Rectangle: Rounded Corners 18">
+            <a:extLst>
+              <a:ext uri="{FF2B5EF4-FFF2-40B4-BE49-F238E27FC236}">
+                <a16:creationId xmlns:a16="http://schemas.microsoft.com/office/drawing/2014/main" id="{2324B5DE-2D6D-84AE-FA10-C63BCD9F0584}"/>
               </a:ext>
             </a:extLst>
           </p:cNvPr>
@@ -8278,12 +9257,12 @@
         </p:nvSpPr>
         <p:spPr>
           <a:xfrm>
-            <a:off x="8153400" y="1397000"/>
-            <a:ext cx="3517900" cy="2159000"/>
+            <a:off x="2501900" y="5384800"/>
+            <a:ext cx="1841500" cy="812800"/>
           </a:xfrm>
           <a:prstGeom prst="roundRect">
             <a:avLst>
-              <a:gd name="adj" fmla="val 8000"/>
+              <a:gd name="adj" fmla="val 12000"/>
             </a:avLst>
           </a:prstGeom>
           <a:solidFill>
@@ -8342,130 +9321,10 @@
       </p:sp>
       <p:sp>
         <p:nvSpPr>
-          <p:cNvPr id="12" name="TextBox 11">
-            <a:extLst>
-              <a:ext uri="{FF2B5EF4-FFF2-40B4-BE49-F238E27FC236}">
-                <a16:creationId xmlns:a16="http://schemas.microsoft.com/office/drawing/2014/main" id="{2CFA58AD-AF8D-FF44-DC74-35D6F7A2608B}"/>
-              </a:ext>
-            </a:extLst>
-          </p:cNvPr>
-          <p:cNvSpPr txBox="1"/>
-          <p:nvPr/>
-        </p:nvSpPr>
-        <p:spPr>
-          <a:xfrm>
-            <a:off x="8407400" y="1676400"/>
-            <a:ext cx="3009900" cy="400110"/>
-          </a:xfrm>
-          <a:prstGeom prst="rect">
-            <a:avLst/>
-          </a:prstGeom>
-          <a:noFill/>
-        </p:spPr>
-        <p:txBody>
-          <a:bodyPr vert="horz" wrap="square" lIns="0" tIns="0" rIns="0" bIns="0" rtlCol="0">
-            <a:spAutoFit/>
-          </a:bodyPr>
-          <a:lstStyle/>
-          <a:p>
-            <a:r>
-              <a:rPr lang="en-US" sz="2600" b="1">
-                <a:solidFill>
-                  <a:srgbClr val="1E2761"/>
-                </a:solidFill>
-                <a:latin typeface="Cambria" panose="02040503050406030204" pitchFamily="18" charset="0"/>
-              </a:rPr>
-              <a:t>^TNX</a:t>
-            </a:r>
-          </a:p>
-        </p:txBody>
-      </p:sp>
-      <p:sp>
-        <p:nvSpPr>
-          <p:cNvPr id="13" name="TextBox 12">
-            <a:extLst>
-              <a:ext uri="{FF2B5EF4-FFF2-40B4-BE49-F238E27FC236}">
-                <a16:creationId xmlns:a16="http://schemas.microsoft.com/office/drawing/2014/main" id="{8724D6A9-FF1A-3EB8-E568-D42836A70C90}"/>
-              </a:ext>
-            </a:extLst>
-          </p:cNvPr>
-          <p:cNvSpPr txBox="1"/>
-          <p:nvPr/>
-        </p:nvSpPr>
-        <p:spPr>
-          <a:xfrm>
-            <a:off x="8407400" y="2311400"/>
-            <a:ext cx="3009900" cy="215444"/>
-          </a:xfrm>
-          <a:prstGeom prst="rect">
-            <a:avLst/>
-          </a:prstGeom>
-          <a:noFill/>
-        </p:spPr>
-        <p:txBody>
-          <a:bodyPr vert="horz" wrap="square" lIns="0" tIns="0" rIns="0" bIns="0" rtlCol="0">
-            <a:spAutoFit/>
-          </a:bodyPr>
-          <a:lstStyle/>
-          <a:p>
-            <a:r>
-              <a:rPr lang="en-US" sz="1400" b="1">
-                <a:solidFill>
-                  <a:srgbClr val="1A1A2E"/>
-                </a:solidFill>
-                <a:latin typeface="Calibri" panose="020F0502020204030204" pitchFamily="34" charset="0"/>
-              </a:rPr>
-              <a:t>10-Year Treasury Yield</a:t>
-            </a:r>
-          </a:p>
-        </p:txBody>
-      </p:sp>
-      <p:sp>
-        <p:nvSpPr>
-          <p:cNvPr id="14" name="TextBox 13">
-            <a:extLst>
-              <a:ext uri="{FF2B5EF4-FFF2-40B4-BE49-F238E27FC236}">
-                <a16:creationId xmlns:a16="http://schemas.microsoft.com/office/drawing/2014/main" id="{7ACD4CD8-6630-A3BC-44F4-7725FFD8991E}"/>
-              </a:ext>
-            </a:extLst>
-          </p:cNvPr>
-          <p:cNvSpPr txBox="1"/>
-          <p:nvPr/>
-        </p:nvSpPr>
-        <p:spPr>
-          <a:xfrm>
-            <a:off x="8407400" y="2667000"/>
-            <a:ext cx="3009900" cy="184666"/>
-          </a:xfrm>
-          <a:prstGeom prst="rect">
-            <a:avLst/>
-          </a:prstGeom>
-          <a:noFill/>
-        </p:spPr>
-        <p:txBody>
-          <a:bodyPr vert="horz" wrap="square" lIns="0" tIns="0" rIns="0" bIns="0" rtlCol="0">
-            <a:spAutoFit/>
-          </a:bodyPr>
-          <a:lstStyle/>
-          <a:p>
-            <a:r>
-              <a:rPr lang="en-US" sz="1200" i="1">
-                <a:solidFill>
-                  <a:srgbClr val="6B7280"/>
-                </a:solidFill>
-                <a:latin typeface="Calibri" panose="020F0502020204030204" pitchFamily="34" charset="0"/>
-              </a:rPr>
-              <a:t>Covariate (past-only)</a:t>
-            </a:r>
-          </a:p>
-        </p:txBody>
-      </p:sp>
-      <p:sp>
-        <p:nvSpPr>
-          <p:cNvPr id="15" name="Rectangle 14">
-            <a:extLst>
-              <a:ext uri="{FF2B5EF4-FFF2-40B4-BE49-F238E27FC236}">
-                <a16:creationId xmlns:a16="http://schemas.microsoft.com/office/drawing/2014/main" id="{3B5A0C7F-DFBE-0DE5-519E-CB513D7315D8}"/>
+          <p:cNvPr id="20" name="Oval 19">
+            <a:extLst>
+              <a:ext uri="{FF2B5EF4-FFF2-40B4-BE49-F238E27FC236}">
+                <a16:creationId xmlns:a16="http://schemas.microsoft.com/office/drawing/2014/main" id="{BBA14E74-2668-A133-395A-C43EEA12ED9E}"/>
               </a:ext>
             </a:extLst>
           </p:cNvPr>
@@ -8474,14 +9333,14 @@
         </p:nvSpPr>
         <p:spPr>
           <a:xfrm>
-            <a:off x="1270000" y="5334000"/>
-            <a:ext cx="9652000" cy="50800"/>
-          </a:xfrm>
-          <a:prstGeom prst="rect">
+            <a:off x="2679700" y="5562600"/>
+            <a:ext cx="152400" cy="152400"/>
+          </a:xfrm>
+          <a:prstGeom prst="ellipse">
             <a:avLst/>
           </a:prstGeom>
           <a:solidFill>
-            <a:srgbClr val="CADCFC"/>
+            <a:srgbClr val="EB6834"/>
           </a:solidFill>
           <a:ln w="19050" cap="flat" cmpd="sng" algn="ctr">
             <a:noFill/>
@@ -8530,10 +9389,50 @@
       </p:sp>
       <p:sp>
         <p:nvSpPr>
-          <p:cNvPr id="16" name="Oval 15">
-            <a:extLst>
-              <a:ext uri="{FF2B5EF4-FFF2-40B4-BE49-F238E27FC236}">
-                <a16:creationId xmlns:a16="http://schemas.microsoft.com/office/drawing/2014/main" id="{9302A855-0577-E4CC-D14F-E29951316DB5}"/>
+          <p:cNvPr id="21" name="TextBox 20">
+            <a:extLst>
+              <a:ext uri="{FF2B5EF4-FFF2-40B4-BE49-F238E27FC236}">
+                <a16:creationId xmlns:a16="http://schemas.microsoft.com/office/drawing/2014/main" id="{223BE7C1-C281-A979-04C9-8AC4C378CD7D}"/>
+              </a:ext>
+            </a:extLst>
+          </p:cNvPr>
+          <p:cNvSpPr txBox="1"/>
+          <p:nvPr/>
+        </p:nvSpPr>
+        <p:spPr>
+          <a:xfrm>
+            <a:off x="2679700" y="5816600"/>
+            <a:ext cx="1485900" cy="184666"/>
+          </a:xfrm>
+          <a:prstGeom prst="rect">
+            <a:avLst/>
+          </a:prstGeom>
+          <a:noFill/>
+        </p:spPr>
+        <p:txBody>
+          <a:bodyPr vert="horz" wrap="square" lIns="0" tIns="0" rIns="0" bIns="0" rtlCol="0">
+            <a:spAutoFit/>
+          </a:bodyPr>
+          <a:lstStyle/>
+          <a:p>
+            <a:r>
+              <a:rPr lang="en-US" sz="1200" b="1">
+                <a:solidFill>
+                  <a:srgbClr val="1A1A2E"/>
+                </a:solidFill>
+                <a:latin typeface="Calibri" panose="020F0502020204030204" pitchFamily="34" charset="0"/>
+              </a:rPr>
+              <a:t>Simple return</a:t>
+            </a:r>
+          </a:p>
+        </p:txBody>
+      </p:sp>
+      <p:sp>
+        <p:nvSpPr>
+          <p:cNvPr id="22" name="Rectangle: Rounded Corners 21">
+            <a:extLst>
+              <a:ext uri="{FF2B5EF4-FFF2-40B4-BE49-F238E27FC236}">
+                <a16:creationId xmlns:a16="http://schemas.microsoft.com/office/drawing/2014/main" id="{F6736E73-652B-CBC1-497D-59E741A91703}"/>
               </a:ext>
             </a:extLst>
           </p:cNvPr>
@@ -8542,21 +9441,29 @@
         </p:nvSpPr>
         <p:spPr>
           <a:xfrm>
-            <a:off x="1219200" y="5257800"/>
-            <a:ext cx="203200" cy="203200"/>
-          </a:xfrm>
-          <a:prstGeom prst="ellipse">
-            <a:avLst/>
+            <a:off x="4495800" y="5384800"/>
+            <a:ext cx="1841500" cy="812800"/>
+          </a:xfrm>
+          <a:prstGeom prst="roundRect">
+            <a:avLst>
+              <a:gd name="adj" fmla="val 12000"/>
+            </a:avLst>
           </a:prstGeom>
           <a:solidFill>
-            <a:srgbClr val="1E2761"/>
+            <a:srgbClr val="F4F6FB"/>
           </a:solidFill>
           <a:ln w="19050" cap="flat" cmpd="sng" algn="ctr">
             <a:noFill/>
             <a:prstDash val="solid"/>
             <a:miter lim="800000"/>
           </a:ln>
-          <a:effectLst/>
+          <a:effectLst>
+            <a:innerShdw blurRad="127000" dist="38100" dir="5400000">
+              <a:srgbClr val="888888">
+                <a:alpha val="25000"/>
+              </a:srgbClr>
+            </a:innerShdw>
+          </a:effectLst>
           <a:extLst>
             <a:ext uri="{91240B29-F687-4F45-9708-019B960494DF}">
               <a14:hiddenLine xmlns:a14="http://schemas.microsoft.com/office/drawing/2010/main" w="19050" cap="flat" cmpd="sng" algn="ctr">
@@ -8598,10 +9505,10 @@
       </p:sp>
       <p:sp>
         <p:nvSpPr>
-          <p:cNvPr id="17" name="Oval 16">
-            <a:extLst>
-              <a:ext uri="{FF2B5EF4-FFF2-40B4-BE49-F238E27FC236}">
-                <a16:creationId xmlns:a16="http://schemas.microsoft.com/office/drawing/2014/main" id="{4E6B8BFD-1264-326C-ED2A-687D47F29F58}"/>
+          <p:cNvPr id="23" name="Oval 22">
+            <a:extLst>
+              <a:ext uri="{FF2B5EF4-FFF2-40B4-BE49-F238E27FC236}">
+                <a16:creationId xmlns:a16="http://schemas.microsoft.com/office/drawing/2014/main" id="{7D8378AF-72E6-4E6D-F55F-52D51FE49A17}"/>
               </a:ext>
             </a:extLst>
           </p:cNvPr>
@@ -8610,14 +9517,14 @@
         </p:nvSpPr>
         <p:spPr>
           <a:xfrm>
-            <a:off x="10769600" y="5257800"/>
-            <a:ext cx="203200" cy="203200"/>
+            <a:off x="4673600" y="5562600"/>
+            <a:ext cx="152400" cy="152400"/>
           </a:xfrm>
           <a:prstGeom prst="ellipse">
             <a:avLst/>
           </a:prstGeom>
           <a:solidFill>
-            <a:srgbClr val="1E2761"/>
+            <a:srgbClr val="1BAF7A"/>
           </a:solidFill>
           <a:ln w="19050" cap="flat" cmpd="sng" algn="ctr">
             <a:noFill/>
@@ -8666,10 +9573,10 @@
       </p:sp>
       <p:sp>
         <p:nvSpPr>
-          <p:cNvPr id="18" name="TextBox 17">
-            <a:extLst>
-              <a:ext uri="{FF2B5EF4-FFF2-40B4-BE49-F238E27FC236}">
-                <a16:creationId xmlns:a16="http://schemas.microsoft.com/office/drawing/2014/main" id="{FBF4CA03-FE01-31C2-1A2C-EDA380EBE604}"/>
+          <p:cNvPr id="24" name="TextBox 23">
+            <a:extLst>
+              <a:ext uri="{FF2B5EF4-FFF2-40B4-BE49-F238E27FC236}">
+                <a16:creationId xmlns:a16="http://schemas.microsoft.com/office/drawing/2014/main" id="{D5B90DD5-A2C1-95E0-83B0-6D6F6753400C}"/>
               </a:ext>
             </a:extLst>
           </p:cNvPr>
@@ -8678,8 +9585,8 @@
         </p:nvSpPr>
         <p:spPr>
           <a:xfrm>
-            <a:off x="762000" y="5435600"/>
-            <a:ext cx="1778000" cy="184666"/>
+            <a:off x="4673600" y="5816600"/>
+            <a:ext cx="1485900" cy="184666"/>
           </a:xfrm>
           <a:prstGeom prst="rect">
             <a:avLst/>
@@ -8692,25 +9599,60 @@
           </a:bodyPr>
           <a:lstStyle/>
           <a:p>
-            <a:pPr algn="ctr"/>
             <a:r>
               <a:rPr lang="en-US" sz="1200" b="1">
                 <a:solidFill>
-                  <a:srgbClr val="1E2761"/>
+                  <a:srgbClr val="1A1A2E"/>
                 </a:solidFill>
                 <a:latin typeface="Calibri" panose="020F0502020204030204" pitchFamily="34" charset="0"/>
               </a:rPr>
-              <a:t>2005-01-01</a:t>
-            </a:r>
-          </a:p>
-        </p:txBody>
-      </p:sp>
-      <p:sp>
-        <p:nvSpPr>
-          <p:cNvPr id="19" name="TextBox 18">
-            <a:extLst>
-              <a:ext uri="{FF2B5EF4-FFF2-40B4-BE49-F238E27FC236}">
-                <a16:creationId xmlns:a16="http://schemas.microsoft.com/office/drawing/2014/main" id="{FD647B0E-B6C3-F546-D661-E5E3365FA62F}"/>
+              <a:t>Log return</a:t>
+            </a:r>
+          </a:p>
+        </p:txBody>
+      </p:sp>
+      <p:pic>
+        <p:nvPicPr>
+          <p:cNvPr id="26" name="Picture 25">
+            <a:extLst>
+              <a:ext uri="{FF2B5EF4-FFF2-40B4-BE49-F238E27FC236}">
+                <a16:creationId xmlns:a16="http://schemas.microsoft.com/office/drawing/2014/main" id="{9D5F2B02-4B67-56C8-8A9D-2EF3DA8B9352}"/>
+              </a:ext>
+            </a:extLst>
+          </p:cNvPr>
+          <p:cNvPicPr>
+            <a:picLocks/>
+          </p:cNvPicPr>
+          <p:nvPr/>
+        </p:nvPicPr>
+        <p:blipFill>
+          <a:blip r:embed="rId2">
+            <a:extLst>
+              <a:ext uri="{28A0092B-C50C-407E-A947-70E740481C1C}">
+                <a14:useLocalDpi xmlns:a14="http://schemas.microsoft.com/office/drawing/2010/main" val="0"/>
+              </a:ext>
+            </a:extLst>
+          </a:blip>
+          <a:stretch>
+            <a:fillRect/>
+          </a:stretch>
+        </p:blipFill>
+        <p:spPr>
+          <a:xfrm>
+            <a:off x="6731000" y="1270000"/>
+            <a:ext cx="5080000" cy="4368800"/>
+          </a:xfrm>
+          <a:prstGeom prst="rect">
+            <a:avLst/>
+          </a:prstGeom>
+        </p:spPr>
+      </p:pic>
+      <p:sp>
+        <p:nvSpPr>
+          <p:cNvPr id="27" name="TextBox 26">
+            <a:extLst>
+              <a:ext uri="{FF2B5EF4-FFF2-40B4-BE49-F238E27FC236}">
+                <a16:creationId xmlns:a16="http://schemas.microsoft.com/office/drawing/2014/main" id="{6F0548C3-2283-B30F-EC08-DC2973B08D30}"/>
               </a:ext>
             </a:extLst>
           </p:cNvPr>
@@ -8719,8 +9661,8 @@
         </p:nvSpPr>
         <p:spPr>
           <a:xfrm>
-            <a:off x="9652000" y="5435600"/>
-            <a:ext cx="1778000" cy="184666"/>
+            <a:off x="6731000" y="5740400"/>
+            <a:ext cx="5080000" cy="169277"/>
           </a:xfrm>
           <a:prstGeom prst="rect">
             <a:avLst/>
@@ -8735,107 +9677,21 @@
           <a:p>
             <a:pPr algn="ctr"/>
             <a:r>
-              <a:rPr lang="en-US" sz="1200" b="1">
-                <a:solidFill>
-                  <a:srgbClr val="1E2761"/>
+              <a:rPr lang="en-US" sz="1100" i="1">
+                <a:solidFill>
+                  <a:srgbClr val="6B7280"/>
                 </a:solidFill>
                 <a:latin typeface="Calibri" panose="020F0502020204030204" pitchFamily="34" charset="0"/>
               </a:rPr>
-              <a:t>Present</a:t>
-            </a:r>
-          </a:p>
-        </p:txBody>
-      </p:sp>
-      <p:sp>
-        <p:nvSpPr>
-          <p:cNvPr id="20" name="TextBox 19">
-            <a:extLst>
-              <a:ext uri="{FF2B5EF4-FFF2-40B4-BE49-F238E27FC236}">
-                <a16:creationId xmlns:a16="http://schemas.microsoft.com/office/drawing/2014/main" id="{D6995F9A-4B74-7535-1F7F-43F1F53C397C}"/>
-              </a:ext>
-            </a:extLst>
-          </p:cNvPr>
-          <p:cNvSpPr txBox="1"/>
-          <p:nvPr/>
-        </p:nvSpPr>
-        <p:spPr>
-          <a:xfrm>
-            <a:off x="508000" y="5918200"/>
-            <a:ext cx="11176000" cy="184666"/>
-          </a:xfrm>
-          <a:prstGeom prst="rect">
-            <a:avLst/>
-          </a:prstGeom>
-          <a:noFill/>
-        </p:spPr>
-        <p:txBody>
-          <a:bodyPr vert="horz" wrap="square" lIns="0" tIns="0" rIns="0" bIns="0" rtlCol="0">
-            <a:spAutoFit/>
-          </a:bodyPr>
-          <a:lstStyle/>
-          <a:p>
-            <a:r>
-              <a:rPr lang="en-US" sz="1200" i="1">
-                <a:solidFill>
-                  <a:srgbClr val="6B7280"/>
-                </a:solidFill>
-                <a:latin typeface="Calibri" panose="020F0502020204030204" pitchFamily="34" charset="0"/>
-              </a:rPr>
-              <a:t>Refetched live via yfinance at run time -- always ends at today.</a:t>
-            </a:r>
-          </a:p>
-        </p:txBody>
-      </p:sp>
-      <p:sp>
-        <p:nvSpPr>
-          <p:cNvPr id="21" name="TextBox 20">
-            <a:extLst>
-              <a:ext uri="{FF2B5EF4-FFF2-40B4-BE49-F238E27FC236}">
-                <a16:creationId xmlns:a16="http://schemas.microsoft.com/office/drawing/2014/main" id="{57DE7740-0CC2-A3E6-0D89-38E583873BBF}"/>
-              </a:ext>
-            </a:extLst>
-          </p:cNvPr>
-          <p:cNvSpPr txBox="1"/>
-          <p:nvPr/>
-        </p:nvSpPr>
-        <p:spPr>
-          <a:xfrm>
-            <a:off x="508000" y="6273800"/>
-            <a:ext cx="11176000" cy="169277"/>
-          </a:xfrm>
-          <a:prstGeom prst="rect">
-            <a:avLst/>
-          </a:prstGeom>
-          <a:noFill/>
-        </p:spPr>
-        <p:txBody>
-          <a:bodyPr vert="horz" wrap="square" lIns="0" tIns="0" rIns="0" bIns="0" rtlCol="0">
-            <a:spAutoFit/>
-          </a:bodyPr>
-          <a:lstStyle/>
-          <a:p>
-            <a:r>
-              <a:rPr lang="fr-FR" sz="1100">
-                <a:solidFill>
-                  <a:srgbClr val="6B7280"/>
-                </a:solidFill>
-                <a:latin typeface="Calibri" panose="020F0502020204030204" pitchFamily="34" charset="0"/>
-              </a:rPr>
-              <a:t>Source: Yahoo Finance (via yfinance)</a:t>
-            </a:r>
-            <a:endParaRPr lang="en-US" sz="1100">
-              <a:solidFill>
-                <a:srgbClr val="6B7280"/>
-              </a:solidFill>
-              <a:latin typeface="Calibri" panose="020F0502020204030204" pitchFamily="34" charset="0"/>
-            </a:endParaRPr>
+              <a:t>Real example -- history (solid) into naive / zero-shot forecast</a:t>
+            </a:r>
           </a:p>
         </p:txBody>
       </p:sp>
     </p:spTree>
     <p:extLst>
       <p:ext uri="{BB962C8B-B14F-4D97-AF65-F5344CB8AC3E}">
-        <p14:creationId xmlns:p14="http://schemas.microsoft.com/office/powerpoint/2010/main" val="2842351651"/>
+        <p14:creationId xmlns:p14="http://schemas.microsoft.com/office/powerpoint/2010/main" val="2615087431"/>
       </p:ext>
     </p:extLst>
   </p:cSld>
@@ -8875,7 +9731,7 @@
           <p:cNvPr id="2" name="TextBox 1">
             <a:extLst>
               <a:ext uri="{FF2B5EF4-FFF2-40B4-BE49-F238E27FC236}">
-                <a16:creationId xmlns:a16="http://schemas.microsoft.com/office/drawing/2014/main" id="{B3A54190-1EDE-E330-D4B3-6ECDB5837436}"/>
+                <a16:creationId xmlns:a16="http://schemas.microsoft.com/office/drawing/2014/main" id="{9E775E37-2B39-ACEE-D294-EDD719B7CDB6}"/>
               </a:ext>
             </a:extLst>
           </p:cNvPr>
@@ -8915,7 +9771,7 @@
           <p:cNvPr id="3" name="Rectangle: Rounded Corners 2">
             <a:extLst>
               <a:ext uri="{FF2B5EF4-FFF2-40B4-BE49-F238E27FC236}">
-                <a16:creationId xmlns:a16="http://schemas.microsoft.com/office/drawing/2014/main" id="{33C5F064-14A0-DA18-783C-72CFA68E9C98}"/>
+                <a16:creationId xmlns:a16="http://schemas.microsoft.com/office/drawing/2014/main" id="{E848A154-4374-9C44-DA2E-A7F899CB1DA6}"/>
               </a:ext>
             </a:extLst>
           </p:cNvPr>
@@ -8991,7 +9847,7 @@
           <p:cNvPr id="4" name="TextBox 3">
             <a:extLst>
               <a:ext uri="{FF2B5EF4-FFF2-40B4-BE49-F238E27FC236}">
-                <a16:creationId xmlns:a16="http://schemas.microsoft.com/office/drawing/2014/main" id="{E1D7926F-2550-2063-26DB-E059DF84B277}"/>
+                <a16:creationId xmlns:a16="http://schemas.microsoft.com/office/drawing/2014/main" id="{7134B6E4-E6A0-73FC-F82A-45D23E30D1E3}"/>
               </a:ext>
             </a:extLst>
           </p:cNvPr>
@@ -9032,7 +9888,7 @@
           <p:cNvPr id="5" name="TextBox 4">
             <a:extLst>
               <a:ext uri="{FF2B5EF4-FFF2-40B4-BE49-F238E27FC236}">
-                <a16:creationId xmlns:a16="http://schemas.microsoft.com/office/drawing/2014/main" id="{C91CE1B2-9DB9-ACB7-463F-EA74EDFD267D}"/>
+                <a16:creationId xmlns:a16="http://schemas.microsoft.com/office/drawing/2014/main" id="{A0FF501C-22D0-0241-7280-AFFCBE5CDF11}"/>
               </a:ext>
             </a:extLst>
           </p:cNvPr>
@@ -9073,7 +9929,7 @@
           <p:cNvPr id="6" name="Rectangle: Rounded Corners 5">
             <a:extLst>
               <a:ext uri="{FF2B5EF4-FFF2-40B4-BE49-F238E27FC236}">
-                <a16:creationId xmlns:a16="http://schemas.microsoft.com/office/drawing/2014/main" id="{3881267E-2606-123E-0C5A-0930784C3EF9}"/>
+                <a16:creationId xmlns:a16="http://schemas.microsoft.com/office/drawing/2014/main" id="{0FA66CC6-A959-338F-25FC-88FF7327CE28}"/>
               </a:ext>
             </a:extLst>
           </p:cNvPr>
@@ -9149,7 +10005,7 @@
           <p:cNvPr id="7" name="TextBox 6">
             <a:extLst>
               <a:ext uri="{FF2B5EF4-FFF2-40B4-BE49-F238E27FC236}">
-                <a16:creationId xmlns:a16="http://schemas.microsoft.com/office/drawing/2014/main" id="{9E7F8C1A-F646-DA74-0CB8-C1AF3011DD19}"/>
+                <a16:creationId xmlns:a16="http://schemas.microsoft.com/office/drawing/2014/main" id="{2F9F9CA9-7303-3713-D241-BD0F613DAE13}"/>
               </a:ext>
             </a:extLst>
           </p:cNvPr>
@@ -9190,7 +10046,7 @@
           <p:cNvPr id="8" name="TextBox 7">
             <a:extLst>
               <a:ext uri="{FF2B5EF4-FFF2-40B4-BE49-F238E27FC236}">
-                <a16:creationId xmlns:a16="http://schemas.microsoft.com/office/drawing/2014/main" id="{6B8DB88A-85A7-D6FE-10FD-A6CB662E6106}"/>
+                <a16:creationId xmlns:a16="http://schemas.microsoft.com/office/drawing/2014/main" id="{CC8C3629-6864-548D-BCD8-FCF73D1906C1}"/>
               </a:ext>
             </a:extLst>
           </p:cNvPr>
@@ -9231,7 +10087,7 @@
           <p:cNvPr id="9" name="Rectangle: Rounded Corners 8">
             <a:extLst>
               <a:ext uri="{FF2B5EF4-FFF2-40B4-BE49-F238E27FC236}">
-                <a16:creationId xmlns:a16="http://schemas.microsoft.com/office/drawing/2014/main" id="{D8EB0886-955D-F27D-D5D4-A2700CB4079B}"/>
+                <a16:creationId xmlns:a16="http://schemas.microsoft.com/office/drawing/2014/main" id="{CDCF1EF9-FB67-9654-58ED-216FFA949784}"/>
               </a:ext>
             </a:extLst>
           </p:cNvPr>
@@ -9307,7 +10163,7 @@
           <p:cNvPr id="10" name="TextBox 9">
             <a:extLst>
               <a:ext uri="{FF2B5EF4-FFF2-40B4-BE49-F238E27FC236}">
-                <a16:creationId xmlns:a16="http://schemas.microsoft.com/office/drawing/2014/main" id="{AFCD1272-68BA-DEEF-8B1A-C8402412E720}"/>
+                <a16:creationId xmlns:a16="http://schemas.microsoft.com/office/drawing/2014/main" id="{A26C3485-F37C-53A7-A95D-112226813734}"/>
               </a:ext>
             </a:extLst>
           </p:cNvPr>
@@ -9348,7 +10204,7 @@
           <p:cNvPr id="11" name="TextBox 10">
             <a:extLst>
               <a:ext uri="{FF2B5EF4-FFF2-40B4-BE49-F238E27FC236}">
-                <a16:creationId xmlns:a16="http://schemas.microsoft.com/office/drawing/2014/main" id="{E0D8178D-D067-DC1E-069F-E1A324E82578}"/>
+                <a16:creationId xmlns:a16="http://schemas.microsoft.com/office/drawing/2014/main" id="{F3225F5D-F573-4E08-A7DB-2101DD678BBF}"/>
               </a:ext>
             </a:extLst>
           </p:cNvPr>
@@ -9389,7 +10245,7 @@
           <p:cNvPr id="12" name="Rectangle: Rounded Corners 11">
             <a:extLst>
               <a:ext uri="{FF2B5EF4-FFF2-40B4-BE49-F238E27FC236}">
-                <a16:creationId xmlns:a16="http://schemas.microsoft.com/office/drawing/2014/main" id="{98101E22-7F23-54FF-70B3-97202CE94629}"/>
+                <a16:creationId xmlns:a16="http://schemas.microsoft.com/office/drawing/2014/main" id="{1D190F22-8026-6321-3804-67CDF47A526E}"/>
               </a:ext>
             </a:extLst>
           </p:cNvPr>
@@ -9465,7 +10321,7 @@
           <p:cNvPr id="13" name="TextBox 12">
             <a:extLst>
               <a:ext uri="{FF2B5EF4-FFF2-40B4-BE49-F238E27FC236}">
-                <a16:creationId xmlns:a16="http://schemas.microsoft.com/office/drawing/2014/main" id="{283A5211-B79C-3C7A-CFB6-A8DBBE10A0C4}"/>
+                <a16:creationId xmlns:a16="http://schemas.microsoft.com/office/drawing/2014/main" id="{70BFD417-0B9E-1DE0-6C47-93B8FC918E6A}"/>
               </a:ext>
             </a:extLst>
           </p:cNvPr>
@@ -9506,7 +10362,7 @@
           <p:cNvPr id="14" name="TextBox 13">
             <a:extLst>
               <a:ext uri="{FF2B5EF4-FFF2-40B4-BE49-F238E27FC236}">
-                <a16:creationId xmlns:a16="http://schemas.microsoft.com/office/drawing/2014/main" id="{D39F7CDE-6E08-3BB9-3560-47597C1A1DD8}"/>
+                <a16:creationId xmlns:a16="http://schemas.microsoft.com/office/drawing/2014/main" id="{0182A662-F94A-1E35-42F5-5F77220FFBBC}"/>
               </a:ext>
             </a:extLst>
           </p:cNvPr>
@@ -9547,7 +10403,7 @@
           <p:cNvPr id="15" name="Rectangle: Rounded Corners 14">
             <a:extLst>
               <a:ext uri="{FF2B5EF4-FFF2-40B4-BE49-F238E27FC236}">
-                <a16:creationId xmlns:a16="http://schemas.microsoft.com/office/drawing/2014/main" id="{473DEA30-9703-7D05-4A24-286F24A4E914}"/>
+                <a16:creationId xmlns:a16="http://schemas.microsoft.com/office/drawing/2014/main" id="{F0876A0D-0C8C-2C20-E44A-F587A30AFF70}"/>
               </a:ext>
             </a:extLst>
           </p:cNvPr>
@@ -9623,7 +10479,7 @@
           <p:cNvPr id="16" name="TextBox 15">
             <a:extLst>
               <a:ext uri="{FF2B5EF4-FFF2-40B4-BE49-F238E27FC236}">
-                <a16:creationId xmlns:a16="http://schemas.microsoft.com/office/drawing/2014/main" id="{18732CFD-D882-58D1-D513-7E66FE977206}"/>
+                <a16:creationId xmlns:a16="http://schemas.microsoft.com/office/drawing/2014/main" id="{EC7C1F50-A9CC-C735-1A88-D5E8E6FA8DB3}"/>
               </a:ext>
             </a:extLst>
           </p:cNvPr>
@@ -9664,7 +10520,7 @@
           <p:cNvPr id="17" name="TextBox 16">
             <a:extLst>
               <a:ext uri="{FF2B5EF4-FFF2-40B4-BE49-F238E27FC236}">
-                <a16:creationId xmlns:a16="http://schemas.microsoft.com/office/drawing/2014/main" id="{47FCA101-2048-328D-A37C-9422C7559E10}"/>
+                <a16:creationId xmlns:a16="http://schemas.microsoft.com/office/drawing/2014/main" id="{0B369624-F841-86F9-BE70-80B8DC9A6EB5}"/>
               </a:ext>
             </a:extLst>
           </p:cNvPr>
@@ -9705,7 +10561,7 @@
           <p:cNvPr id="18" name="Rectangle: Rounded Corners 17">
             <a:extLst>
               <a:ext uri="{FF2B5EF4-FFF2-40B4-BE49-F238E27FC236}">
-                <a16:creationId xmlns:a16="http://schemas.microsoft.com/office/drawing/2014/main" id="{C75B31D8-D77C-9A85-E327-34CCE4B33B15}"/>
+                <a16:creationId xmlns:a16="http://schemas.microsoft.com/office/drawing/2014/main" id="{23CB8387-D6E7-AE32-513B-DAF2C36D2FE7}"/>
               </a:ext>
             </a:extLst>
           </p:cNvPr>
@@ -9781,7 +10637,7 @@
           <p:cNvPr id="19" name="TextBox 18">
             <a:extLst>
               <a:ext uri="{FF2B5EF4-FFF2-40B4-BE49-F238E27FC236}">
-                <a16:creationId xmlns:a16="http://schemas.microsoft.com/office/drawing/2014/main" id="{346A274C-B4B8-BD87-A63A-BF3BD99BBDFF}"/>
+                <a16:creationId xmlns:a16="http://schemas.microsoft.com/office/drawing/2014/main" id="{BB9143BF-8479-5D59-0BED-E57392014A90}"/>
               </a:ext>
             </a:extLst>
           </p:cNvPr>
@@ -9822,7 +10678,7 @@
           <p:cNvPr id="20" name="TextBox 19">
             <a:extLst>
               <a:ext uri="{FF2B5EF4-FFF2-40B4-BE49-F238E27FC236}">
-                <a16:creationId xmlns:a16="http://schemas.microsoft.com/office/drawing/2014/main" id="{9187689B-459F-C718-8213-380AF6CB3E97}"/>
+                <a16:creationId xmlns:a16="http://schemas.microsoft.com/office/drawing/2014/main" id="{BC7C94F4-2247-FAC6-0C69-100AABCFAB75}"/>
               </a:ext>
             </a:extLst>
           </p:cNvPr>
@@ -9861,7 +10717,7 @@
     </p:spTree>
     <p:extLst>
       <p:ext uri="{BB962C8B-B14F-4D97-AF65-F5344CB8AC3E}">
-        <p14:creationId xmlns:p14="http://schemas.microsoft.com/office/powerpoint/2010/main" val="3099436200"/>
+        <p14:creationId xmlns:p14="http://schemas.microsoft.com/office/powerpoint/2010/main" val="2725829632"/>
       </p:ext>
     </p:extLst>
   </p:cSld>
@@ -9901,7 +10757,7 @@
           <p:cNvPr id="2" name="Oval 1">
             <a:extLst>
               <a:ext uri="{FF2B5EF4-FFF2-40B4-BE49-F238E27FC236}">
-                <a16:creationId xmlns:a16="http://schemas.microsoft.com/office/drawing/2014/main" id="{416EBC48-58E5-B623-C628-D0E67B3708EE}"/>
+                <a16:creationId xmlns:a16="http://schemas.microsoft.com/office/drawing/2014/main" id="{F5BF4092-9277-5990-3A7A-167BBB4D1D7D}"/>
               </a:ext>
             </a:extLst>
           </p:cNvPr>
@@ -9969,7 +10825,7 @@
           <p:cNvPr id="3" name="TextBox 2">
             <a:extLst>
               <a:ext uri="{FF2B5EF4-FFF2-40B4-BE49-F238E27FC236}">
-                <a16:creationId xmlns:a16="http://schemas.microsoft.com/office/drawing/2014/main" id="{FBF7AD2C-EBEA-3060-16A6-FCFF593012DA}"/>
+                <a16:creationId xmlns:a16="http://schemas.microsoft.com/office/drawing/2014/main" id="{95583435-3A37-8AD0-820A-AECDEFEAA7E5}"/>
               </a:ext>
             </a:extLst>
           </p:cNvPr>
@@ -10009,7 +10865,7 @@
           <p:cNvPr id="5" name="Picture 4">
             <a:extLst>
               <a:ext uri="{FF2B5EF4-FFF2-40B4-BE49-F238E27FC236}">
-                <a16:creationId xmlns:a16="http://schemas.microsoft.com/office/drawing/2014/main" id="{C4BA7D81-1FAE-ECAC-555A-0795EB7C3B5E}"/>
+                <a16:creationId xmlns:a16="http://schemas.microsoft.com/office/drawing/2014/main" id="{26B77CA7-1444-0731-A16A-AAEF0E50F4A3}"/>
               </a:ext>
             </a:extLst>
           </p:cNvPr>
@@ -10045,7 +10901,7 @@
           <p:cNvPr id="6" name="TextBox 5">
             <a:extLst>
               <a:ext uri="{FF2B5EF4-FFF2-40B4-BE49-F238E27FC236}">
-                <a16:creationId xmlns:a16="http://schemas.microsoft.com/office/drawing/2014/main" id="{B469B476-6B75-11B2-35E9-983F07ABC11D}"/>
+                <a16:creationId xmlns:a16="http://schemas.microsoft.com/office/drawing/2014/main" id="{0028ECB7-9F71-057A-B0F5-0755868D7E40}"/>
               </a:ext>
             </a:extLst>
           </p:cNvPr>
@@ -10084,7 +10940,7 @@
     </p:spTree>
     <p:extLst>
       <p:ext uri="{BB962C8B-B14F-4D97-AF65-F5344CB8AC3E}">
-        <p14:creationId xmlns:p14="http://schemas.microsoft.com/office/powerpoint/2010/main" val="455503889"/>
+        <p14:creationId xmlns:p14="http://schemas.microsoft.com/office/powerpoint/2010/main" val="3509973509"/>
       </p:ext>
     </p:extLst>
   </p:cSld>
@@ -10124,7 +10980,7 @@
           <p:cNvPr id="2" name="Oval 1">
             <a:extLst>
               <a:ext uri="{FF2B5EF4-FFF2-40B4-BE49-F238E27FC236}">
-                <a16:creationId xmlns:a16="http://schemas.microsoft.com/office/drawing/2014/main" id="{394A45E7-7E09-836C-1CFF-547C0E87C15F}"/>
+                <a16:creationId xmlns:a16="http://schemas.microsoft.com/office/drawing/2014/main" id="{46880669-9918-DF6C-1B53-26A89A01B3DC}"/>
               </a:ext>
             </a:extLst>
           </p:cNvPr>
@@ -10192,7 +11048,7 @@
           <p:cNvPr id="3" name="TextBox 2">
             <a:extLst>
               <a:ext uri="{FF2B5EF4-FFF2-40B4-BE49-F238E27FC236}">
-                <a16:creationId xmlns:a16="http://schemas.microsoft.com/office/drawing/2014/main" id="{C4838A8A-1A37-CDEE-9A0D-41E58C26B039}"/>
+                <a16:creationId xmlns:a16="http://schemas.microsoft.com/office/drawing/2014/main" id="{FB210546-C166-E961-92B2-C748DAFF5A8C}"/>
               </a:ext>
             </a:extLst>
           </p:cNvPr>
@@ -10232,7 +11088,7 @@
           <p:cNvPr id="5" name="Picture 4">
             <a:extLst>
               <a:ext uri="{FF2B5EF4-FFF2-40B4-BE49-F238E27FC236}">
-                <a16:creationId xmlns:a16="http://schemas.microsoft.com/office/drawing/2014/main" id="{9E6C38A4-5DBA-A335-F3DE-265E71356914}"/>
+                <a16:creationId xmlns:a16="http://schemas.microsoft.com/office/drawing/2014/main" id="{4A98BB4B-C31F-C6E1-1E3C-F7CE518BDB94}"/>
               </a:ext>
             </a:extLst>
           </p:cNvPr>
@@ -10268,7 +11124,7 @@
           <p:cNvPr id="6" name="TextBox 5">
             <a:extLst>
               <a:ext uri="{FF2B5EF4-FFF2-40B4-BE49-F238E27FC236}">
-                <a16:creationId xmlns:a16="http://schemas.microsoft.com/office/drawing/2014/main" id="{F65F43AC-4F19-B010-6A19-52B9FF8EC81C}"/>
+                <a16:creationId xmlns:a16="http://schemas.microsoft.com/office/drawing/2014/main" id="{2762E1D3-1F7F-E339-25A4-24B377F6F3E1}"/>
               </a:ext>
             </a:extLst>
           </p:cNvPr>
@@ -10307,7 +11163,7 @@
     </p:spTree>
     <p:extLst>
       <p:ext uri="{BB962C8B-B14F-4D97-AF65-F5344CB8AC3E}">
-        <p14:creationId xmlns:p14="http://schemas.microsoft.com/office/powerpoint/2010/main" val="3448165479"/>
+        <p14:creationId xmlns:p14="http://schemas.microsoft.com/office/powerpoint/2010/main" val="2828875272"/>
       </p:ext>
     </p:extLst>
   </p:cSld>
@@ -10347,7 +11203,7 @@
           <p:cNvPr id="2" name="Oval 1">
             <a:extLst>
               <a:ext uri="{FF2B5EF4-FFF2-40B4-BE49-F238E27FC236}">
-                <a16:creationId xmlns:a16="http://schemas.microsoft.com/office/drawing/2014/main" id="{F4D1A81E-3D81-178B-A4F8-B322EA8647FF}"/>
+                <a16:creationId xmlns:a16="http://schemas.microsoft.com/office/drawing/2014/main" id="{5D1990F6-43CE-6CF3-3EC8-64189B4620BD}"/>
               </a:ext>
             </a:extLst>
           </p:cNvPr>
@@ -10415,7 +11271,7 @@
           <p:cNvPr id="3" name="TextBox 2">
             <a:extLst>
               <a:ext uri="{FF2B5EF4-FFF2-40B4-BE49-F238E27FC236}">
-                <a16:creationId xmlns:a16="http://schemas.microsoft.com/office/drawing/2014/main" id="{BE5C11C7-D21E-4D04-7A0A-EE65C6094EEF}"/>
+                <a16:creationId xmlns:a16="http://schemas.microsoft.com/office/drawing/2014/main" id="{6A3A0A29-42A1-C75B-0AEB-E2272EA3D1C2}"/>
               </a:ext>
             </a:extLst>
           </p:cNvPr>
@@ -10455,7 +11311,7 @@
           <p:cNvPr id="5" name="Picture 4">
             <a:extLst>
               <a:ext uri="{FF2B5EF4-FFF2-40B4-BE49-F238E27FC236}">
-                <a16:creationId xmlns:a16="http://schemas.microsoft.com/office/drawing/2014/main" id="{44BE4948-9378-BDCB-D735-5F820E3BD7AE}"/>
+                <a16:creationId xmlns:a16="http://schemas.microsoft.com/office/drawing/2014/main" id="{7B73951B-3B1C-191D-1362-3F710D81C61B}"/>
               </a:ext>
             </a:extLst>
           </p:cNvPr>
@@ -10491,7 +11347,7 @@
           <p:cNvPr id="6" name="TextBox 5">
             <a:extLst>
               <a:ext uri="{FF2B5EF4-FFF2-40B4-BE49-F238E27FC236}">
-                <a16:creationId xmlns:a16="http://schemas.microsoft.com/office/drawing/2014/main" id="{4848BFB6-1B0F-9130-531A-51FF6F8BD3C6}"/>
+                <a16:creationId xmlns:a16="http://schemas.microsoft.com/office/drawing/2014/main" id="{5B8DF8AD-36A1-8CA1-C3A7-4CA8DE65E0F9}"/>
               </a:ext>
             </a:extLst>
           </p:cNvPr>
@@ -10530,7 +11386,7 @@
     </p:spTree>
     <p:extLst>
       <p:ext uri="{BB962C8B-B14F-4D97-AF65-F5344CB8AC3E}">
-        <p14:creationId xmlns:p14="http://schemas.microsoft.com/office/powerpoint/2010/main" val="2694180943"/>
+        <p14:creationId xmlns:p14="http://schemas.microsoft.com/office/powerpoint/2010/main" val="2062953982"/>
       </p:ext>
     </p:extLst>
   </p:cSld>
@@ -10570,7 +11426,7 @@
           <p:cNvPr id="2" name="Oval 1">
             <a:extLst>
               <a:ext uri="{FF2B5EF4-FFF2-40B4-BE49-F238E27FC236}">
-                <a16:creationId xmlns:a16="http://schemas.microsoft.com/office/drawing/2014/main" id="{820AB90B-F090-8F3F-E710-865A53872020}"/>
+                <a16:creationId xmlns:a16="http://schemas.microsoft.com/office/drawing/2014/main" id="{347CE92C-D5F2-4DE6-76CD-BFD2BEC6A2DF}"/>
               </a:ext>
             </a:extLst>
           </p:cNvPr>
@@ -10638,7 +11494,7 @@
           <p:cNvPr id="3" name="TextBox 2">
             <a:extLst>
               <a:ext uri="{FF2B5EF4-FFF2-40B4-BE49-F238E27FC236}">
-                <a16:creationId xmlns:a16="http://schemas.microsoft.com/office/drawing/2014/main" id="{7951B58D-73E4-405C-E8A4-632EE4EB372E}"/>
+                <a16:creationId xmlns:a16="http://schemas.microsoft.com/office/drawing/2014/main" id="{8A9CEC94-BE92-567F-2104-6FB1B1AAA665}"/>
               </a:ext>
             </a:extLst>
           </p:cNvPr>
@@ -10678,7 +11534,7 @@
           <p:cNvPr id="5" name="Picture 4">
             <a:extLst>
               <a:ext uri="{FF2B5EF4-FFF2-40B4-BE49-F238E27FC236}">
-                <a16:creationId xmlns:a16="http://schemas.microsoft.com/office/drawing/2014/main" id="{18BD76FD-9241-AB14-A7DF-B6F551C46304}"/>
+                <a16:creationId xmlns:a16="http://schemas.microsoft.com/office/drawing/2014/main" id="{2D7FDC14-4015-8345-D6CB-57CE4C4DE96B}"/>
               </a:ext>
             </a:extLst>
           </p:cNvPr>
@@ -10714,7 +11570,7 @@
           <p:cNvPr id="6" name="TextBox 5">
             <a:extLst>
               <a:ext uri="{FF2B5EF4-FFF2-40B4-BE49-F238E27FC236}">
-                <a16:creationId xmlns:a16="http://schemas.microsoft.com/office/drawing/2014/main" id="{491816C8-A749-E405-D192-6E190DFD9FDE}"/>
+                <a16:creationId xmlns:a16="http://schemas.microsoft.com/office/drawing/2014/main" id="{DE15E825-4E30-BD8B-46B2-728494A51CA9}"/>
               </a:ext>
             </a:extLst>
           </p:cNvPr>
@@ -10753,7 +11609,7 @@
     </p:spTree>
     <p:extLst>
       <p:ext uri="{BB962C8B-B14F-4D97-AF65-F5344CB8AC3E}">
-        <p14:creationId xmlns:p14="http://schemas.microsoft.com/office/powerpoint/2010/main" val="378966060"/>
+        <p14:creationId xmlns:p14="http://schemas.microsoft.com/office/powerpoint/2010/main" val="3301779906"/>
       </p:ext>
     </p:extLst>
   </p:cSld>

</xml_diff>